<commit_message>
refactor(cmpsc-448): simplify slide visuals
hide reference curves on unseen-data slides and apply the gradient
accent throughout the deck while removing footer rules
</commit_message>
<xml_diff>
--- a/cmpsc-448/presentation/bias-variance-tradeoff.pptx
+++ b/cmpsc-448/presentation/bias-variance-tradeoff.pptx
@@ -578,7 +578,7 @@
           <a:lstStyle/>
           <a:p>
             <a:r>
-              <a:t>Keep the straight fit from slide 1 frozen. Reveal the first 25 observations from the independent 1,000-point test set; slide 3 will show exactly these same observations and axis limits. No model is refitted, and there is no distribution shift or extrapolation. The line still misses the curvature. Bias is the systematic difference between the average prediction over repeated training samples and the true regression function. Here the model family only permits straight lines, so even its average fit cannot capture curvature. The dashed curve is known because we generated this example; in practice it is hidden. Underfitting usually leaves substantial error even on training data. More samples alone will not make a straight model quadratic. Linear regression can also use polynomial features: it is the straight-line specification here that is restrictive.</a:t>
+              <a:t>Keep the straight fit from slide 1 frozen. Reveal the first 25 observations from the independent 1,000-point test set; slide 3 will show exactly these same observations and axis limits. No model is refitted, and there is no distribution shift or extrapolation. The line still misses the curvature. Bias is the systematic difference between the average prediction over repeated training samples and the true regression function. Here the model family only permits straight lines, so even its average fit cannot capture curvature. The true curve is deliberately hidden here, as it would be in practice; only the frozen model and unseen observations are shown. Underfitting usually leaves substantial error even on training data. More samples alone will not make a straight model quadratic. Linear regression can also use polynomial features: it is the straight-line specification here that is restrictive.</a:t>
             </a:r>
           </a:p>
         </p:txBody>
@@ -4005,44 +4005,9 @@
           </a:p>
         </p:txBody>
       </p:sp>
-      <p:cxnSp>
-        <p:nvCxnSpPr>
-          <p:cNvPr id="4" name="Connector 3"/>
-          <p:cNvCxnSpPr/>
-          <p:nvPr/>
-        </p:nvCxnSpPr>
-        <p:spPr>
-          <a:xfrm>
-            <a:off x="594360" y="6419088"/>
-            <a:ext cx="10972800" cy="0"/>
-          </a:xfrm>
-          <a:prstGeom prst="line">
-            <a:avLst/>
-          </a:prstGeom>
-          <a:ln w="12700">
-            <a:solidFill>
-              <a:srgbClr val="D4D6D0"/>
-            </a:solidFill>
-          </a:ln>
-        </p:spPr>
-        <p:style>
-          <a:lnRef idx="2">
-            <a:schemeClr val="accent1"/>
-          </a:lnRef>
-          <a:fillRef idx="0">
-            <a:schemeClr val="accent1"/>
-          </a:fillRef>
-          <a:effectRef idx="0">
-            <a:schemeClr val="accent1"/>
-          </a:effectRef>
-          <a:fontRef idx="minor">
-            <a:schemeClr val="tx1"/>
-          </a:fontRef>
-        </p:style>
-      </p:cxnSp>
       <p:sp>
         <p:nvSpPr>
-          <p:cNvPr id="5" name="TextBox 4"/>
+          <p:cNvPr id="4" name="TextBox 3"/>
           <p:cNvSpPr txBox="1"/>
           <p:nvPr/>
         </p:nvSpPr>
@@ -4081,7 +4046,7 @@
       </p:sp>
       <p:sp>
         <p:nvSpPr>
-          <p:cNvPr id="6" name="TextBox 5"/>
+          <p:cNvPr id="5" name="TextBox 4"/>
           <p:cNvSpPr txBox="1"/>
           <p:nvPr/>
         </p:nvSpPr>
@@ -4120,7 +4085,7 @@
       </p:sp>
       <p:cxnSp>
         <p:nvCxnSpPr>
-          <p:cNvPr id="7" name="Connector 6"/>
+          <p:cNvPr id="6" name="Connector 5"/>
           <p:cNvCxnSpPr/>
           <p:nvPr/>
         </p:nvCxnSpPr>
@@ -4155,7 +4120,7 @@
       </p:cxnSp>
       <p:cxnSp>
         <p:nvCxnSpPr>
-          <p:cNvPr id="8" name="Connector 7"/>
+          <p:cNvPr id="7" name="Connector 6"/>
           <p:cNvCxnSpPr/>
           <p:nvPr/>
         </p:nvCxnSpPr>
@@ -4190,7 +4155,7 @@
       </p:cxnSp>
       <p:sp>
         <p:nvSpPr>
-          <p:cNvPr id="9" name="TextBox 8"/>
+          <p:cNvPr id="8" name="TextBox 7"/>
           <p:cNvSpPr txBox="1"/>
           <p:nvPr/>
         </p:nvSpPr>
@@ -4229,7 +4194,7 @@
       </p:sp>
       <p:sp>
         <p:nvSpPr>
-          <p:cNvPr id="10" name="TextBox 9"/>
+          <p:cNvPr id="9" name="TextBox 8"/>
           <p:cNvSpPr txBox="1"/>
           <p:nvPr/>
         </p:nvSpPr>
@@ -4268,7 +4233,7 @@
       </p:sp>
       <p:sp>
         <p:nvSpPr>
-          <p:cNvPr id="11" name="Freeform 10"/>
+          <p:cNvPr id="10" name="Freeform 9"/>
           <p:cNvSpPr/>
           <p:nvPr/>
         </p:nvSpPr>
@@ -5519,7 +5484,7 @@
       </p:sp>
       <p:sp>
         <p:nvSpPr>
-          <p:cNvPr id="12" name="Oval 11"/>
+          <p:cNvPr id="11" name="Oval 10"/>
           <p:cNvSpPr/>
           <p:nvPr/>
         </p:nvSpPr>
@@ -5564,7 +5529,7 @@
       </p:sp>
       <p:sp>
         <p:nvSpPr>
-          <p:cNvPr id="13" name="Oval 12"/>
+          <p:cNvPr id="12" name="Oval 11"/>
           <p:cNvSpPr/>
           <p:nvPr/>
         </p:nvSpPr>
@@ -5609,7 +5574,7 @@
       </p:sp>
       <p:sp>
         <p:nvSpPr>
-          <p:cNvPr id="14" name="Oval 13"/>
+          <p:cNvPr id="13" name="Oval 12"/>
           <p:cNvSpPr/>
           <p:nvPr/>
         </p:nvSpPr>
@@ -5654,7 +5619,7 @@
       </p:sp>
       <p:sp>
         <p:nvSpPr>
-          <p:cNvPr id="15" name="Oval 14"/>
+          <p:cNvPr id="14" name="Oval 13"/>
           <p:cNvSpPr/>
           <p:nvPr/>
         </p:nvSpPr>
@@ -5699,7 +5664,7 @@
       </p:sp>
       <p:sp>
         <p:nvSpPr>
-          <p:cNvPr id="16" name="Oval 15"/>
+          <p:cNvPr id="15" name="Oval 14"/>
           <p:cNvSpPr/>
           <p:nvPr/>
         </p:nvSpPr>
@@ -5744,7 +5709,7 @@
       </p:sp>
       <p:sp>
         <p:nvSpPr>
-          <p:cNvPr id="17" name="Oval 16"/>
+          <p:cNvPr id="16" name="Oval 15"/>
           <p:cNvSpPr/>
           <p:nvPr/>
         </p:nvSpPr>
@@ -5789,7 +5754,7 @@
       </p:sp>
       <p:sp>
         <p:nvSpPr>
-          <p:cNvPr id="18" name="Oval 17"/>
+          <p:cNvPr id="17" name="Oval 16"/>
           <p:cNvSpPr/>
           <p:nvPr/>
         </p:nvSpPr>
@@ -5834,7 +5799,7 @@
       </p:sp>
       <p:sp>
         <p:nvSpPr>
-          <p:cNvPr id="19" name="Oval 18"/>
+          <p:cNvPr id="18" name="Oval 17"/>
           <p:cNvSpPr/>
           <p:nvPr/>
         </p:nvSpPr>
@@ -5879,7 +5844,7 @@
       </p:sp>
       <p:sp>
         <p:nvSpPr>
-          <p:cNvPr id="20" name="Oval 19"/>
+          <p:cNvPr id="19" name="Oval 18"/>
           <p:cNvSpPr/>
           <p:nvPr/>
         </p:nvSpPr>
@@ -5924,7 +5889,7 @@
       </p:sp>
       <p:sp>
         <p:nvSpPr>
-          <p:cNvPr id="21" name="Oval 20"/>
+          <p:cNvPr id="20" name="Oval 19"/>
           <p:cNvSpPr/>
           <p:nvPr/>
         </p:nvSpPr>
@@ -5969,7 +5934,7 @@
       </p:sp>
       <p:sp>
         <p:nvSpPr>
-          <p:cNvPr id="22" name="Oval 21"/>
+          <p:cNvPr id="21" name="Oval 20"/>
           <p:cNvSpPr/>
           <p:nvPr/>
         </p:nvSpPr>
@@ -6014,7 +5979,7 @@
       </p:sp>
       <p:sp>
         <p:nvSpPr>
-          <p:cNvPr id="23" name="Oval 22"/>
+          <p:cNvPr id="22" name="Oval 21"/>
           <p:cNvSpPr/>
           <p:nvPr/>
         </p:nvSpPr>
@@ -6059,7 +6024,7 @@
       </p:sp>
       <p:sp>
         <p:nvSpPr>
-          <p:cNvPr id="24" name="Oval 23"/>
+          <p:cNvPr id="23" name="Oval 22"/>
           <p:cNvSpPr/>
           <p:nvPr/>
         </p:nvSpPr>
@@ -6104,7 +6069,7 @@
       </p:sp>
       <p:sp>
         <p:nvSpPr>
-          <p:cNvPr id="25" name="Oval 24"/>
+          <p:cNvPr id="24" name="Oval 23"/>
           <p:cNvSpPr/>
           <p:nvPr/>
         </p:nvSpPr>
@@ -6149,7 +6114,7 @@
       </p:sp>
       <p:sp>
         <p:nvSpPr>
-          <p:cNvPr id="26" name="Oval 25"/>
+          <p:cNvPr id="25" name="Oval 24"/>
           <p:cNvSpPr/>
           <p:nvPr/>
         </p:nvSpPr>
@@ -6194,7 +6159,7 @@
       </p:sp>
       <p:sp>
         <p:nvSpPr>
-          <p:cNvPr id="27" name="Oval 26"/>
+          <p:cNvPr id="26" name="Oval 25"/>
           <p:cNvSpPr/>
           <p:nvPr/>
         </p:nvSpPr>
@@ -6239,7 +6204,7 @@
       </p:sp>
       <p:sp>
         <p:nvSpPr>
-          <p:cNvPr id="28" name="Oval 27"/>
+          <p:cNvPr id="27" name="Oval 26"/>
           <p:cNvSpPr/>
           <p:nvPr/>
         </p:nvSpPr>
@@ -6284,7 +6249,7 @@
       </p:sp>
       <p:sp>
         <p:nvSpPr>
-          <p:cNvPr id="29" name="Oval 28"/>
+          <p:cNvPr id="28" name="Oval 27"/>
           <p:cNvSpPr/>
           <p:nvPr/>
         </p:nvSpPr>
@@ -6329,7 +6294,7 @@
       </p:sp>
       <p:sp>
         <p:nvSpPr>
-          <p:cNvPr id="30" name="Oval 29"/>
+          <p:cNvPr id="29" name="Oval 28"/>
           <p:cNvSpPr/>
           <p:nvPr/>
         </p:nvSpPr>
@@ -6374,7 +6339,7 @@
       </p:sp>
       <p:sp>
         <p:nvSpPr>
-          <p:cNvPr id="31" name="Oval 30"/>
+          <p:cNvPr id="30" name="Oval 29"/>
           <p:cNvSpPr/>
           <p:nvPr/>
         </p:nvSpPr>
@@ -6419,7 +6384,7 @@
       </p:sp>
       <p:sp>
         <p:nvSpPr>
-          <p:cNvPr id="32" name="TextBox 31"/>
+          <p:cNvPr id="31" name="TextBox 30"/>
           <p:cNvSpPr txBox="1"/>
           <p:nvPr/>
         </p:nvSpPr>
@@ -6458,7 +6423,7 @@
       </p:sp>
       <p:cxnSp>
         <p:nvCxnSpPr>
-          <p:cNvPr id="33" name="Connector 32"/>
+          <p:cNvPr id="32" name="Connector 31"/>
           <p:cNvCxnSpPr/>
           <p:nvPr/>
         </p:nvCxnSpPr>
@@ -6493,7 +6458,7 @@
       </p:cxnSp>
       <p:cxnSp>
         <p:nvCxnSpPr>
-          <p:cNvPr id="34" name="Connector 33"/>
+          <p:cNvPr id="33" name="Connector 32"/>
           <p:cNvCxnSpPr/>
           <p:nvPr/>
         </p:nvCxnSpPr>
@@ -6528,7 +6493,7 @@
       </p:cxnSp>
       <p:sp>
         <p:nvSpPr>
-          <p:cNvPr id="35" name="TextBox 34"/>
+          <p:cNvPr id="34" name="TextBox 33"/>
           <p:cNvSpPr txBox="1"/>
           <p:nvPr/>
         </p:nvSpPr>
@@ -6567,7 +6532,7 @@
       </p:sp>
       <p:sp>
         <p:nvSpPr>
-          <p:cNvPr id="36" name="TextBox 35"/>
+          <p:cNvPr id="35" name="TextBox 34"/>
           <p:cNvSpPr txBox="1"/>
           <p:nvPr/>
         </p:nvSpPr>
@@ -6606,7 +6571,7 @@
       </p:sp>
       <p:sp>
         <p:nvSpPr>
-          <p:cNvPr id="37" name="Freeform 36"/>
+          <p:cNvPr id="36" name="Freeform 35"/>
           <p:cNvSpPr/>
           <p:nvPr/>
         </p:nvSpPr>
@@ -7857,7 +7822,7 @@
       </p:sp>
       <p:sp>
         <p:nvSpPr>
-          <p:cNvPr id="38" name="Oval 37"/>
+          <p:cNvPr id="37" name="Oval 36"/>
           <p:cNvSpPr/>
           <p:nvPr/>
         </p:nvSpPr>
@@ -7902,7 +7867,7 @@
       </p:sp>
       <p:sp>
         <p:nvSpPr>
-          <p:cNvPr id="39" name="Oval 38"/>
+          <p:cNvPr id="38" name="Oval 37"/>
           <p:cNvSpPr/>
           <p:nvPr/>
         </p:nvSpPr>
@@ -7947,7 +7912,7 @@
       </p:sp>
       <p:sp>
         <p:nvSpPr>
-          <p:cNvPr id="40" name="Oval 39"/>
+          <p:cNvPr id="39" name="Oval 38"/>
           <p:cNvSpPr/>
           <p:nvPr/>
         </p:nvSpPr>
@@ -7992,7 +7957,7 @@
       </p:sp>
       <p:sp>
         <p:nvSpPr>
-          <p:cNvPr id="41" name="Oval 40"/>
+          <p:cNvPr id="40" name="Oval 39"/>
           <p:cNvSpPr/>
           <p:nvPr/>
         </p:nvSpPr>
@@ -8037,7 +8002,7 @@
       </p:sp>
       <p:sp>
         <p:nvSpPr>
-          <p:cNvPr id="42" name="Oval 41"/>
+          <p:cNvPr id="41" name="Oval 40"/>
           <p:cNvSpPr/>
           <p:nvPr/>
         </p:nvSpPr>
@@ -8082,7 +8047,7 @@
       </p:sp>
       <p:sp>
         <p:nvSpPr>
-          <p:cNvPr id="43" name="Oval 42"/>
+          <p:cNvPr id="42" name="Oval 41"/>
           <p:cNvSpPr/>
           <p:nvPr/>
         </p:nvSpPr>
@@ -8127,7 +8092,7 @@
       </p:sp>
       <p:sp>
         <p:nvSpPr>
-          <p:cNvPr id="44" name="Oval 43"/>
+          <p:cNvPr id="43" name="Oval 42"/>
           <p:cNvSpPr/>
           <p:nvPr/>
         </p:nvSpPr>
@@ -8172,7 +8137,7 @@
       </p:sp>
       <p:sp>
         <p:nvSpPr>
-          <p:cNvPr id="45" name="Oval 44"/>
+          <p:cNvPr id="44" name="Oval 43"/>
           <p:cNvSpPr/>
           <p:nvPr/>
         </p:nvSpPr>
@@ -8217,7 +8182,7 @@
       </p:sp>
       <p:sp>
         <p:nvSpPr>
-          <p:cNvPr id="46" name="Oval 45"/>
+          <p:cNvPr id="45" name="Oval 44"/>
           <p:cNvSpPr/>
           <p:nvPr/>
         </p:nvSpPr>
@@ -8262,7 +8227,7 @@
       </p:sp>
       <p:sp>
         <p:nvSpPr>
-          <p:cNvPr id="47" name="Oval 46"/>
+          <p:cNvPr id="46" name="Oval 45"/>
           <p:cNvSpPr/>
           <p:nvPr/>
         </p:nvSpPr>
@@ -8307,7 +8272,7 @@
       </p:sp>
       <p:sp>
         <p:nvSpPr>
-          <p:cNvPr id="48" name="Oval 47"/>
+          <p:cNvPr id="47" name="Oval 46"/>
           <p:cNvSpPr/>
           <p:nvPr/>
         </p:nvSpPr>
@@ -8352,7 +8317,7 @@
       </p:sp>
       <p:sp>
         <p:nvSpPr>
-          <p:cNvPr id="49" name="Oval 48"/>
+          <p:cNvPr id="48" name="Oval 47"/>
           <p:cNvSpPr/>
           <p:nvPr/>
         </p:nvSpPr>
@@ -8397,7 +8362,7 @@
       </p:sp>
       <p:sp>
         <p:nvSpPr>
-          <p:cNvPr id="50" name="Oval 49"/>
+          <p:cNvPr id="49" name="Oval 48"/>
           <p:cNvSpPr/>
           <p:nvPr/>
         </p:nvSpPr>
@@ -8442,7 +8407,7 @@
       </p:sp>
       <p:sp>
         <p:nvSpPr>
-          <p:cNvPr id="51" name="Oval 50"/>
+          <p:cNvPr id="50" name="Oval 49"/>
           <p:cNvSpPr/>
           <p:nvPr/>
         </p:nvSpPr>
@@ -8487,7 +8452,7 @@
       </p:sp>
       <p:sp>
         <p:nvSpPr>
-          <p:cNvPr id="52" name="Oval 51"/>
+          <p:cNvPr id="51" name="Oval 50"/>
           <p:cNvSpPr/>
           <p:nvPr/>
         </p:nvSpPr>
@@ -8532,7 +8497,7 @@
       </p:sp>
       <p:sp>
         <p:nvSpPr>
-          <p:cNvPr id="53" name="Oval 52"/>
+          <p:cNvPr id="52" name="Oval 51"/>
           <p:cNvSpPr/>
           <p:nvPr/>
         </p:nvSpPr>
@@ -8577,7 +8542,7 @@
       </p:sp>
       <p:sp>
         <p:nvSpPr>
-          <p:cNvPr id="54" name="Oval 53"/>
+          <p:cNvPr id="53" name="Oval 52"/>
           <p:cNvSpPr/>
           <p:nvPr/>
         </p:nvSpPr>
@@ -8622,7 +8587,7 @@
       </p:sp>
       <p:sp>
         <p:nvSpPr>
-          <p:cNvPr id="55" name="Oval 54"/>
+          <p:cNvPr id="54" name="Oval 53"/>
           <p:cNvSpPr/>
           <p:nvPr/>
         </p:nvSpPr>
@@ -8667,7 +8632,7 @@
       </p:sp>
       <p:sp>
         <p:nvSpPr>
-          <p:cNvPr id="56" name="Oval 55"/>
+          <p:cNvPr id="55" name="Oval 54"/>
           <p:cNvSpPr/>
           <p:nvPr/>
         </p:nvSpPr>
@@ -8712,7 +8677,7 @@
       </p:sp>
       <p:sp>
         <p:nvSpPr>
-          <p:cNvPr id="57" name="Oval 56"/>
+          <p:cNvPr id="56" name="Oval 55"/>
           <p:cNvSpPr/>
           <p:nvPr/>
         </p:nvSpPr>
@@ -8757,7 +8722,7 @@
       </p:sp>
       <p:sp>
         <p:nvSpPr>
-          <p:cNvPr id="58" name="Oval 57"/>
+          <p:cNvPr id="57" name="Oval 56"/>
           <p:cNvSpPr/>
           <p:nvPr/>
         </p:nvSpPr>
@@ -8802,7 +8767,7 @@
       </p:sp>
       <p:sp>
         <p:nvSpPr>
-          <p:cNvPr id="59" name="TextBox 58"/>
+          <p:cNvPr id="58" name="TextBox 57"/>
           <p:cNvSpPr txBox="1"/>
           <p:nvPr/>
         </p:nvSpPr>
@@ -8841,7 +8806,7 @@
       </p:sp>
       <p:cxnSp>
         <p:nvCxnSpPr>
-          <p:cNvPr id="60" name="Connector 59"/>
+          <p:cNvPr id="59" name="Connector 58"/>
           <p:cNvCxnSpPr/>
           <p:nvPr/>
         </p:nvCxnSpPr>
@@ -8876,7 +8841,7 @@
       </p:cxnSp>
       <p:sp>
         <p:nvSpPr>
-          <p:cNvPr id="61" name="TextBox 60"/>
+          <p:cNvPr id="60" name="TextBox 59"/>
           <p:cNvSpPr txBox="1"/>
           <p:nvPr/>
         </p:nvSpPr>
@@ -8939,9 +8904,33 @@
         <p:nvPr/>
       </p:nvGrpSpPr>
       <p:grpSpPr/>
+      <p:pic>
+        <p:nvPicPr>
+          <p:cNvPr id="2" name="Picture 1" descr="image.png"/>
+          <p:cNvPicPr>
+            <a:picLocks noChangeAspect="1"/>
+          </p:cNvPicPr>
+          <p:nvPr/>
+        </p:nvPicPr>
+        <p:blipFill>
+          <a:blip r:embed="rId2"/>
+          <a:stretch>
+            <a:fillRect/>
+          </a:stretch>
+        </p:blipFill>
+        <p:spPr>
+          <a:xfrm>
+            <a:off x="11768328" y="201168"/>
+            <a:ext cx="219456" cy="6455664"/>
+          </a:xfrm>
+          <a:prstGeom prst="rect">
+            <a:avLst/>
+          </a:prstGeom>
+        </p:spPr>
+      </p:pic>
       <p:sp>
         <p:nvSpPr>
-          <p:cNvPr id="2" name="TextBox 1"/>
+          <p:cNvPr id="3" name="TextBox 2"/>
           <p:cNvSpPr txBox="1"/>
           <p:nvPr/>
         </p:nvSpPr>
@@ -8978,41 +8967,6 @@
           </a:p>
         </p:txBody>
       </p:sp>
-      <p:cxnSp>
-        <p:nvCxnSpPr>
-          <p:cNvPr id="3" name="Connector 2"/>
-          <p:cNvCxnSpPr/>
-          <p:nvPr/>
-        </p:nvCxnSpPr>
-        <p:spPr>
-          <a:xfrm>
-            <a:off x="594360" y="6419088"/>
-            <a:ext cx="10972800" cy="0"/>
-          </a:xfrm>
-          <a:prstGeom prst="line">
-            <a:avLst/>
-          </a:prstGeom>
-          <a:ln w="12700">
-            <a:solidFill>
-              <a:srgbClr val="D4D6D0"/>
-            </a:solidFill>
-          </a:ln>
-        </p:spPr>
-        <p:style>
-          <a:lnRef idx="2">
-            <a:schemeClr val="accent1"/>
-          </a:lnRef>
-          <a:fillRef idx="0">
-            <a:schemeClr val="accent1"/>
-          </a:fillRef>
-          <a:effectRef idx="0">
-            <a:schemeClr val="accent1"/>
-          </a:effectRef>
-          <a:fontRef idx="minor">
-            <a:schemeClr val="tx1"/>
-          </a:fontRef>
-        </p:style>
-      </p:cxnSp>
       <p:sp>
         <p:nvSpPr>
           <p:cNvPr id="4" name="TextBox 3"/>
@@ -9208,1258 +9162,6 @@
         </p:nvSpPr>
         <p:spPr>
           <a:xfrm>
-            <a:off x="896112" y="3099816"/>
-            <a:ext cx="6510528" cy="1582826"/>
-          </a:xfrm>
-          <a:custGeom>
-            <a:avLst/>
-            <a:gdLst/>
-            <a:ahLst/>
-            <a:cxnLst/>
-            <a:rect l="l" t="t" r="r" b="b"/>
-            <a:pathLst>
-              <a:path w="7120" h="1731">
-                <a:moveTo>
-                  <a:pt x="0" y="800"/>
-                </a:moveTo>
-                <a:lnTo>
-                  <a:pt x="18" y="811"/>
-                </a:lnTo>
-                <a:lnTo>
-                  <a:pt x="36" y="822"/>
-                </a:lnTo>
-                <a:lnTo>
-                  <a:pt x="54" y="833"/>
-                </a:lnTo>
-                <a:lnTo>
-                  <a:pt x="71" y="844"/>
-                </a:lnTo>
-                <a:lnTo>
-                  <a:pt x="89" y="854"/>
-                </a:lnTo>
-                <a:lnTo>
-                  <a:pt x="107" y="865"/>
-                </a:lnTo>
-                <a:lnTo>
-                  <a:pt x="125" y="876"/>
-                </a:lnTo>
-                <a:lnTo>
-                  <a:pt x="143" y="886"/>
-                </a:lnTo>
-                <a:lnTo>
-                  <a:pt x="161" y="897"/>
-                </a:lnTo>
-                <a:lnTo>
-                  <a:pt x="178" y="907"/>
-                </a:lnTo>
-                <a:lnTo>
-                  <a:pt x="196" y="917"/>
-                </a:lnTo>
-                <a:lnTo>
-                  <a:pt x="214" y="928"/>
-                </a:lnTo>
-                <a:lnTo>
-                  <a:pt x="232" y="938"/>
-                </a:lnTo>
-                <a:lnTo>
-                  <a:pt x="250" y="948"/>
-                </a:lnTo>
-                <a:lnTo>
-                  <a:pt x="268" y="958"/>
-                </a:lnTo>
-                <a:lnTo>
-                  <a:pt x="286" y="968"/>
-                </a:lnTo>
-                <a:lnTo>
-                  <a:pt x="303" y="978"/>
-                </a:lnTo>
-                <a:lnTo>
-                  <a:pt x="321" y="988"/>
-                </a:lnTo>
-                <a:lnTo>
-                  <a:pt x="339" y="998"/>
-                </a:lnTo>
-                <a:lnTo>
-                  <a:pt x="357" y="1007"/>
-                </a:lnTo>
-                <a:lnTo>
-                  <a:pt x="375" y="1017"/>
-                </a:lnTo>
-                <a:lnTo>
-                  <a:pt x="393" y="1027"/>
-                </a:lnTo>
-                <a:lnTo>
-                  <a:pt x="410" y="1036"/>
-                </a:lnTo>
-                <a:lnTo>
-                  <a:pt x="428" y="1046"/>
-                </a:lnTo>
-                <a:lnTo>
-                  <a:pt x="446" y="1055"/>
-                </a:lnTo>
-                <a:lnTo>
-                  <a:pt x="464" y="1065"/>
-                </a:lnTo>
-                <a:lnTo>
-                  <a:pt x="482" y="1074"/>
-                </a:lnTo>
-                <a:lnTo>
-                  <a:pt x="500" y="1083"/>
-                </a:lnTo>
-                <a:lnTo>
-                  <a:pt x="517" y="1092"/>
-                </a:lnTo>
-                <a:lnTo>
-                  <a:pt x="535" y="1101"/>
-                </a:lnTo>
-                <a:lnTo>
-                  <a:pt x="553" y="1110"/>
-                </a:lnTo>
-                <a:lnTo>
-                  <a:pt x="571" y="1119"/>
-                </a:lnTo>
-                <a:lnTo>
-                  <a:pt x="589" y="1128"/>
-                </a:lnTo>
-                <a:lnTo>
-                  <a:pt x="607" y="1137"/>
-                </a:lnTo>
-                <a:lnTo>
-                  <a:pt x="625" y="1146"/>
-                </a:lnTo>
-                <a:lnTo>
-                  <a:pt x="642" y="1155"/>
-                </a:lnTo>
-                <a:lnTo>
-                  <a:pt x="660" y="1163"/>
-                </a:lnTo>
-                <a:lnTo>
-                  <a:pt x="678" y="1172"/>
-                </a:lnTo>
-                <a:lnTo>
-                  <a:pt x="696" y="1180"/>
-                </a:lnTo>
-                <a:lnTo>
-                  <a:pt x="714" y="1189"/>
-                </a:lnTo>
-                <a:lnTo>
-                  <a:pt x="732" y="1197"/>
-                </a:lnTo>
-                <a:lnTo>
-                  <a:pt x="749" y="1206"/>
-                </a:lnTo>
-                <a:lnTo>
-                  <a:pt x="767" y="1214"/>
-                </a:lnTo>
-                <a:lnTo>
-                  <a:pt x="785" y="1222"/>
-                </a:lnTo>
-                <a:lnTo>
-                  <a:pt x="803" y="1230"/>
-                </a:lnTo>
-                <a:lnTo>
-                  <a:pt x="821" y="1238"/>
-                </a:lnTo>
-                <a:lnTo>
-                  <a:pt x="839" y="1246"/>
-                </a:lnTo>
-                <a:lnTo>
-                  <a:pt x="857" y="1254"/>
-                </a:lnTo>
-                <a:lnTo>
-                  <a:pt x="874" y="1262"/>
-                </a:lnTo>
-                <a:lnTo>
-                  <a:pt x="892" y="1270"/>
-                </a:lnTo>
-                <a:lnTo>
-                  <a:pt x="910" y="1277"/>
-                </a:lnTo>
-                <a:lnTo>
-                  <a:pt x="928" y="1285"/>
-                </a:lnTo>
-                <a:lnTo>
-                  <a:pt x="946" y="1293"/>
-                </a:lnTo>
-                <a:lnTo>
-                  <a:pt x="964" y="1300"/>
-                </a:lnTo>
-                <a:lnTo>
-                  <a:pt x="981" y="1308"/>
-                </a:lnTo>
-                <a:lnTo>
-                  <a:pt x="999" y="1315"/>
-                </a:lnTo>
-                <a:lnTo>
-                  <a:pt x="1017" y="1322"/>
-                </a:lnTo>
-                <a:lnTo>
-                  <a:pt x="1035" y="1330"/>
-                </a:lnTo>
-                <a:lnTo>
-                  <a:pt x="1053" y="1337"/>
-                </a:lnTo>
-                <a:lnTo>
-                  <a:pt x="1071" y="1344"/>
-                </a:lnTo>
-                <a:lnTo>
-                  <a:pt x="1089" y="1351"/>
-                </a:lnTo>
-                <a:lnTo>
-                  <a:pt x="1106" y="1358"/>
-                </a:lnTo>
-                <a:lnTo>
-                  <a:pt x="1124" y="1365"/>
-                </a:lnTo>
-                <a:lnTo>
-                  <a:pt x="1142" y="1372"/>
-                </a:lnTo>
-                <a:lnTo>
-                  <a:pt x="1160" y="1379"/>
-                </a:lnTo>
-                <a:lnTo>
-                  <a:pt x="1178" y="1386"/>
-                </a:lnTo>
-                <a:lnTo>
-                  <a:pt x="1196" y="1392"/>
-                </a:lnTo>
-                <a:lnTo>
-                  <a:pt x="1213" y="1399"/>
-                </a:lnTo>
-                <a:lnTo>
-                  <a:pt x="1231" y="1405"/>
-                </a:lnTo>
-                <a:lnTo>
-                  <a:pt x="1249" y="1412"/>
-                </a:lnTo>
-                <a:lnTo>
-                  <a:pt x="1267" y="1418"/>
-                </a:lnTo>
-                <a:lnTo>
-                  <a:pt x="1285" y="1425"/>
-                </a:lnTo>
-                <a:lnTo>
-                  <a:pt x="1303" y="1431"/>
-                </a:lnTo>
-                <a:lnTo>
-                  <a:pt x="1321" y="1437"/>
-                </a:lnTo>
-                <a:lnTo>
-                  <a:pt x="1338" y="1443"/>
-                </a:lnTo>
-                <a:lnTo>
-                  <a:pt x="1356" y="1449"/>
-                </a:lnTo>
-                <a:lnTo>
-                  <a:pt x="1374" y="1455"/>
-                </a:lnTo>
-                <a:lnTo>
-                  <a:pt x="1392" y="1461"/>
-                </a:lnTo>
-                <a:lnTo>
-                  <a:pt x="1410" y="1467"/>
-                </a:lnTo>
-                <a:lnTo>
-                  <a:pt x="1428" y="1473"/>
-                </a:lnTo>
-                <a:lnTo>
-                  <a:pt x="1445" y="1479"/>
-                </a:lnTo>
-                <a:lnTo>
-                  <a:pt x="1463" y="1485"/>
-                </a:lnTo>
-                <a:lnTo>
-                  <a:pt x="1481" y="1490"/>
-                </a:lnTo>
-                <a:lnTo>
-                  <a:pt x="1499" y="1496"/>
-                </a:lnTo>
-                <a:lnTo>
-                  <a:pt x="1517" y="1501"/>
-                </a:lnTo>
-                <a:lnTo>
-                  <a:pt x="1535" y="1507"/>
-                </a:lnTo>
-                <a:lnTo>
-                  <a:pt x="1552" y="1512"/>
-                </a:lnTo>
-                <a:lnTo>
-                  <a:pt x="1570" y="1517"/>
-                </a:lnTo>
-                <a:lnTo>
-                  <a:pt x="1588" y="1523"/>
-                </a:lnTo>
-                <a:lnTo>
-                  <a:pt x="1606" y="1528"/>
-                </a:lnTo>
-                <a:lnTo>
-                  <a:pt x="1624" y="1533"/>
-                </a:lnTo>
-                <a:lnTo>
-                  <a:pt x="1642" y="1538"/>
-                </a:lnTo>
-                <a:lnTo>
-                  <a:pt x="1660" y="1543"/>
-                </a:lnTo>
-                <a:lnTo>
-                  <a:pt x="1677" y="1548"/>
-                </a:lnTo>
-                <a:lnTo>
-                  <a:pt x="1695" y="1553"/>
-                </a:lnTo>
-                <a:lnTo>
-                  <a:pt x="1713" y="1558"/>
-                </a:lnTo>
-                <a:lnTo>
-                  <a:pt x="1731" y="1562"/>
-                </a:lnTo>
-                <a:lnTo>
-                  <a:pt x="1749" y="1567"/>
-                </a:lnTo>
-                <a:lnTo>
-                  <a:pt x="1767" y="1572"/>
-                </a:lnTo>
-                <a:lnTo>
-                  <a:pt x="1784" y="1576"/>
-                </a:lnTo>
-                <a:lnTo>
-                  <a:pt x="1802" y="1581"/>
-                </a:lnTo>
-                <a:lnTo>
-                  <a:pt x="1820" y="1585"/>
-                </a:lnTo>
-                <a:lnTo>
-                  <a:pt x="1838" y="1589"/>
-                </a:lnTo>
-                <a:lnTo>
-                  <a:pt x="1856" y="1594"/>
-                </a:lnTo>
-                <a:lnTo>
-                  <a:pt x="1874" y="1598"/>
-                </a:lnTo>
-                <a:lnTo>
-                  <a:pt x="1892" y="1602"/>
-                </a:lnTo>
-                <a:lnTo>
-                  <a:pt x="1909" y="1606"/>
-                </a:lnTo>
-                <a:lnTo>
-                  <a:pt x="1927" y="1610"/>
-                </a:lnTo>
-                <a:lnTo>
-                  <a:pt x="1945" y="1614"/>
-                </a:lnTo>
-                <a:lnTo>
-                  <a:pt x="1963" y="1618"/>
-                </a:lnTo>
-                <a:lnTo>
-                  <a:pt x="1981" y="1622"/>
-                </a:lnTo>
-                <a:lnTo>
-                  <a:pt x="1999" y="1625"/>
-                </a:lnTo>
-                <a:lnTo>
-                  <a:pt x="2016" y="1629"/>
-                </a:lnTo>
-                <a:lnTo>
-                  <a:pt x="2034" y="1633"/>
-                </a:lnTo>
-                <a:lnTo>
-                  <a:pt x="2052" y="1636"/>
-                </a:lnTo>
-                <a:lnTo>
-                  <a:pt x="2070" y="1640"/>
-                </a:lnTo>
-                <a:lnTo>
-                  <a:pt x="2088" y="1643"/>
-                </a:lnTo>
-                <a:lnTo>
-                  <a:pt x="2106" y="1646"/>
-                </a:lnTo>
-                <a:lnTo>
-                  <a:pt x="2124" y="1650"/>
-                </a:lnTo>
-                <a:lnTo>
-                  <a:pt x="2141" y="1653"/>
-                </a:lnTo>
-                <a:lnTo>
-                  <a:pt x="2159" y="1656"/>
-                </a:lnTo>
-                <a:lnTo>
-                  <a:pt x="2177" y="1659"/>
-                </a:lnTo>
-                <a:lnTo>
-                  <a:pt x="2195" y="1662"/>
-                </a:lnTo>
-                <a:lnTo>
-                  <a:pt x="2213" y="1665"/>
-                </a:lnTo>
-                <a:lnTo>
-                  <a:pt x="2231" y="1668"/>
-                </a:lnTo>
-                <a:lnTo>
-                  <a:pt x="2248" y="1671"/>
-                </a:lnTo>
-                <a:lnTo>
-                  <a:pt x="2266" y="1674"/>
-                </a:lnTo>
-                <a:lnTo>
-                  <a:pt x="2284" y="1676"/>
-                </a:lnTo>
-                <a:lnTo>
-                  <a:pt x="2302" y="1679"/>
-                </a:lnTo>
-                <a:lnTo>
-                  <a:pt x="2320" y="1682"/>
-                </a:lnTo>
-                <a:lnTo>
-                  <a:pt x="2338" y="1684"/>
-                </a:lnTo>
-                <a:lnTo>
-                  <a:pt x="2355" y="1687"/>
-                </a:lnTo>
-                <a:lnTo>
-                  <a:pt x="2373" y="1689"/>
-                </a:lnTo>
-                <a:lnTo>
-                  <a:pt x="2391" y="1691"/>
-                </a:lnTo>
-                <a:lnTo>
-                  <a:pt x="2409" y="1693"/>
-                </a:lnTo>
-                <a:lnTo>
-                  <a:pt x="2427" y="1696"/>
-                </a:lnTo>
-                <a:lnTo>
-                  <a:pt x="2445" y="1698"/>
-                </a:lnTo>
-                <a:lnTo>
-                  <a:pt x="2463" y="1700"/>
-                </a:lnTo>
-                <a:lnTo>
-                  <a:pt x="2480" y="1702"/>
-                </a:lnTo>
-                <a:lnTo>
-                  <a:pt x="2498" y="1704"/>
-                </a:lnTo>
-                <a:lnTo>
-                  <a:pt x="2516" y="1706"/>
-                </a:lnTo>
-                <a:lnTo>
-                  <a:pt x="2534" y="1707"/>
-                </a:lnTo>
-                <a:lnTo>
-                  <a:pt x="2552" y="1709"/>
-                </a:lnTo>
-                <a:lnTo>
-                  <a:pt x="2570" y="1711"/>
-                </a:lnTo>
-                <a:lnTo>
-                  <a:pt x="2587" y="1712"/>
-                </a:lnTo>
-                <a:lnTo>
-                  <a:pt x="2605" y="1714"/>
-                </a:lnTo>
-                <a:lnTo>
-                  <a:pt x="2623" y="1715"/>
-                </a:lnTo>
-                <a:lnTo>
-                  <a:pt x="2641" y="1717"/>
-                </a:lnTo>
-                <a:lnTo>
-                  <a:pt x="2659" y="1718"/>
-                </a:lnTo>
-                <a:lnTo>
-                  <a:pt x="2677" y="1719"/>
-                </a:lnTo>
-                <a:lnTo>
-                  <a:pt x="2695" y="1720"/>
-                </a:lnTo>
-                <a:lnTo>
-                  <a:pt x="2712" y="1722"/>
-                </a:lnTo>
-                <a:lnTo>
-                  <a:pt x="2730" y="1723"/>
-                </a:lnTo>
-                <a:lnTo>
-                  <a:pt x="2748" y="1724"/>
-                </a:lnTo>
-                <a:lnTo>
-                  <a:pt x="2766" y="1725"/>
-                </a:lnTo>
-                <a:lnTo>
-                  <a:pt x="2784" y="1725"/>
-                </a:lnTo>
-                <a:lnTo>
-                  <a:pt x="2802" y="1726"/>
-                </a:lnTo>
-                <a:lnTo>
-                  <a:pt x="2819" y="1727"/>
-                </a:lnTo>
-                <a:lnTo>
-                  <a:pt x="2837" y="1728"/>
-                </a:lnTo>
-                <a:lnTo>
-                  <a:pt x="2855" y="1728"/>
-                </a:lnTo>
-                <a:lnTo>
-                  <a:pt x="2873" y="1729"/>
-                </a:lnTo>
-                <a:lnTo>
-                  <a:pt x="2891" y="1729"/>
-                </a:lnTo>
-                <a:lnTo>
-                  <a:pt x="2909" y="1730"/>
-                </a:lnTo>
-                <a:lnTo>
-                  <a:pt x="2927" y="1730"/>
-                </a:lnTo>
-                <a:lnTo>
-                  <a:pt x="2944" y="1730"/>
-                </a:lnTo>
-                <a:lnTo>
-                  <a:pt x="2962" y="1731"/>
-                </a:lnTo>
-                <a:lnTo>
-                  <a:pt x="2980" y="1731"/>
-                </a:lnTo>
-                <a:lnTo>
-                  <a:pt x="2998" y="1731"/>
-                </a:lnTo>
-                <a:lnTo>
-                  <a:pt x="3016" y="1731"/>
-                </a:lnTo>
-                <a:lnTo>
-                  <a:pt x="3034" y="1731"/>
-                </a:lnTo>
-                <a:lnTo>
-                  <a:pt x="3051" y="1731"/>
-                </a:lnTo>
-                <a:lnTo>
-                  <a:pt x="3069" y="1730"/>
-                </a:lnTo>
-                <a:lnTo>
-                  <a:pt x="3087" y="1730"/>
-                </a:lnTo>
-                <a:lnTo>
-                  <a:pt x="3105" y="1730"/>
-                </a:lnTo>
-                <a:lnTo>
-                  <a:pt x="3123" y="1730"/>
-                </a:lnTo>
-                <a:lnTo>
-                  <a:pt x="3141" y="1729"/>
-                </a:lnTo>
-                <a:lnTo>
-                  <a:pt x="3158" y="1729"/>
-                </a:lnTo>
-                <a:lnTo>
-                  <a:pt x="3176" y="1728"/>
-                </a:lnTo>
-                <a:lnTo>
-                  <a:pt x="3194" y="1727"/>
-                </a:lnTo>
-                <a:lnTo>
-                  <a:pt x="3212" y="1727"/>
-                </a:lnTo>
-                <a:lnTo>
-                  <a:pt x="3230" y="1726"/>
-                </a:lnTo>
-                <a:lnTo>
-                  <a:pt x="3248" y="1725"/>
-                </a:lnTo>
-                <a:lnTo>
-                  <a:pt x="3266" y="1724"/>
-                </a:lnTo>
-                <a:lnTo>
-                  <a:pt x="3283" y="1723"/>
-                </a:lnTo>
-                <a:lnTo>
-                  <a:pt x="3301" y="1722"/>
-                </a:lnTo>
-                <a:lnTo>
-                  <a:pt x="3319" y="1721"/>
-                </a:lnTo>
-                <a:lnTo>
-                  <a:pt x="3337" y="1720"/>
-                </a:lnTo>
-                <a:lnTo>
-                  <a:pt x="3355" y="1719"/>
-                </a:lnTo>
-                <a:lnTo>
-                  <a:pt x="3373" y="1717"/>
-                </a:lnTo>
-                <a:lnTo>
-                  <a:pt x="3390" y="1716"/>
-                </a:lnTo>
-                <a:lnTo>
-                  <a:pt x="3408" y="1715"/>
-                </a:lnTo>
-                <a:lnTo>
-                  <a:pt x="3426" y="1713"/>
-                </a:lnTo>
-                <a:lnTo>
-                  <a:pt x="3444" y="1712"/>
-                </a:lnTo>
-                <a:lnTo>
-                  <a:pt x="3462" y="1710"/>
-                </a:lnTo>
-                <a:lnTo>
-                  <a:pt x="3480" y="1708"/>
-                </a:lnTo>
-                <a:lnTo>
-                  <a:pt x="3498" y="1707"/>
-                </a:lnTo>
-                <a:lnTo>
-                  <a:pt x="3515" y="1705"/>
-                </a:lnTo>
-                <a:lnTo>
-                  <a:pt x="3533" y="1703"/>
-                </a:lnTo>
-                <a:lnTo>
-                  <a:pt x="3551" y="1701"/>
-                </a:lnTo>
-                <a:lnTo>
-                  <a:pt x="3569" y="1699"/>
-                </a:lnTo>
-                <a:lnTo>
-                  <a:pt x="3587" y="1697"/>
-                </a:lnTo>
-                <a:lnTo>
-                  <a:pt x="3605" y="1695"/>
-                </a:lnTo>
-                <a:lnTo>
-                  <a:pt x="3622" y="1693"/>
-                </a:lnTo>
-                <a:lnTo>
-                  <a:pt x="3640" y="1690"/>
-                </a:lnTo>
-                <a:lnTo>
-                  <a:pt x="3658" y="1688"/>
-                </a:lnTo>
-                <a:lnTo>
-                  <a:pt x="3676" y="1686"/>
-                </a:lnTo>
-                <a:lnTo>
-                  <a:pt x="3694" y="1683"/>
-                </a:lnTo>
-                <a:lnTo>
-                  <a:pt x="3712" y="1681"/>
-                </a:lnTo>
-                <a:lnTo>
-                  <a:pt x="3730" y="1678"/>
-                </a:lnTo>
-                <a:lnTo>
-                  <a:pt x="3747" y="1675"/>
-                </a:lnTo>
-                <a:lnTo>
-                  <a:pt x="3765" y="1673"/>
-                </a:lnTo>
-                <a:lnTo>
-                  <a:pt x="3783" y="1670"/>
-                </a:lnTo>
-                <a:lnTo>
-                  <a:pt x="3801" y="1667"/>
-                </a:lnTo>
-                <a:lnTo>
-                  <a:pt x="3819" y="1664"/>
-                </a:lnTo>
-                <a:lnTo>
-                  <a:pt x="3837" y="1661"/>
-                </a:lnTo>
-                <a:lnTo>
-                  <a:pt x="3854" y="1658"/>
-                </a:lnTo>
-                <a:lnTo>
-                  <a:pt x="3872" y="1655"/>
-                </a:lnTo>
-                <a:lnTo>
-                  <a:pt x="3890" y="1652"/>
-                </a:lnTo>
-                <a:lnTo>
-                  <a:pt x="3908" y="1648"/>
-                </a:lnTo>
-                <a:lnTo>
-                  <a:pt x="3926" y="1645"/>
-                </a:lnTo>
-                <a:lnTo>
-                  <a:pt x="3944" y="1642"/>
-                </a:lnTo>
-                <a:lnTo>
-                  <a:pt x="3962" y="1638"/>
-                </a:lnTo>
-                <a:lnTo>
-                  <a:pt x="3979" y="1635"/>
-                </a:lnTo>
-                <a:lnTo>
-                  <a:pt x="3997" y="1631"/>
-                </a:lnTo>
-                <a:lnTo>
-                  <a:pt x="4015" y="1628"/>
-                </a:lnTo>
-                <a:lnTo>
-                  <a:pt x="4033" y="1624"/>
-                </a:lnTo>
-                <a:lnTo>
-                  <a:pt x="4051" y="1620"/>
-                </a:lnTo>
-                <a:lnTo>
-                  <a:pt x="4069" y="1616"/>
-                </a:lnTo>
-                <a:lnTo>
-                  <a:pt x="4086" y="1612"/>
-                </a:lnTo>
-                <a:lnTo>
-                  <a:pt x="4104" y="1608"/>
-                </a:lnTo>
-                <a:lnTo>
-                  <a:pt x="4122" y="1604"/>
-                </a:lnTo>
-                <a:lnTo>
-                  <a:pt x="4140" y="1600"/>
-                </a:lnTo>
-                <a:lnTo>
-                  <a:pt x="4158" y="1596"/>
-                </a:lnTo>
-                <a:lnTo>
-                  <a:pt x="4176" y="1592"/>
-                </a:lnTo>
-                <a:lnTo>
-                  <a:pt x="4193" y="1588"/>
-                </a:lnTo>
-                <a:lnTo>
-                  <a:pt x="4211" y="1583"/>
-                </a:lnTo>
-                <a:lnTo>
-                  <a:pt x="4229" y="1579"/>
-                </a:lnTo>
-                <a:lnTo>
-                  <a:pt x="4247" y="1574"/>
-                </a:lnTo>
-                <a:lnTo>
-                  <a:pt x="4265" y="1570"/>
-                </a:lnTo>
-                <a:lnTo>
-                  <a:pt x="4283" y="1565"/>
-                </a:lnTo>
-                <a:lnTo>
-                  <a:pt x="4301" y="1561"/>
-                </a:lnTo>
-                <a:lnTo>
-                  <a:pt x="4318" y="1556"/>
-                </a:lnTo>
-                <a:lnTo>
-                  <a:pt x="4336" y="1551"/>
-                </a:lnTo>
-                <a:lnTo>
-                  <a:pt x="4354" y="1546"/>
-                </a:lnTo>
-                <a:lnTo>
-                  <a:pt x="4372" y="1541"/>
-                </a:lnTo>
-                <a:lnTo>
-                  <a:pt x="4390" y="1536"/>
-                </a:lnTo>
-                <a:lnTo>
-                  <a:pt x="4408" y="1531"/>
-                </a:lnTo>
-                <a:lnTo>
-                  <a:pt x="4425" y="1526"/>
-                </a:lnTo>
-                <a:lnTo>
-                  <a:pt x="4443" y="1521"/>
-                </a:lnTo>
-                <a:lnTo>
-                  <a:pt x="4461" y="1515"/>
-                </a:lnTo>
-                <a:lnTo>
-                  <a:pt x="4479" y="1510"/>
-                </a:lnTo>
-                <a:lnTo>
-                  <a:pt x="4497" y="1505"/>
-                </a:lnTo>
-                <a:lnTo>
-                  <a:pt x="4515" y="1499"/>
-                </a:lnTo>
-                <a:lnTo>
-                  <a:pt x="4533" y="1494"/>
-                </a:lnTo>
-                <a:lnTo>
-                  <a:pt x="4550" y="1488"/>
-                </a:lnTo>
-                <a:lnTo>
-                  <a:pt x="4568" y="1482"/>
-                </a:lnTo>
-                <a:lnTo>
-                  <a:pt x="4586" y="1477"/>
-                </a:lnTo>
-                <a:lnTo>
-                  <a:pt x="4604" y="1471"/>
-                </a:lnTo>
-                <a:lnTo>
-                  <a:pt x="4622" y="1465"/>
-                </a:lnTo>
-                <a:lnTo>
-                  <a:pt x="4640" y="1459"/>
-                </a:lnTo>
-                <a:lnTo>
-                  <a:pt x="4657" y="1453"/>
-                </a:lnTo>
-                <a:lnTo>
-                  <a:pt x="4675" y="1447"/>
-                </a:lnTo>
-                <a:lnTo>
-                  <a:pt x="4693" y="1441"/>
-                </a:lnTo>
-                <a:lnTo>
-                  <a:pt x="4711" y="1435"/>
-                </a:lnTo>
-                <a:lnTo>
-                  <a:pt x="4729" y="1429"/>
-                </a:lnTo>
-                <a:lnTo>
-                  <a:pt x="4747" y="1422"/>
-                </a:lnTo>
-                <a:lnTo>
-                  <a:pt x="4765" y="1416"/>
-                </a:lnTo>
-                <a:lnTo>
-                  <a:pt x="4782" y="1409"/>
-                </a:lnTo>
-                <a:lnTo>
-                  <a:pt x="4800" y="1403"/>
-                </a:lnTo>
-                <a:lnTo>
-                  <a:pt x="4818" y="1396"/>
-                </a:lnTo>
-                <a:lnTo>
-                  <a:pt x="4836" y="1390"/>
-                </a:lnTo>
-                <a:lnTo>
-                  <a:pt x="4854" y="1383"/>
-                </a:lnTo>
-                <a:lnTo>
-                  <a:pt x="4872" y="1376"/>
-                </a:lnTo>
-                <a:lnTo>
-                  <a:pt x="4889" y="1369"/>
-                </a:lnTo>
-                <a:lnTo>
-                  <a:pt x="4907" y="1362"/>
-                </a:lnTo>
-                <a:lnTo>
-                  <a:pt x="4925" y="1355"/>
-                </a:lnTo>
-                <a:lnTo>
-                  <a:pt x="4943" y="1348"/>
-                </a:lnTo>
-                <a:lnTo>
-                  <a:pt x="4961" y="1341"/>
-                </a:lnTo>
-                <a:lnTo>
-                  <a:pt x="4979" y="1334"/>
-                </a:lnTo>
-                <a:lnTo>
-                  <a:pt x="4996" y="1327"/>
-                </a:lnTo>
-                <a:lnTo>
-                  <a:pt x="5014" y="1320"/>
-                </a:lnTo>
-                <a:lnTo>
-                  <a:pt x="5032" y="1312"/>
-                </a:lnTo>
-                <a:lnTo>
-                  <a:pt x="5050" y="1305"/>
-                </a:lnTo>
-                <a:lnTo>
-                  <a:pt x="5068" y="1297"/>
-                </a:lnTo>
-                <a:lnTo>
-                  <a:pt x="5086" y="1290"/>
-                </a:lnTo>
-                <a:lnTo>
-                  <a:pt x="5104" y="1282"/>
-                </a:lnTo>
-                <a:lnTo>
-                  <a:pt x="5121" y="1274"/>
-                </a:lnTo>
-                <a:lnTo>
-                  <a:pt x="5139" y="1267"/>
-                </a:lnTo>
-                <a:lnTo>
-                  <a:pt x="5157" y="1259"/>
-                </a:lnTo>
-                <a:lnTo>
-                  <a:pt x="5175" y="1251"/>
-                </a:lnTo>
-                <a:lnTo>
-                  <a:pt x="5193" y="1243"/>
-                </a:lnTo>
-                <a:lnTo>
-                  <a:pt x="5211" y="1235"/>
-                </a:lnTo>
-                <a:lnTo>
-                  <a:pt x="5228" y="1227"/>
-                </a:lnTo>
-                <a:lnTo>
-                  <a:pt x="5246" y="1219"/>
-                </a:lnTo>
-                <a:lnTo>
-                  <a:pt x="5264" y="1211"/>
-                </a:lnTo>
-                <a:lnTo>
-                  <a:pt x="5282" y="1202"/>
-                </a:lnTo>
-                <a:lnTo>
-                  <a:pt x="5300" y="1194"/>
-                </a:lnTo>
-                <a:lnTo>
-                  <a:pt x="5318" y="1186"/>
-                </a:lnTo>
-                <a:lnTo>
-                  <a:pt x="5336" y="1177"/>
-                </a:lnTo>
-                <a:lnTo>
-                  <a:pt x="5353" y="1169"/>
-                </a:lnTo>
-                <a:lnTo>
-                  <a:pt x="5371" y="1160"/>
-                </a:lnTo>
-                <a:lnTo>
-                  <a:pt x="5389" y="1151"/>
-                </a:lnTo>
-                <a:lnTo>
-                  <a:pt x="5407" y="1143"/>
-                </a:lnTo>
-                <a:lnTo>
-                  <a:pt x="5425" y="1134"/>
-                </a:lnTo>
-                <a:lnTo>
-                  <a:pt x="5443" y="1125"/>
-                </a:lnTo>
-                <a:lnTo>
-                  <a:pt x="5460" y="1116"/>
-                </a:lnTo>
-                <a:lnTo>
-                  <a:pt x="5478" y="1107"/>
-                </a:lnTo>
-                <a:lnTo>
-                  <a:pt x="5496" y="1098"/>
-                </a:lnTo>
-                <a:lnTo>
-                  <a:pt x="5514" y="1089"/>
-                </a:lnTo>
-                <a:lnTo>
-                  <a:pt x="5532" y="1080"/>
-                </a:lnTo>
-                <a:lnTo>
-                  <a:pt x="5550" y="1070"/>
-                </a:lnTo>
-                <a:lnTo>
-                  <a:pt x="5568" y="1061"/>
-                </a:lnTo>
-                <a:lnTo>
-                  <a:pt x="5585" y="1052"/>
-                </a:lnTo>
-                <a:lnTo>
-                  <a:pt x="5603" y="1042"/>
-                </a:lnTo>
-                <a:lnTo>
-                  <a:pt x="5621" y="1033"/>
-                </a:lnTo>
-                <a:lnTo>
-                  <a:pt x="5639" y="1023"/>
-                </a:lnTo>
-                <a:lnTo>
-                  <a:pt x="5657" y="1013"/>
-                </a:lnTo>
-                <a:lnTo>
-                  <a:pt x="5675" y="1004"/>
-                </a:lnTo>
-                <a:lnTo>
-                  <a:pt x="5692" y="994"/>
-                </a:lnTo>
-                <a:lnTo>
-                  <a:pt x="5710" y="984"/>
-                </a:lnTo>
-                <a:lnTo>
-                  <a:pt x="5728" y="974"/>
-                </a:lnTo>
-                <a:lnTo>
-                  <a:pt x="5746" y="964"/>
-                </a:lnTo>
-                <a:lnTo>
-                  <a:pt x="5764" y="954"/>
-                </a:lnTo>
-                <a:lnTo>
-                  <a:pt x="5782" y="944"/>
-                </a:lnTo>
-                <a:lnTo>
-                  <a:pt x="5799" y="934"/>
-                </a:lnTo>
-                <a:lnTo>
-                  <a:pt x="5817" y="924"/>
-                </a:lnTo>
-                <a:lnTo>
-                  <a:pt x="5835" y="913"/>
-                </a:lnTo>
-                <a:lnTo>
-                  <a:pt x="5853" y="903"/>
-                </a:lnTo>
-                <a:lnTo>
-                  <a:pt x="5871" y="893"/>
-                </a:lnTo>
-                <a:lnTo>
-                  <a:pt x="5889" y="882"/>
-                </a:lnTo>
-                <a:lnTo>
-                  <a:pt x="5907" y="872"/>
-                </a:lnTo>
-                <a:lnTo>
-                  <a:pt x="5924" y="861"/>
-                </a:lnTo>
-                <a:lnTo>
-                  <a:pt x="5942" y="850"/>
-                </a:lnTo>
-                <a:lnTo>
-                  <a:pt x="5960" y="839"/>
-                </a:lnTo>
-                <a:lnTo>
-                  <a:pt x="5978" y="829"/>
-                </a:lnTo>
-                <a:lnTo>
-                  <a:pt x="5996" y="818"/>
-                </a:lnTo>
-                <a:lnTo>
-                  <a:pt x="6014" y="807"/>
-                </a:lnTo>
-                <a:lnTo>
-                  <a:pt x="6031" y="796"/>
-                </a:lnTo>
-                <a:lnTo>
-                  <a:pt x="6049" y="785"/>
-                </a:lnTo>
-                <a:lnTo>
-                  <a:pt x="6067" y="774"/>
-                </a:lnTo>
-                <a:lnTo>
-                  <a:pt x="6085" y="762"/>
-                </a:lnTo>
-                <a:lnTo>
-                  <a:pt x="6103" y="751"/>
-                </a:lnTo>
-                <a:lnTo>
-                  <a:pt x="6121" y="740"/>
-                </a:lnTo>
-                <a:lnTo>
-                  <a:pt x="6139" y="728"/>
-                </a:lnTo>
-                <a:lnTo>
-                  <a:pt x="6156" y="717"/>
-                </a:lnTo>
-                <a:lnTo>
-                  <a:pt x="6174" y="705"/>
-                </a:lnTo>
-                <a:lnTo>
-                  <a:pt x="6192" y="694"/>
-                </a:lnTo>
-                <a:lnTo>
-                  <a:pt x="6210" y="682"/>
-                </a:lnTo>
-                <a:lnTo>
-                  <a:pt x="6228" y="670"/>
-                </a:lnTo>
-                <a:lnTo>
-                  <a:pt x="6246" y="658"/>
-                </a:lnTo>
-                <a:lnTo>
-                  <a:pt x="6263" y="647"/>
-                </a:lnTo>
-                <a:lnTo>
-                  <a:pt x="6281" y="635"/>
-                </a:lnTo>
-                <a:lnTo>
-                  <a:pt x="6299" y="623"/>
-                </a:lnTo>
-                <a:lnTo>
-                  <a:pt x="6317" y="611"/>
-                </a:lnTo>
-                <a:lnTo>
-                  <a:pt x="6335" y="598"/>
-                </a:lnTo>
-                <a:lnTo>
-                  <a:pt x="6353" y="586"/>
-                </a:lnTo>
-                <a:lnTo>
-                  <a:pt x="6371" y="574"/>
-                </a:lnTo>
-                <a:lnTo>
-                  <a:pt x="6388" y="562"/>
-                </a:lnTo>
-                <a:lnTo>
-                  <a:pt x="6406" y="549"/>
-                </a:lnTo>
-                <a:lnTo>
-                  <a:pt x="6424" y="537"/>
-                </a:lnTo>
-                <a:lnTo>
-                  <a:pt x="6442" y="524"/>
-                </a:lnTo>
-                <a:lnTo>
-                  <a:pt x="6460" y="512"/>
-                </a:lnTo>
-                <a:lnTo>
-                  <a:pt x="6478" y="499"/>
-                </a:lnTo>
-                <a:lnTo>
-                  <a:pt x="6495" y="486"/>
-                </a:lnTo>
-                <a:lnTo>
-                  <a:pt x="6513" y="474"/>
-                </a:lnTo>
-                <a:lnTo>
-                  <a:pt x="6531" y="461"/>
-                </a:lnTo>
-                <a:lnTo>
-                  <a:pt x="6549" y="448"/>
-                </a:lnTo>
-                <a:lnTo>
-                  <a:pt x="6567" y="435"/>
-                </a:lnTo>
-                <a:lnTo>
-                  <a:pt x="6585" y="422"/>
-                </a:lnTo>
-                <a:lnTo>
-                  <a:pt x="6603" y="409"/>
-                </a:lnTo>
-                <a:lnTo>
-                  <a:pt x="6620" y="395"/>
-                </a:lnTo>
-                <a:lnTo>
-                  <a:pt x="6638" y="382"/>
-                </a:lnTo>
-                <a:lnTo>
-                  <a:pt x="6656" y="369"/>
-                </a:lnTo>
-                <a:lnTo>
-                  <a:pt x="6674" y="356"/>
-                </a:lnTo>
-                <a:lnTo>
-                  <a:pt x="6692" y="342"/>
-                </a:lnTo>
-                <a:lnTo>
-                  <a:pt x="6710" y="329"/>
-                </a:lnTo>
-                <a:lnTo>
-                  <a:pt x="6727" y="315"/>
-                </a:lnTo>
-                <a:lnTo>
-                  <a:pt x="6745" y="301"/>
-                </a:lnTo>
-                <a:lnTo>
-                  <a:pt x="6763" y="288"/>
-                </a:lnTo>
-                <a:lnTo>
-                  <a:pt x="6781" y="274"/>
-                </a:lnTo>
-                <a:lnTo>
-                  <a:pt x="6799" y="260"/>
-                </a:lnTo>
-                <a:lnTo>
-                  <a:pt x="6817" y="246"/>
-                </a:lnTo>
-                <a:lnTo>
-                  <a:pt x="6834" y="232"/>
-                </a:lnTo>
-                <a:lnTo>
-                  <a:pt x="6852" y="218"/>
-                </a:lnTo>
-                <a:lnTo>
-                  <a:pt x="6870" y="204"/>
-                </a:lnTo>
-                <a:lnTo>
-                  <a:pt x="6888" y="190"/>
-                </a:lnTo>
-                <a:lnTo>
-                  <a:pt x="6906" y="176"/>
-                </a:lnTo>
-                <a:lnTo>
-                  <a:pt x="6924" y="161"/>
-                </a:lnTo>
-                <a:lnTo>
-                  <a:pt x="6942" y="147"/>
-                </a:lnTo>
-                <a:lnTo>
-                  <a:pt x="6959" y="133"/>
-                </a:lnTo>
-                <a:lnTo>
-                  <a:pt x="6977" y="118"/>
-                </a:lnTo>
-                <a:lnTo>
-                  <a:pt x="6995" y="104"/>
-                </a:lnTo>
-                <a:lnTo>
-                  <a:pt x="7013" y="89"/>
-                </a:lnTo>
-                <a:lnTo>
-                  <a:pt x="7031" y="74"/>
-                </a:lnTo>
-                <a:lnTo>
-                  <a:pt x="7049" y="60"/>
-                </a:lnTo>
-                <a:lnTo>
-                  <a:pt x="7066" y="45"/>
-                </a:lnTo>
-                <a:lnTo>
-                  <a:pt x="7084" y="30"/>
-                </a:lnTo>
-                <a:lnTo>
-                  <a:pt x="7102" y="15"/>
-                </a:lnTo>
-                <a:lnTo>
-                  <a:pt x="7120" y="0"/>
-                </a:lnTo>
-              </a:path>
-            </a:pathLst>
-          </a:custGeom>
-          <a:noFill/>
-          <a:ln w="25400">
-            <a:solidFill>
-              <a:srgbClr val="7963AF"/>
-            </a:solidFill>
-            <a:prstDash val="dash"/>
-          </a:ln>
-        </p:spPr>
-        <p:style>
-          <a:lnRef idx="1">
-            <a:schemeClr val="accent1"/>
-          </a:lnRef>
-          <a:fillRef idx="3">
-            <a:schemeClr val="accent1"/>
-          </a:fillRef>
-          <a:effectRef idx="0">
-            <a:schemeClr val="accent1"/>
-          </a:effectRef>
-          <a:fontRef idx="minor">
-            <a:schemeClr val="lt1"/>
-          </a:fontRef>
-        </p:style>
-        <p:txBody>
-          <a:bodyPr rtlCol="0" anchor="ctr"/>
-          <a:lstStyle/>
-          <a:p>
-            <a:pPr algn="ctr"/>
-          </a:p>
-        </p:txBody>
-      </p:sp>
-      <p:sp>
-        <p:nvSpPr>
-          <p:cNvPr id="10" name="Freeform 9"/>
-          <p:cNvSpPr/>
-          <p:nvPr/>
-        </p:nvSpPr>
-        <p:spPr>
-          <a:xfrm>
             <a:off x="896112" y="3765499"/>
             <a:ext cx="6510528" cy="761695"/>
           </a:xfrm>
@@ -11705,7 +10407,7 @@
       </p:sp>
       <p:sp>
         <p:nvSpPr>
-          <p:cNvPr id="11" name="Oval 10"/>
+          <p:cNvPr id="10" name="Oval 9"/>
           <p:cNvSpPr/>
           <p:nvPr/>
         </p:nvSpPr>
@@ -11750,7 +10452,7 @@
       </p:sp>
       <p:sp>
         <p:nvSpPr>
-          <p:cNvPr id="12" name="Oval 11"/>
+          <p:cNvPr id="11" name="Oval 10"/>
           <p:cNvSpPr/>
           <p:nvPr/>
         </p:nvSpPr>
@@ -11795,7 +10497,7 @@
       </p:sp>
       <p:sp>
         <p:nvSpPr>
-          <p:cNvPr id="13" name="Oval 12"/>
+          <p:cNvPr id="12" name="Oval 11"/>
           <p:cNvSpPr/>
           <p:nvPr/>
         </p:nvSpPr>
@@ -11840,7 +10542,7 @@
       </p:sp>
       <p:sp>
         <p:nvSpPr>
-          <p:cNvPr id="14" name="Oval 13"/>
+          <p:cNvPr id="13" name="Oval 12"/>
           <p:cNvSpPr/>
           <p:nvPr/>
         </p:nvSpPr>
@@ -11885,7 +10587,7 @@
       </p:sp>
       <p:sp>
         <p:nvSpPr>
-          <p:cNvPr id="15" name="Oval 14"/>
+          <p:cNvPr id="14" name="Oval 13"/>
           <p:cNvSpPr/>
           <p:nvPr/>
         </p:nvSpPr>
@@ -11930,7 +10632,7 @@
       </p:sp>
       <p:sp>
         <p:nvSpPr>
-          <p:cNvPr id="16" name="Oval 15"/>
+          <p:cNvPr id="15" name="Oval 14"/>
           <p:cNvSpPr/>
           <p:nvPr/>
         </p:nvSpPr>
@@ -11975,7 +10677,7 @@
       </p:sp>
       <p:sp>
         <p:nvSpPr>
-          <p:cNvPr id="17" name="Oval 16"/>
+          <p:cNvPr id="16" name="Oval 15"/>
           <p:cNvSpPr/>
           <p:nvPr/>
         </p:nvSpPr>
@@ -12020,7 +10722,7 @@
       </p:sp>
       <p:sp>
         <p:nvSpPr>
-          <p:cNvPr id="18" name="Oval 17"/>
+          <p:cNvPr id="17" name="Oval 16"/>
           <p:cNvSpPr/>
           <p:nvPr/>
         </p:nvSpPr>
@@ -12065,7 +10767,7 @@
       </p:sp>
       <p:sp>
         <p:nvSpPr>
-          <p:cNvPr id="19" name="Oval 18"/>
+          <p:cNvPr id="18" name="Oval 17"/>
           <p:cNvSpPr/>
           <p:nvPr/>
         </p:nvSpPr>
@@ -12110,7 +10812,7 @@
       </p:sp>
       <p:sp>
         <p:nvSpPr>
-          <p:cNvPr id="20" name="Oval 19"/>
+          <p:cNvPr id="19" name="Oval 18"/>
           <p:cNvSpPr/>
           <p:nvPr/>
         </p:nvSpPr>
@@ -12155,7 +10857,7 @@
       </p:sp>
       <p:sp>
         <p:nvSpPr>
-          <p:cNvPr id="21" name="Oval 20"/>
+          <p:cNvPr id="20" name="Oval 19"/>
           <p:cNvSpPr/>
           <p:nvPr/>
         </p:nvSpPr>
@@ -12200,7 +10902,7 @@
       </p:sp>
       <p:sp>
         <p:nvSpPr>
-          <p:cNvPr id="22" name="Oval 21"/>
+          <p:cNvPr id="21" name="Oval 20"/>
           <p:cNvSpPr/>
           <p:nvPr/>
         </p:nvSpPr>
@@ -12245,7 +10947,7 @@
       </p:sp>
       <p:sp>
         <p:nvSpPr>
-          <p:cNvPr id="23" name="Oval 22"/>
+          <p:cNvPr id="22" name="Oval 21"/>
           <p:cNvSpPr/>
           <p:nvPr/>
         </p:nvSpPr>
@@ -12290,7 +10992,7 @@
       </p:sp>
       <p:sp>
         <p:nvSpPr>
-          <p:cNvPr id="24" name="Oval 23"/>
+          <p:cNvPr id="23" name="Oval 22"/>
           <p:cNvSpPr/>
           <p:nvPr/>
         </p:nvSpPr>
@@ -12335,7 +11037,7 @@
       </p:sp>
       <p:sp>
         <p:nvSpPr>
-          <p:cNvPr id="25" name="Oval 24"/>
+          <p:cNvPr id="24" name="Oval 23"/>
           <p:cNvSpPr/>
           <p:nvPr/>
         </p:nvSpPr>
@@ -12380,7 +11082,7 @@
       </p:sp>
       <p:sp>
         <p:nvSpPr>
-          <p:cNvPr id="26" name="Oval 25"/>
+          <p:cNvPr id="25" name="Oval 24"/>
           <p:cNvSpPr/>
           <p:nvPr/>
         </p:nvSpPr>
@@ -12425,7 +11127,7 @@
       </p:sp>
       <p:sp>
         <p:nvSpPr>
-          <p:cNvPr id="27" name="Oval 26"/>
+          <p:cNvPr id="26" name="Oval 25"/>
           <p:cNvSpPr/>
           <p:nvPr/>
         </p:nvSpPr>
@@ -12470,7 +11172,7 @@
       </p:sp>
       <p:sp>
         <p:nvSpPr>
-          <p:cNvPr id="28" name="Oval 27"/>
+          <p:cNvPr id="27" name="Oval 26"/>
           <p:cNvSpPr/>
           <p:nvPr/>
         </p:nvSpPr>
@@ -12515,7 +11217,7 @@
       </p:sp>
       <p:sp>
         <p:nvSpPr>
-          <p:cNvPr id="29" name="Oval 28"/>
+          <p:cNvPr id="28" name="Oval 27"/>
           <p:cNvSpPr/>
           <p:nvPr/>
         </p:nvSpPr>
@@ -12560,7 +11262,7 @@
       </p:sp>
       <p:sp>
         <p:nvSpPr>
-          <p:cNvPr id="30" name="Oval 29"/>
+          <p:cNvPr id="29" name="Oval 28"/>
           <p:cNvSpPr/>
           <p:nvPr/>
         </p:nvSpPr>
@@ -12605,7 +11307,7 @@
       </p:sp>
       <p:sp>
         <p:nvSpPr>
-          <p:cNvPr id="31" name="Oval 30"/>
+          <p:cNvPr id="30" name="Oval 29"/>
           <p:cNvSpPr/>
           <p:nvPr/>
         </p:nvSpPr>
@@ -12650,7 +11352,7 @@
       </p:sp>
       <p:sp>
         <p:nvSpPr>
-          <p:cNvPr id="32" name="Oval 31"/>
+          <p:cNvPr id="31" name="Oval 30"/>
           <p:cNvSpPr/>
           <p:nvPr/>
         </p:nvSpPr>
@@ -12695,7 +11397,7 @@
       </p:sp>
       <p:sp>
         <p:nvSpPr>
-          <p:cNvPr id="33" name="Oval 32"/>
+          <p:cNvPr id="32" name="Oval 31"/>
           <p:cNvSpPr/>
           <p:nvPr/>
         </p:nvSpPr>
@@ -12740,7 +11442,7 @@
       </p:sp>
       <p:sp>
         <p:nvSpPr>
-          <p:cNvPr id="34" name="Oval 33"/>
+          <p:cNvPr id="33" name="Oval 32"/>
           <p:cNvSpPr/>
           <p:nvPr/>
         </p:nvSpPr>
@@ -12785,7 +11487,7 @@
       </p:sp>
       <p:sp>
         <p:nvSpPr>
-          <p:cNvPr id="35" name="Oval 34"/>
+          <p:cNvPr id="34" name="Oval 33"/>
           <p:cNvSpPr/>
           <p:nvPr/>
         </p:nvSpPr>
@@ -12830,7 +11532,7 @@
       </p:sp>
       <p:sp>
         <p:nvSpPr>
-          <p:cNvPr id="36" name="TextBox 35"/>
+          <p:cNvPr id="35" name="TextBox 34"/>
           <p:cNvSpPr txBox="1"/>
           <p:nvPr/>
         </p:nvSpPr>
@@ -12869,7 +11571,7 @@
       </p:sp>
       <p:sp>
         <p:nvSpPr>
-          <p:cNvPr id="37" name="TextBox 36"/>
+          <p:cNvPr id="36" name="TextBox 35"/>
           <p:cNvSpPr txBox="1"/>
           <p:nvPr/>
         </p:nvSpPr>
@@ -12924,7 +11626,7 @@
       </p:sp>
       <p:sp>
         <p:nvSpPr>
-          <p:cNvPr id="38" name="Oval 37"/>
+          <p:cNvPr id="37" name="Oval 36"/>
           <p:cNvSpPr/>
           <p:nvPr/>
         </p:nvSpPr>
@@ -12969,7 +11671,7 @@
       </p:sp>
       <p:sp>
         <p:nvSpPr>
-          <p:cNvPr id="39" name="TextBox 38"/>
+          <p:cNvPr id="38" name="TextBox 37"/>
           <p:cNvSpPr txBox="1"/>
           <p:nvPr/>
         </p:nvSpPr>
@@ -13008,7 +11710,7 @@
       </p:sp>
       <p:cxnSp>
         <p:nvCxnSpPr>
-          <p:cNvPr id="40" name="Connector 39"/>
+          <p:cNvPr id="39" name="Connector 38"/>
           <p:cNvCxnSpPr/>
           <p:nvPr/>
         </p:nvCxnSpPr>
@@ -13043,7 +11745,7 @@
       </p:cxnSp>
       <p:sp>
         <p:nvSpPr>
-          <p:cNvPr id="41" name="TextBox 40"/>
+          <p:cNvPr id="40" name="TextBox 39"/>
           <p:cNvSpPr txBox="1"/>
           <p:nvPr/>
         </p:nvSpPr>
@@ -13080,81 +11782,6 @@
           </a:p>
         </p:txBody>
       </p:sp>
-      <p:cxnSp>
-        <p:nvCxnSpPr>
-          <p:cNvPr id="42" name="Connector 41"/>
-          <p:cNvCxnSpPr/>
-          <p:nvPr/>
-        </p:nvCxnSpPr>
-        <p:spPr>
-          <a:xfrm>
-            <a:off x="6400800" y="5989320"/>
-            <a:ext cx="256032" cy="0"/>
-          </a:xfrm>
-          <a:prstGeom prst="line">
-            <a:avLst/>
-          </a:prstGeom>
-          <a:ln w="25400">
-            <a:solidFill>
-              <a:srgbClr val="7963AF"/>
-            </a:solidFill>
-            <a:prstDash val="dash"/>
-          </a:ln>
-        </p:spPr>
-        <p:style>
-          <a:lnRef idx="2">
-            <a:schemeClr val="accent1"/>
-          </a:lnRef>
-          <a:fillRef idx="0">
-            <a:schemeClr val="accent1"/>
-          </a:fillRef>
-          <a:effectRef idx="0">
-            <a:schemeClr val="accent1"/>
-          </a:effectRef>
-          <a:fontRef idx="minor">
-            <a:schemeClr val="tx1"/>
-          </a:fontRef>
-        </p:style>
-      </p:cxnSp>
-      <p:sp>
-        <p:nvSpPr>
-          <p:cNvPr id="43" name="TextBox 42"/>
-          <p:cNvSpPr txBox="1"/>
-          <p:nvPr/>
-        </p:nvSpPr>
-        <p:spPr>
-          <a:xfrm>
-            <a:off x="6757416" y="5870448"/>
-            <a:ext cx="2468880" cy="320040"/>
-          </a:xfrm>
-          <a:prstGeom prst="rect">
-            <a:avLst/>
-          </a:prstGeom>
-          <a:noFill/>
-        </p:spPr>
-        <p:txBody>
-          <a:bodyPr wrap="square" lIns="0" rIns="0" tIns="0" bIns="0">
-            <a:spAutoFit/>
-          </a:bodyPr>
-          <a:lstStyle/>
-          <a:p>
-            <a:pPr>
-              <a:spcAft>
-                <a:spcPts val="0"/>
-              </a:spcAft>
-              <a:defRPr sz="1300" b="0">
-                <a:solidFill>
-                  <a:srgbClr val="686C66"/>
-                </a:solidFill>
-                <a:latin typeface="Arial"/>
-              </a:defRPr>
-            </a:pPr>
-            <a:r>
-              <a:t>true pattern</a:t>
-            </a:r>
-          </a:p>
-        </p:txBody>
-      </p:sp>
     </p:spTree>
   </p:cSld>
   <p:clrMapOvr>
@@ -13181,9 +11808,33 @@
         <p:nvPr/>
       </p:nvGrpSpPr>
       <p:grpSpPr/>
+      <p:pic>
+        <p:nvPicPr>
+          <p:cNvPr id="2" name="Picture 1" descr="image.png"/>
+          <p:cNvPicPr>
+            <a:picLocks noChangeAspect="1"/>
+          </p:cNvPicPr>
+          <p:nvPr/>
+        </p:nvPicPr>
+        <p:blipFill>
+          <a:blip r:embed="rId2"/>
+          <a:stretch>
+            <a:fillRect/>
+          </a:stretch>
+        </p:blipFill>
+        <p:spPr>
+          <a:xfrm>
+            <a:off x="11768328" y="201168"/>
+            <a:ext cx="219456" cy="6455664"/>
+          </a:xfrm>
+          <a:prstGeom prst="rect">
+            <a:avLst/>
+          </a:prstGeom>
+        </p:spPr>
+      </p:pic>
       <p:sp>
         <p:nvSpPr>
-          <p:cNvPr id="2" name="TextBox 1"/>
+          <p:cNvPr id="3" name="TextBox 2"/>
           <p:cNvSpPr txBox="1"/>
           <p:nvPr/>
         </p:nvSpPr>
@@ -13220,41 +11871,6 @@
           </a:p>
         </p:txBody>
       </p:sp>
-      <p:cxnSp>
-        <p:nvCxnSpPr>
-          <p:cNvPr id="3" name="Connector 2"/>
-          <p:cNvCxnSpPr/>
-          <p:nvPr/>
-        </p:nvCxnSpPr>
-        <p:spPr>
-          <a:xfrm>
-            <a:off x="594360" y="6419088"/>
-            <a:ext cx="10972800" cy="0"/>
-          </a:xfrm>
-          <a:prstGeom prst="line">
-            <a:avLst/>
-          </a:prstGeom>
-          <a:ln w="12700">
-            <a:solidFill>
-              <a:srgbClr val="D4D6D0"/>
-            </a:solidFill>
-          </a:ln>
-        </p:spPr>
-        <p:style>
-          <a:lnRef idx="2">
-            <a:schemeClr val="accent1"/>
-          </a:lnRef>
-          <a:fillRef idx="0">
-            <a:schemeClr val="accent1"/>
-          </a:fillRef>
-          <a:effectRef idx="0">
-            <a:schemeClr val="accent1"/>
-          </a:effectRef>
-          <a:fontRef idx="minor">
-            <a:schemeClr val="tx1"/>
-          </a:fontRef>
-        </p:style>
-      </p:cxnSp>
       <p:sp>
         <p:nvSpPr>
           <p:cNvPr id="4" name="TextBox 3"/>
@@ -13450,1258 +12066,6 @@
         </p:nvSpPr>
         <p:spPr>
           <a:xfrm>
-            <a:off x="896112" y="3099816"/>
-            <a:ext cx="6510528" cy="1582826"/>
-          </a:xfrm>
-          <a:custGeom>
-            <a:avLst/>
-            <a:gdLst/>
-            <a:ahLst/>
-            <a:cxnLst/>
-            <a:rect l="l" t="t" r="r" b="b"/>
-            <a:pathLst>
-              <a:path w="7120" h="1731">
-                <a:moveTo>
-                  <a:pt x="0" y="800"/>
-                </a:moveTo>
-                <a:lnTo>
-                  <a:pt x="18" y="811"/>
-                </a:lnTo>
-                <a:lnTo>
-                  <a:pt x="36" y="822"/>
-                </a:lnTo>
-                <a:lnTo>
-                  <a:pt x="54" y="833"/>
-                </a:lnTo>
-                <a:lnTo>
-                  <a:pt x="71" y="844"/>
-                </a:lnTo>
-                <a:lnTo>
-                  <a:pt x="89" y="854"/>
-                </a:lnTo>
-                <a:lnTo>
-                  <a:pt x="107" y="865"/>
-                </a:lnTo>
-                <a:lnTo>
-                  <a:pt x="125" y="876"/>
-                </a:lnTo>
-                <a:lnTo>
-                  <a:pt x="143" y="886"/>
-                </a:lnTo>
-                <a:lnTo>
-                  <a:pt x="161" y="897"/>
-                </a:lnTo>
-                <a:lnTo>
-                  <a:pt x="178" y="907"/>
-                </a:lnTo>
-                <a:lnTo>
-                  <a:pt x="196" y="917"/>
-                </a:lnTo>
-                <a:lnTo>
-                  <a:pt x="214" y="928"/>
-                </a:lnTo>
-                <a:lnTo>
-                  <a:pt x="232" y="938"/>
-                </a:lnTo>
-                <a:lnTo>
-                  <a:pt x="250" y="948"/>
-                </a:lnTo>
-                <a:lnTo>
-                  <a:pt x="268" y="958"/>
-                </a:lnTo>
-                <a:lnTo>
-                  <a:pt x="286" y="968"/>
-                </a:lnTo>
-                <a:lnTo>
-                  <a:pt x="303" y="978"/>
-                </a:lnTo>
-                <a:lnTo>
-                  <a:pt x="321" y="988"/>
-                </a:lnTo>
-                <a:lnTo>
-                  <a:pt x="339" y="998"/>
-                </a:lnTo>
-                <a:lnTo>
-                  <a:pt x="357" y="1007"/>
-                </a:lnTo>
-                <a:lnTo>
-                  <a:pt x="375" y="1017"/>
-                </a:lnTo>
-                <a:lnTo>
-                  <a:pt x="393" y="1027"/>
-                </a:lnTo>
-                <a:lnTo>
-                  <a:pt x="410" y="1036"/>
-                </a:lnTo>
-                <a:lnTo>
-                  <a:pt x="428" y="1046"/>
-                </a:lnTo>
-                <a:lnTo>
-                  <a:pt x="446" y="1055"/>
-                </a:lnTo>
-                <a:lnTo>
-                  <a:pt x="464" y="1065"/>
-                </a:lnTo>
-                <a:lnTo>
-                  <a:pt x="482" y="1074"/>
-                </a:lnTo>
-                <a:lnTo>
-                  <a:pt x="500" y="1083"/>
-                </a:lnTo>
-                <a:lnTo>
-                  <a:pt x="517" y="1092"/>
-                </a:lnTo>
-                <a:lnTo>
-                  <a:pt x="535" y="1101"/>
-                </a:lnTo>
-                <a:lnTo>
-                  <a:pt x="553" y="1110"/>
-                </a:lnTo>
-                <a:lnTo>
-                  <a:pt x="571" y="1119"/>
-                </a:lnTo>
-                <a:lnTo>
-                  <a:pt x="589" y="1128"/>
-                </a:lnTo>
-                <a:lnTo>
-                  <a:pt x="607" y="1137"/>
-                </a:lnTo>
-                <a:lnTo>
-                  <a:pt x="625" y="1146"/>
-                </a:lnTo>
-                <a:lnTo>
-                  <a:pt x="642" y="1155"/>
-                </a:lnTo>
-                <a:lnTo>
-                  <a:pt x="660" y="1163"/>
-                </a:lnTo>
-                <a:lnTo>
-                  <a:pt x="678" y="1172"/>
-                </a:lnTo>
-                <a:lnTo>
-                  <a:pt x="696" y="1180"/>
-                </a:lnTo>
-                <a:lnTo>
-                  <a:pt x="714" y="1189"/>
-                </a:lnTo>
-                <a:lnTo>
-                  <a:pt x="732" y="1197"/>
-                </a:lnTo>
-                <a:lnTo>
-                  <a:pt x="749" y="1206"/>
-                </a:lnTo>
-                <a:lnTo>
-                  <a:pt x="767" y="1214"/>
-                </a:lnTo>
-                <a:lnTo>
-                  <a:pt x="785" y="1222"/>
-                </a:lnTo>
-                <a:lnTo>
-                  <a:pt x="803" y="1230"/>
-                </a:lnTo>
-                <a:lnTo>
-                  <a:pt x="821" y="1238"/>
-                </a:lnTo>
-                <a:lnTo>
-                  <a:pt x="839" y="1246"/>
-                </a:lnTo>
-                <a:lnTo>
-                  <a:pt x="857" y="1254"/>
-                </a:lnTo>
-                <a:lnTo>
-                  <a:pt x="874" y="1262"/>
-                </a:lnTo>
-                <a:lnTo>
-                  <a:pt x="892" y="1270"/>
-                </a:lnTo>
-                <a:lnTo>
-                  <a:pt x="910" y="1277"/>
-                </a:lnTo>
-                <a:lnTo>
-                  <a:pt x="928" y="1285"/>
-                </a:lnTo>
-                <a:lnTo>
-                  <a:pt x="946" y="1293"/>
-                </a:lnTo>
-                <a:lnTo>
-                  <a:pt x="964" y="1300"/>
-                </a:lnTo>
-                <a:lnTo>
-                  <a:pt x="981" y="1308"/>
-                </a:lnTo>
-                <a:lnTo>
-                  <a:pt x="999" y="1315"/>
-                </a:lnTo>
-                <a:lnTo>
-                  <a:pt x="1017" y="1322"/>
-                </a:lnTo>
-                <a:lnTo>
-                  <a:pt x="1035" y="1330"/>
-                </a:lnTo>
-                <a:lnTo>
-                  <a:pt x="1053" y="1337"/>
-                </a:lnTo>
-                <a:lnTo>
-                  <a:pt x="1071" y="1344"/>
-                </a:lnTo>
-                <a:lnTo>
-                  <a:pt x="1089" y="1351"/>
-                </a:lnTo>
-                <a:lnTo>
-                  <a:pt x="1106" y="1358"/>
-                </a:lnTo>
-                <a:lnTo>
-                  <a:pt x="1124" y="1365"/>
-                </a:lnTo>
-                <a:lnTo>
-                  <a:pt x="1142" y="1372"/>
-                </a:lnTo>
-                <a:lnTo>
-                  <a:pt x="1160" y="1379"/>
-                </a:lnTo>
-                <a:lnTo>
-                  <a:pt x="1178" y="1386"/>
-                </a:lnTo>
-                <a:lnTo>
-                  <a:pt x="1196" y="1392"/>
-                </a:lnTo>
-                <a:lnTo>
-                  <a:pt x="1213" y="1399"/>
-                </a:lnTo>
-                <a:lnTo>
-                  <a:pt x="1231" y="1405"/>
-                </a:lnTo>
-                <a:lnTo>
-                  <a:pt x="1249" y="1412"/>
-                </a:lnTo>
-                <a:lnTo>
-                  <a:pt x="1267" y="1418"/>
-                </a:lnTo>
-                <a:lnTo>
-                  <a:pt x="1285" y="1425"/>
-                </a:lnTo>
-                <a:lnTo>
-                  <a:pt x="1303" y="1431"/>
-                </a:lnTo>
-                <a:lnTo>
-                  <a:pt x="1321" y="1437"/>
-                </a:lnTo>
-                <a:lnTo>
-                  <a:pt x="1338" y="1443"/>
-                </a:lnTo>
-                <a:lnTo>
-                  <a:pt x="1356" y="1449"/>
-                </a:lnTo>
-                <a:lnTo>
-                  <a:pt x="1374" y="1455"/>
-                </a:lnTo>
-                <a:lnTo>
-                  <a:pt x="1392" y="1461"/>
-                </a:lnTo>
-                <a:lnTo>
-                  <a:pt x="1410" y="1467"/>
-                </a:lnTo>
-                <a:lnTo>
-                  <a:pt x="1428" y="1473"/>
-                </a:lnTo>
-                <a:lnTo>
-                  <a:pt x="1445" y="1479"/>
-                </a:lnTo>
-                <a:lnTo>
-                  <a:pt x="1463" y="1485"/>
-                </a:lnTo>
-                <a:lnTo>
-                  <a:pt x="1481" y="1490"/>
-                </a:lnTo>
-                <a:lnTo>
-                  <a:pt x="1499" y="1496"/>
-                </a:lnTo>
-                <a:lnTo>
-                  <a:pt x="1517" y="1501"/>
-                </a:lnTo>
-                <a:lnTo>
-                  <a:pt x="1535" y="1507"/>
-                </a:lnTo>
-                <a:lnTo>
-                  <a:pt x="1552" y="1512"/>
-                </a:lnTo>
-                <a:lnTo>
-                  <a:pt x="1570" y="1517"/>
-                </a:lnTo>
-                <a:lnTo>
-                  <a:pt x="1588" y="1523"/>
-                </a:lnTo>
-                <a:lnTo>
-                  <a:pt x="1606" y="1528"/>
-                </a:lnTo>
-                <a:lnTo>
-                  <a:pt x="1624" y="1533"/>
-                </a:lnTo>
-                <a:lnTo>
-                  <a:pt x="1642" y="1538"/>
-                </a:lnTo>
-                <a:lnTo>
-                  <a:pt x="1660" y="1543"/>
-                </a:lnTo>
-                <a:lnTo>
-                  <a:pt x="1677" y="1548"/>
-                </a:lnTo>
-                <a:lnTo>
-                  <a:pt x="1695" y="1553"/>
-                </a:lnTo>
-                <a:lnTo>
-                  <a:pt x="1713" y="1558"/>
-                </a:lnTo>
-                <a:lnTo>
-                  <a:pt x="1731" y="1562"/>
-                </a:lnTo>
-                <a:lnTo>
-                  <a:pt x="1749" y="1567"/>
-                </a:lnTo>
-                <a:lnTo>
-                  <a:pt x="1767" y="1572"/>
-                </a:lnTo>
-                <a:lnTo>
-                  <a:pt x="1784" y="1576"/>
-                </a:lnTo>
-                <a:lnTo>
-                  <a:pt x="1802" y="1581"/>
-                </a:lnTo>
-                <a:lnTo>
-                  <a:pt x="1820" y="1585"/>
-                </a:lnTo>
-                <a:lnTo>
-                  <a:pt x="1838" y="1589"/>
-                </a:lnTo>
-                <a:lnTo>
-                  <a:pt x="1856" y="1594"/>
-                </a:lnTo>
-                <a:lnTo>
-                  <a:pt x="1874" y="1598"/>
-                </a:lnTo>
-                <a:lnTo>
-                  <a:pt x="1892" y="1602"/>
-                </a:lnTo>
-                <a:lnTo>
-                  <a:pt x="1909" y="1606"/>
-                </a:lnTo>
-                <a:lnTo>
-                  <a:pt x="1927" y="1610"/>
-                </a:lnTo>
-                <a:lnTo>
-                  <a:pt x="1945" y="1614"/>
-                </a:lnTo>
-                <a:lnTo>
-                  <a:pt x="1963" y="1618"/>
-                </a:lnTo>
-                <a:lnTo>
-                  <a:pt x="1981" y="1622"/>
-                </a:lnTo>
-                <a:lnTo>
-                  <a:pt x="1999" y="1625"/>
-                </a:lnTo>
-                <a:lnTo>
-                  <a:pt x="2016" y="1629"/>
-                </a:lnTo>
-                <a:lnTo>
-                  <a:pt x="2034" y="1633"/>
-                </a:lnTo>
-                <a:lnTo>
-                  <a:pt x="2052" y="1636"/>
-                </a:lnTo>
-                <a:lnTo>
-                  <a:pt x="2070" y="1640"/>
-                </a:lnTo>
-                <a:lnTo>
-                  <a:pt x="2088" y="1643"/>
-                </a:lnTo>
-                <a:lnTo>
-                  <a:pt x="2106" y="1646"/>
-                </a:lnTo>
-                <a:lnTo>
-                  <a:pt x="2124" y="1650"/>
-                </a:lnTo>
-                <a:lnTo>
-                  <a:pt x="2141" y="1653"/>
-                </a:lnTo>
-                <a:lnTo>
-                  <a:pt x="2159" y="1656"/>
-                </a:lnTo>
-                <a:lnTo>
-                  <a:pt x="2177" y="1659"/>
-                </a:lnTo>
-                <a:lnTo>
-                  <a:pt x="2195" y="1662"/>
-                </a:lnTo>
-                <a:lnTo>
-                  <a:pt x="2213" y="1665"/>
-                </a:lnTo>
-                <a:lnTo>
-                  <a:pt x="2231" y="1668"/>
-                </a:lnTo>
-                <a:lnTo>
-                  <a:pt x="2248" y="1671"/>
-                </a:lnTo>
-                <a:lnTo>
-                  <a:pt x="2266" y="1674"/>
-                </a:lnTo>
-                <a:lnTo>
-                  <a:pt x="2284" y="1676"/>
-                </a:lnTo>
-                <a:lnTo>
-                  <a:pt x="2302" y="1679"/>
-                </a:lnTo>
-                <a:lnTo>
-                  <a:pt x="2320" y="1682"/>
-                </a:lnTo>
-                <a:lnTo>
-                  <a:pt x="2338" y="1684"/>
-                </a:lnTo>
-                <a:lnTo>
-                  <a:pt x="2355" y="1687"/>
-                </a:lnTo>
-                <a:lnTo>
-                  <a:pt x="2373" y="1689"/>
-                </a:lnTo>
-                <a:lnTo>
-                  <a:pt x="2391" y="1691"/>
-                </a:lnTo>
-                <a:lnTo>
-                  <a:pt x="2409" y="1693"/>
-                </a:lnTo>
-                <a:lnTo>
-                  <a:pt x="2427" y="1696"/>
-                </a:lnTo>
-                <a:lnTo>
-                  <a:pt x="2445" y="1698"/>
-                </a:lnTo>
-                <a:lnTo>
-                  <a:pt x="2463" y="1700"/>
-                </a:lnTo>
-                <a:lnTo>
-                  <a:pt x="2480" y="1702"/>
-                </a:lnTo>
-                <a:lnTo>
-                  <a:pt x="2498" y="1704"/>
-                </a:lnTo>
-                <a:lnTo>
-                  <a:pt x="2516" y="1706"/>
-                </a:lnTo>
-                <a:lnTo>
-                  <a:pt x="2534" y="1707"/>
-                </a:lnTo>
-                <a:lnTo>
-                  <a:pt x="2552" y="1709"/>
-                </a:lnTo>
-                <a:lnTo>
-                  <a:pt x="2570" y="1711"/>
-                </a:lnTo>
-                <a:lnTo>
-                  <a:pt x="2587" y="1712"/>
-                </a:lnTo>
-                <a:lnTo>
-                  <a:pt x="2605" y="1714"/>
-                </a:lnTo>
-                <a:lnTo>
-                  <a:pt x="2623" y="1715"/>
-                </a:lnTo>
-                <a:lnTo>
-                  <a:pt x="2641" y="1717"/>
-                </a:lnTo>
-                <a:lnTo>
-                  <a:pt x="2659" y="1718"/>
-                </a:lnTo>
-                <a:lnTo>
-                  <a:pt x="2677" y="1719"/>
-                </a:lnTo>
-                <a:lnTo>
-                  <a:pt x="2695" y="1720"/>
-                </a:lnTo>
-                <a:lnTo>
-                  <a:pt x="2712" y="1722"/>
-                </a:lnTo>
-                <a:lnTo>
-                  <a:pt x="2730" y="1723"/>
-                </a:lnTo>
-                <a:lnTo>
-                  <a:pt x="2748" y="1724"/>
-                </a:lnTo>
-                <a:lnTo>
-                  <a:pt x="2766" y="1725"/>
-                </a:lnTo>
-                <a:lnTo>
-                  <a:pt x="2784" y="1725"/>
-                </a:lnTo>
-                <a:lnTo>
-                  <a:pt x="2802" y="1726"/>
-                </a:lnTo>
-                <a:lnTo>
-                  <a:pt x="2819" y="1727"/>
-                </a:lnTo>
-                <a:lnTo>
-                  <a:pt x="2837" y="1728"/>
-                </a:lnTo>
-                <a:lnTo>
-                  <a:pt x="2855" y="1728"/>
-                </a:lnTo>
-                <a:lnTo>
-                  <a:pt x="2873" y="1729"/>
-                </a:lnTo>
-                <a:lnTo>
-                  <a:pt x="2891" y="1729"/>
-                </a:lnTo>
-                <a:lnTo>
-                  <a:pt x="2909" y="1730"/>
-                </a:lnTo>
-                <a:lnTo>
-                  <a:pt x="2927" y="1730"/>
-                </a:lnTo>
-                <a:lnTo>
-                  <a:pt x="2944" y="1730"/>
-                </a:lnTo>
-                <a:lnTo>
-                  <a:pt x="2962" y="1731"/>
-                </a:lnTo>
-                <a:lnTo>
-                  <a:pt x="2980" y="1731"/>
-                </a:lnTo>
-                <a:lnTo>
-                  <a:pt x="2998" y="1731"/>
-                </a:lnTo>
-                <a:lnTo>
-                  <a:pt x="3016" y="1731"/>
-                </a:lnTo>
-                <a:lnTo>
-                  <a:pt x="3034" y="1731"/>
-                </a:lnTo>
-                <a:lnTo>
-                  <a:pt x="3051" y="1731"/>
-                </a:lnTo>
-                <a:lnTo>
-                  <a:pt x="3069" y="1730"/>
-                </a:lnTo>
-                <a:lnTo>
-                  <a:pt x="3087" y="1730"/>
-                </a:lnTo>
-                <a:lnTo>
-                  <a:pt x="3105" y="1730"/>
-                </a:lnTo>
-                <a:lnTo>
-                  <a:pt x="3123" y="1730"/>
-                </a:lnTo>
-                <a:lnTo>
-                  <a:pt x="3141" y="1729"/>
-                </a:lnTo>
-                <a:lnTo>
-                  <a:pt x="3158" y="1729"/>
-                </a:lnTo>
-                <a:lnTo>
-                  <a:pt x="3176" y="1728"/>
-                </a:lnTo>
-                <a:lnTo>
-                  <a:pt x="3194" y="1727"/>
-                </a:lnTo>
-                <a:lnTo>
-                  <a:pt x="3212" y="1727"/>
-                </a:lnTo>
-                <a:lnTo>
-                  <a:pt x="3230" y="1726"/>
-                </a:lnTo>
-                <a:lnTo>
-                  <a:pt x="3248" y="1725"/>
-                </a:lnTo>
-                <a:lnTo>
-                  <a:pt x="3266" y="1724"/>
-                </a:lnTo>
-                <a:lnTo>
-                  <a:pt x="3283" y="1723"/>
-                </a:lnTo>
-                <a:lnTo>
-                  <a:pt x="3301" y="1722"/>
-                </a:lnTo>
-                <a:lnTo>
-                  <a:pt x="3319" y="1721"/>
-                </a:lnTo>
-                <a:lnTo>
-                  <a:pt x="3337" y="1720"/>
-                </a:lnTo>
-                <a:lnTo>
-                  <a:pt x="3355" y="1719"/>
-                </a:lnTo>
-                <a:lnTo>
-                  <a:pt x="3373" y="1717"/>
-                </a:lnTo>
-                <a:lnTo>
-                  <a:pt x="3390" y="1716"/>
-                </a:lnTo>
-                <a:lnTo>
-                  <a:pt x="3408" y="1715"/>
-                </a:lnTo>
-                <a:lnTo>
-                  <a:pt x="3426" y="1713"/>
-                </a:lnTo>
-                <a:lnTo>
-                  <a:pt x="3444" y="1712"/>
-                </a:lnTo>
-                <a:lnTo>
-                  <a:pt x="3462" y="1710"/>
-                </a:lnTo>
-                <a:lnTo>
-                  <a:pt x="3480" y="1708"/>
-                </a:lnTo>
-                <a:lnTo>
-                  <a:pt x="3498" y="1707"/>
-                </a:lnTo>
-                <a:lnTo>
-                  <a:pt x="3515" y="1705"/>
-                </a:lnTo>
-                <a:lnTo>
-                  <a:pt x="3533" y="1703"/>
-                </a:lnTo>
-                <a:lnTo>
-                  <a:pt x="3551" y="1701"/>
-                </a:lnTo>
-                <a:lnTo>
-                  <a:pt x="3569" y="1699"/>
-                </a:lnTo>
-                <a:lnTo>
-                  <a:pt x="3587" y="1697"/>
-                </a:lnTo>
-                <a:lnTo>
-                  <a:pt x="3605" y="1695"/>
-                </a:lnTo>
-                <a:lnTo>
-                  <a:pt x="3622" y="1693"/>
-                </a:lnTo>
-                <a:lnTo>
-                  <a:pt x="3640" y="1690"/>
-                </a:lnTo>
-                <a:lnTo>
-                  <a:pt x="3658" y="1688"/>
-                </a:lnTo>
-                <a:lnTo>
-                  <a:pt x="3676" y="1686"/>
-                </a:lnTo>
-                <a:lnTo>
-                  <a:pt x="3694" y="1683"/>
-                </a:lnTo>
-                <a:lnTo>
-                  <a:pt x="3712" y="1681"/>
-                </a:lnTo>
-                <a:lnTo>
-                  <a:pt x="3730" y="1678"/>
-                </a:lnTo>
-                <a:lnTo>
-                  <a:pt x="3747" y="1675"/>
-                </a:lnTo>
-                <a:lnTo>
-                  <a:pt x="3765" y="1673"/>
-                </a:lnTo>
-                <a:lnTo>
-                  <a:pt x="3783" y="1670"/>
-                </a:lnTo>
-                <a:lnTo>
-                  <a:pt x="3801" y="1667"/>
-                </a:lnTo>
-                <a:lnTo>
-                  <a:pt x="3819" y="1664"/>
-                </a:lnTo>
-                <a:lnTo>
-                  <a:pt x="3837" y="1661"/>
-                </a:lnTo>
-                <a:lnTo>
-                  <a:pt x="3854" y="1658"/>
-                </a:lnTo>
-                <a:lnTo>
-                  <a:pt x="3872" y="1655"/>
-                </a:lnTo>
-                <a:lnTo>
-                  <a:pt x="3890" y="1652"/>
-                </a:lnTo>
-                <a:lnTo>
-                  <a:pt x="3908" y="1648"/>
-                </a:lnTo>
-                <a:lnTo>
-                  <a:pt x="3926" y="1645"/>
-                </a:lnTo>
-                <a:lnTo>
-                  <a:pt x="3944" y="1642"/>
-                </a:lnTo>
-                <a:lnTo>
-                  <a:pt x="3962" y="1638"/>
-                </a:lnTo>
-                <a:lnTo>
-                  <a:pt x="3979" y="1635"/>
-                </a:lnTo>
-                <a:lnTo>
-                  <a:pt x="3997" y="1631"/>
-                </a:lnTo>
-                <a:lnTo>
-                  <a:pt x="4015" y="1628"/>
-                </a:lnTo>
-                <a:lnTo>
-                  <a:pt x="4033" y="1624"/>
-                </a:lnTo>
-                <a:lnTo>
-                  <a:pt x="4051" y="1620"/>
-                </a:lnTo>
-                <a:lnTo>
-                  <a:pt x="4069" y="1616"/>
-                </a:lnTo>
-                <a:lnTo>
-                  <a:pt x="4086" y="1612"/>
-                </a:lnTo>
-                <a:lnTo>
-                  <a:pt x="4104" y="1608"/>
-                </a:lnTo>
-                <a:lnTo>
-                  <a:pt x="4122" y="1604"/>
-                </a:lnTo>
-                <a:lnTo>
-                  <a:pt x="4140" y="1600"/>
-                </a:lnTo>
-                <a:lnTo>
-                  <a:pt x="4158" y="1596"/>
-                </a:lnTo>
-                <a:lnTo>
-                  <a:pt x="4176" y="1592"/>
-                </a:lnTo>
-                <a:lnTo>
-                  <a:pt x="4193" y="1588"/>
-                </a:lnTo>
-                <a:lnTo>
-                  <a:pt x="4211" y="1583"/>
-                </a:lnTo>
-                <a:lnTo>
-                  <a:pt x="4229" y="1579"/>
-                </a:lnTo>
-                <a:lnTo>
-                  <a:pt x="4247" y="1574"/>
-                </a:lnTo>
-                <a:lnTo>
-                  <a:pt x="4265" y="1570"/>
-                </a:lnTo>
-                <a:lnTo>
-                  <a:pt x="4283" y="1565"/>
-                </a:lnTo>
-                <a:lnTo>
-                  <a:pt x="4301" y="1561"/>
-                </a:lnTo>
-                <a:lnTo>
-                  <a:pt x="4318" y="1556"/>
-                </a:lnTo>
-                <a:lnTo>
-                  <a:pt x="4336" y="1551"/>
-                </a:lnTo>
-                <a:lnTo>
-                  <a:pt x="4354" y="1546"/>
-                </a:lnTo>
-                <a:lnTo>
-                  <a:pt x="4372" y="1541"/>
-                </a:lnTo>
-                <a:lnTo>
-                  <a:pt x="4390" y="1536"/>
-                </a:lnTo>
-                <a:lnTo>
-                  <a:pt x="4408" y="1531"/>
-                </a:lnTo>
-                <a:lnTo>
-                  <a:pt x="4425" y="1526"/>
-                </a:lnTo>
-                <a:lnTo>
-                  <a:pt x="4443" y="1521"/>
-                </a:lnTo>
-                <a:lnTo>
-                  <a:pt x="4461" y="1515"/>
-                </a:lnTo>
-                <a:lnTo>
-                  <a:pt x="4479" y="1510"/>
-                </a:lnTo>
-                <a:lnTo>
-                  <a:pt x="4497" y="1505"/>
-                </a:lnTo>
-                <a:lnTo>
-                  <a:pt x="4515" y="1499"/>
-                </a:lnTo>
-                <a:lnTo>
-                  <a:pt x="4533" y="1494"/>
-                </a:lnTo>
-                <a:lnTo>
-                  <a:pt x="4550" y="1488"/>
-                </a:lnTo>
-                <a:lnTo>
-                  <a:pt x="4568" y="1482"/>
-                </a:lnTo>
-                <a:lnTo>
-                  <a:pt x="4586" y="1477"/>
-                </a:lnTo>
-                <a:lnTo>
-                  <a:pt x="4604" y="1471"/>
-                </a:lnTo>
-                <a:lnTo>
-                  <a:pt x="4622" y="1465"/>
-                </a:lnTo>
-                <a:lnTo>
-                  <a:pt x="4640" y="1459"/>
-                </a:lnTo>
-                <a:lnTo>
-                  <a:pt x="4657" y="1453"/>
-                </a:lnTo>
-                <a:lnTo>
-                  <a:pt x="4675" y="1447"/>
-                </a:lnTo>
-                <a:lnTo>
-                  <a:pt x="4693" y="1441"/>
-                </a:lnTo>
-                <a:lnTo>
-                  <a:pt x="4711" y="1435"/>
-                </a:lnTo>
-                <a:lnTo>
-                  <a:pt x="4729" y="1429"/>
-                </a:lnTo>
-                <a:lnTo>
-                  <a:pt x="4747" y="1422"/>
-                </a:lnTo>
-                <a:lnTo>
-                  <a:pt x="4765" y="1416"/>
-                </a:lnTo>
-                <a:lnTo>
-                  <a:pt x="4782" y="1409"/>
-                </a:lnTo>
-                <a:lnTo>
-                  <a:pt x="4800" y="1403"/>
-                </a:lnTo>
-                <a:lnTo>
-                  <a:pt x="4818" y="1396"/>
-                </a:lnTo>
-                <a:lnTo>
-                  <a:pt x="4836" y="1390"/>
-                </a:lnTo>
-                <a:lnTo>
-                  <a:pt x="4854" y="1383"/>
-                </a:lnTo>
-                <a:lnTo>
-                  <a:pt x="4872" y="1376"/>
-                </a:lnTo>
-                <a:lnTo>
-                  <a:pt x="4889" y="1369"/>
-                </a:lnTo>
-                <a:lnTo>
-                  <a:pt x="4907" y="1362"/>
-                </a:lnTo>
-                <a:lnTo>
-                  <a:pt x="4925" y="1355"/>
-                </a:lnTo>
-                <a:lnTo>
-                  <a:pt x="4943" y="1348"/>
-                </a:lnTo>
-                <a:lnTo>
-                  <a:pt x="4961" y="1341"/>
-                </a:lnTo>
-                <a:lnTo>
-                  <a:pt x="4979" y="1334"/>
-                </a:lnTo>
-                <a:lnTo>
-                  <a:pt x="4996" y="1327"/>
-                </a:lnTo>
-                <a:lnTo>
-                  <a:pt x="5014" y="1320"/>
-                </a:lnTo>
-                <a:lnTo>
-                  <a:pt x="5032" y="1312"/>
-                </a:lnTo>
-                <a:lnTo>
-                  <a:pt x="5050" y="1305"/>
-                </a:lnTo>
-                <a:lnTo>
-                  <a:pt x="5068" y="1297"/>
-                </a:lnTo>
-                <a:lnTo>
-                  <a:pt x="5086" y="1290"/>
-                </a:lnTo>
-                <a:lnTo>
-                  <a:pt x="5104" y="1282"/>
-                </a:lnTo>
-                <a:lnTo>
-                  <a:pt x="5121" y="1274"/>
-                </a:lnTo>
-                <a:lnTo>
-                  <a:pt x="5139" y="1267"/>
-                </a:lnTo>
-                <a:lnTo>
-                  <a:pt x="5157" y="1259"/>
-                </a:lnTo>
-                <a:lnTo>
-                  <a:pt x="5175" y="1251"/>
-                </a:lnTo>
-                <a:lnTo>
-                  <a:pt x="5193" y="1243"/>
-                </a:lnTo>
-                <a:lnTo>
-                  <a:pt x="5211" y="1235"/>
-                </a:lnTo>
-                <a:lnTo>
-                  <a:pt x="5228" y="1227"/>
-                </a:lnTo>
-                <a:lnTo>
-                  <a:pt x="5246" y="1219"/>
-                </a:lnTo>
-                <a:lnTo>
-                  <a:pt x="5264" y="1211"/>
-                </a:lnTo>
-                <a:lnTo>
-                  <a:pt x="5282" y="1202"/>
-                </a:lnTo>
-                <a:lnTo>
-                  <a:pt x="5300" y="1194"/>
-                </a:lnTo>
-                <a:lnTo>
-                  <a:pt x="5318" y="1186"/>
-                </a:lnTo>
-                <a:lnTo>
-                  <a:pt x="5336" y="1177"/>
-                </a:lnTo>
-                <a:lnTo>
-                  <a:pt x="5353" y="1169"/>
-                </a:lnTo>
-                <a:lnTo>
-                  <a:pt x="5371" y="1160"/>
-                </a:lnTo>
-                <a:lnTo>
-                  <a:pt x="5389" y="1151"/>
-                </a:lnTo>
-                <a:lnTo>
-                  <a:pt x="5407" y="1143"/>
-                </a:lnTo>
-                <a:lnTo>
-                  <a:pt x="5425" y="1134"/>
-                </a:lnTo>
-                <a:lnTo>
-                  <a:pt x="5443" y="1125"/>
-                </a:lnTo>
-                <a:lnTo>
-                  <a:pt x="5460" y="1116"/>
-                </a:lnTo>
-                <a:lnTo>
-                  <a:pt x="5478" y="1107"/>
-                </a:lnTo>
-                <a:lnTo>
-                  <a:pt x="5496" y="1098"/>
-                </a:lnTo>
-                <a:lnTo>
-                  <a:pt x="5514" y="1089"/>
-                </a:lnTo>
-                <a:lnTo>
-                  <a:pt x="5532" y="1080"/>
-                </a:lnTo>
-                <a:lnTo>
-                  <a:pt x="5550" y="1070"/>
-                </a:lnTo>
-                <a:lnTo>
-                  <a:pt x="5568" y="1061"/>
-                </a:lnTo>
-                <a:lnTo>
-                  <a:pt x="5585" y="1052"/>
-                </a:lnTo>
-                <a:lnTo>
-                  <a:pt x="5603" y="1042"/>
-                </a:lnTo>
-                <a:lnTo>
-                  <a:pt x="5621" y="1033"/>
-                </a:lnTo>
-                <a:lnTo>
-                  <a:pt x="5639" y="1023"/>
-                </a:lnTo>
-                <a:lnTo>
-                  <a:pt x="5657" y="1013"/>
-                </a:lnTo>
-                <a:lnTo>
-                  <a:pt x="5675" y="1004"/>
-                </a:lnTo>
-                <a:lnTo>
-                  <a:pt x="5692" y="994"/>
-                </a:lnTo>
-                <a:lnTo>
-                  <a:pt x="5710" y="984"/>
-                </a:lnTo>
-                <a:lnTo>
-                  <a:pt x="5728" y="974"/>
-                </a:lnTo>
-                <a:lnTo>
-                  <a:pt x="5746" y="964"/>
-                </a:lnTo>
-                <a:lnTo>
-                  <a:pt x="5764" y="954"/>
-                </a:lnTo>
-                <a:lnTo>
-                  <a:pt x="5782" y="944"/>
-                </a:lnTo>
-                <a:lnTo>
-                  <a:pt x="5799" y="934"/>
-                </a:lnTo>
-                <a:lnTo>
-                  <a:pt x="5817" y="924"/>
-                </a:lnTo>
-                <a:lnTo>
-                  <a:pt x="5835" y="913"/>
-                </a:lnTo>
-                <a:lnTo>
-                  <a:pt x="5853" y="903"/>
-                </a:lnTo>
-                <a:lnTo>
-                  <a:pt x="5871" y="893"/>
-                </a:lnTo>
-                <a:lnTo>
-                  <a:pt x="5889" y="882"/>
-                </a:lnTo>
-                <a:lnTo>
-                  <a:pt x="5907" y="872"/>
-                </a:lnTo>
-                <a:lnTo>
-                  <a:pt x="5924" y="861"/>
-                </a:lnTo>
-                <a:lnTo>
-                  <a:pt x="5942" y="850"/>
-                </a:lnTo>
-                <a:lnTo>
-                  <a:pt x="5960" y="839"/>
-                </a:lnTo>
-                <a:lnTo>
-                  <a:pt x="5978" y="829"/>
-                </a:lnTo>
-                <a:lnTo>
-                  <a:pt x="5996" y="818"/>
-                </a:lnTo>
-                <a:lnTo>
-                  <a:pt x="6014" y="807"/>
-                </a:lnTo>
-                <a:lnTo>
-                  <a:pt x="6031" y="796"/>
-                </a:lnTo>
-                <a:lnTo>
-                  <a:pt x="6049" y="785"/>
-                </a:lnTo>
-                <a:lnTo>
-                  <a:pt x="6067" y="774"/>
-                </a:lnTo>
-                <a:lnTo>
-                  <a:pt x="6085" y="762"/>
-                </a:lnTo>
-                <a:lnTo>
-                  <a:pt x="6103" y="751"/>
-                </a:lnTo>
-                <a:lnTo>
-                  <a:pt x="6121" y="740"/>
-                </a:lnTo>
-                <a:lnTo>
-                  <a:pt x="6139" y="728"/>
-                </a:lnTo>
-                <a:lnTo>
-                  <a:pt x="6156" y="717"/>
-                </a:lnTo>
-                <a:lnTo>
-                  <a:pt x="6174" y="705"/>
-                </a:lnTo>
-                <a:lnTo>
-                  <a:pt x="6192" y="694"/>
-                </a:lnTo>
-                <a:lnTo>
-                  <a:pt x="6210" y="682"/>
-                </a:lnTo>
-                <a:lnTo>
-                  <a:pt x="6228" y="670"/>
-                </a:lnTo>
-                <a:lnTo>
-                  <a:pt x="6246" y="658"/>
-                </a:lnTo>
-                <a:lnTo>
-                  <a:pt x="6263" y="647"/>
-                </a:lnTo>
-                <a:lnTo>
-                  <a:pt x="6281" y="635"/>
-                </a:lnTo>
-                <a:lnTo>
-                  <a:pt x="6299" y="623"/>
-                </a:lnTo>
-                <a:lnTo>
-                  <a:pt x="6317" y="611"/>
-                </a:lnTo>
-                <a:lnTo>
-                  <a:pt x="6335" y="598"/>
-                </a:lnTo>
-                <a:lnTo>
-                  <a:pt x="6353" y="586"/>
-                </a:lnTo>
-                <a:lnTo>
-                  <a:pt x="6371" y="574"/>
-                </a:lnTo>
-                <a:lnTo>
-                  <a:pt x="6388" y="562"/>
-                </a:lnTo>
-                <a:lnTo>
-                  <a:pt x="6406" y="549"/>
-                </a:lnTo>
-                <a:lnTo>
-                  <a:pt x="6424" y="537"/>
-                </a:lnTo>
-                <a:lnTo>
-                  <a:pt x="6442" y="524"/>
-                </a:lnTo>
-                <a:lnTo>
-                  <a:pt x="6460" y="512"/>
-                </a:lnTo>
-                <a:lnTo>
-                  <a:pt x="6478" y="499"/>
-                </a:lnTo>
-                <a:lnTo>
-                  <a:pt x="6495" y="486"/>
-                </a:lnTo>
-                <a:lnTo>
-                  <a:pt x="6513" y="474"/>
-                </a:lnTo>
-                <a:lnTo>
-                  <a:pt x="6531" y="461"/>
-                </a:lnTo>
-                <a:lnTo>
-                  <a:pt x="6549" y="448"/>
-                </a:lnTo>
-                <a:lnTo>
-                  <a:pt x="6567" y="435"/>
-                </a:lnTo>
-                <a:lnTo>
-                  <a:pt x="6585" y="422"/>
-                </a:lnTo>
-                <a:lnTo>
-                  <a:pt x="6603" y="409"/>
-                </a:lnTo>
-                <a:lnTo>
-                  <a:pt x="6620" y="395"/>
-                </a:lnTo>
-                <a:lnTo>
-                  <a:pt x="6638" y="382"/>
-                </a:lnTo>
-                <a:lnTo>
-                  <a:pt x="6656" y="369"/>
-                </a:lnTo>
-                <a:lnTo>
-                  <a:pt x="6674" y="356"/>
-                </a:lnTo>
-                <a:lnTo>
-                  <a:pt x="6692" y="342"/>
-                </a:lnTo>
-                <a:lnTo>
-                  <a:pt x="6710" y="329"/>
-                </a:lnTo>
-                <a:lnTo>
-                  <a:pt x="6727" y="315"/>
-                </a:lnTo>
-                <a:lnTo>
-                  <a:pt x="6745" y="301"/>
-                </a:lnTo>
-                <a:lnTo>
-                  <a:pt x="6763" y="288"/>
-                </a:lnTo>
-                <a:lnTo>
-                  <a:pt x="6781" y="274"/>
-                </a:lnTo>
-                <a:lnTo>
-                  <a:pt x="6799" y="260"/>
-                </a:lnTo>
-                <a:lnTo>
-                  <a:pt x="6817" y="246"/>
-                </a:lnTo>
-                <a:lnTo>
-                  <a:pt x="6834" y="232"/>
-                </a:lnTo>
-                <a:lnTo>
-                  <a:pt x="6852" y="218"/>
-                </a:lnTo>
-                <a:lnTo>
-                  <a:pt x="6870" y="204"/>
-                </a:lnTo>
-                <a:lnTo>
-                  <a:pt x="6888" y="190"/>
-                </a:lnTo>
-                <a:lnTo>
-                  <a:pt x="6906" y="176"/>
-                </a:lnTo>
-                <a:lnTo>
-                  <a:pt x="6924" y="161"/>
-                </a:lnTo>
-                <a:lnTo>
-                  <a:pt x="6942" y="147"/>
-                </a:lnTo>
-                <a:lnTo>
-                  <a:pt x="6959" y="133"/>
-                </a:lnTo>
-                <a:lnTo>
-                  <a:pt x="6977" y="118"/>
-                </a:lnTo>
-                <a:lnTo>
-                  <a:pt x="6995" y="104"/>
-                </a:lnTo>
-                <a:lnTo>
-                  <a:pt x="7013" y="89"/>
-                </a:lnTo>
-                <a:lnTo>
-                  <a:pt x="7031" y="74"/>
-                </a:lnTo>
-                <a:lnTo>
-                  <a:pt x="7049" y="60"/>
-                </a:lnTo>
-                <a:lnTo>
-                  <a:pt x="7066" y="45"/>
-                </a:lnTo>
-                <a:lnTo>
-                  <a:pt x="7084" y="30"/>
-                </a:lnTo>
-                <a:lnTo>
-                  <a:pt x="7102" y="15"/>
-                </a:lnTo>
-                <a:lnTo>
-                  <a:pt x="7120" y="0"/>
-                </a:lnTo>
-              </a:path>
-            </a:pathLst>
-          </a:custGeom>
-          <a:noFill/>
-          <a:ln w="25400">
-            <a:solidFill>
-              <a:srgbClr val="7963AF"/>
-            </a:solidFill>
-            <a:prstDash val="dash"/>
-          </a:ln>
-        </p:spPr>
-        <p:style>
-          <a:lnRef idx="1">
-            <a:schemeClr val="accent1"/>
-          </a:lnRef>
-          <a:fillRef idx="3">
-            <a:schemeClr val="accent1"/>
-          </a:fillRef>
-          <a:effectRef idx="0">
-            <a:schemeClr val="accent1"/>
-          </a:effectRef>
-          <a:fontRef idx="minor">
-            <a:schemeClr val="lt1"/>
-          </a:fontRef>
-        </p:style>
-        <p:txBody>
-          <a:bodyPr rtlCol="0" anchor="ctr"/>
-          <a:lstStyle/>
-          <a:p>
-            <a:pPr algn="ctr"/>
-          </a:p>
-        </p:txBody>
-      </p:sp>
-      <p:sp>
-        <p:nvSpPr>
-          <p:cNvPr id="10" name="Freeform 9"/>
-          <p:cNvSpPr/>
-          <p:nvPr/>
-        </p:nvSpPr>
-        <p:spPr>
-          <a:xfrm>
             <a:off x="896112" y="2876702"/>
             <a:ext cx="6510528" cy="2254910"/>
           </a:xfrm>
@@ -15947,7 +13311,7 @@
       </p:sp>
       <p:sp>
         <p:nvSpPr>
-          <p:cNvPr id="11" name="Oval 10"/>
+          <p:cNvPr id="10" name="Oval 9"/>
           <p:cNvSpPr/>
           <p:nvPr/>
         </p:nvSpPr>
@@ -15992,7 +13356,7 @@
       </p:sp>
       <p:sp>
         <p:nvSpPr>
-          <p:cNvPr id="12" name="Oval 11"/>
+          <p:cNvPr id="11" name="Oval 10"/>
           <p:cNvSpPr/>
           <p:nvPr/>
         </p:nvSpPr>
@@ -16037,7 +13401,7 @@
       </p:sp>
       <p:sp>
         <p:nvSpPr>
-          <p:cNvPr id="13" name="Oval 12"/>
+          <p:cNvPr id="12" name="Oval 11"/>
           <p:cNvSpPr/>
           <p:nvPr/>
         </p:nvSpPr>
@@ -16082,7 +13446,7 @@
       </p:sp>
       <p:sp>
         <p:nvSpPr>
-          <p:cNvPr id="14" name="Oval 13"/>
+          <p:cNvPr id="13" name="Oval 12"/>
           <p:cNvSpPr/>
           <p:nvPr/>
         </p:nvSpPr>
@@ -16127,7 +13491,7 @@
       </p:sp>
       <p:sp>
         <p:nvSpPr>
-          <p:cNvPr id="15" name="Oval 14"/>
+          <p:cNvPr id="14" name="Oval 13"/>
           <p:cNvSpPr/>
           <p:nvPr/>
         </p:nvSpPr>
@@ -16172,7 +13536,7 @@
       </p:sp>
       <p:sp>
         <p:nvSpPr>
-          <p:cNvPr id="16" name="Oval 15"/>
+          <p:cNvPr id="15" name="Oval 14"/>
           <p:cNvSpPr/>
           <p:nvPr/>
         </p:nvSpPr>
@@ -16217,7 +13581,7 @@
       </p:sp>
       <p:sp>
         <p:nvSpPr>
-          <p:cNvPr id="17" name="Oval 16"/>
+          <p:cNvPr id="16" name="Oval 15"/>
           <p:cNvSpPr/>
           <p:nvPr/>
         </p:nvSpPr>
@@ -16262,7 +13626,7 @@
       </p:sp>
       <p:sp>
         <p:nvSpPr>
-          <p:cNvPr id="18" name="Oval 17"/>
+          <p:cNvPr id="17" name="Oval 16"/>
           <p:cNvSpPr/>
           <p:nvPr/>
         </p:nvSpPr>
@@ -16307,7 +13671,7 @@
       </p:sp>
       <p:sp>
         <p:nvSpPr>
-          <p:cNvPr id="19" name="Oval 18"/>
+          <p:cNvPr id="18" name="Oval 17"/>
           <p:cNvSpPr/>
           <p:nvPr/>
         </p:nvSpPr>
@@ -16352,7 +13716,7 @@
       </p:sp>
       <p:sp>
         <p:nvSpPr>
-          <p:cNvPr id="20" name="Oval 19"/>
+          <p:cNvPr id="19" name="Oval 18"/>
           <p:cNvSpPr/>
           <p:nvPr/>
         </p:nvSpPr>
@@ -16397,7 +13761,7 @@
       </p:sp>
       <p:sp>
         <p:nvSpPr>
-          <p:cNvPr id="21" name="Oval 20"/>
+          <p:cNvPr id="20" name="Oval 19"/>
           <p:cNvSpPr/>
           <p:nvPr/>
         </p:nvSpPr>
@@ -16442,7 +13806,7 @@
       </p:sp>
       <p:sp>
         <p:nvSpPr>
-          <p:cNvPr id="22" name="Oval 21"/>
+          <p:cNvPr id="21" name="Oval 20"/>
           <p:cNvSpPr/>
           <p:nvPr/>
         </p:nvSpPr>
@@ -16487,7 +13851,7 @@
       </p:sp>
       <p:sp>
         <p:nvSpPr>
-          <p:cNvPr id="23" name="Oval 22"/>
+          <p:cNvPr id="22" name="Oval 21"/>
           <p:cNvSpPr/>
           <p:nvPr/>
         </p:nvSpPr>
@@ -16532,7 +13896,7 @@
       </p:sp>
       <p:sp>
         <p:nvSpPr>
-          <p:cNvPr id="24" name="Oval 23"/>
+          <p:cNvPr id="23" name="Oval 22"/>
           <p:cNvSpPr/>
           <p:nvPr/>
         </p:nvSpPr>
@@ -16577,7 +13941,7 @@
       </p:sp>
       <p:sp>
         <p:nvSpPr>
-          <p:cNvPr id="25" name="Oval 24"/>
+          <p:cNvPr id="24" name="Oval 23"/>
           <p:cNvSpPr/>
           <p:nvPr/>
         </p:nvSpPr>
@@ -16622,7 +13986,7 @@
       </p:sp>
       <p:sp>
         <p:nvSpPr>
-          <p:cNvPr id="26" name="Oval 25"/>
+          <p:cNvPr id="25" name="Oval 24"/>
           <p:cNvSpPr/>
           <p:nvPr/>
         </p:nvSpPr>
@@ -16667,7 +14031,7 @@
       </p:sp>
       <p:sp>
         <p:nvSpPr>
-          <p:cNvPr id="27" name="Oval 26"/>
+          <p:cNvPr id="26" name="Oval 25"/>
           <p:cNvSpPr/>
           <p:nvPr/>
         </p:nvSpPr>
@@ -16712,7 +14076,7 @@
       </p:sp>
       <p:sp>
         <p:nvSpPr>
-          <p:cNvPr id="28" name="Oval 27"/>
+          <p:cNvPr id="27" name="Oval 26"/>
           <p:cNvSpPr/>
           <p:nvPr/>
         </p:nvSpPr>
@@ -16757,7 +14121,7 @@
       </p:sp>
       <p:sp>
         <p:nvSpPr>
-          <p:cNvPr id="29" name="Oval 28"/>
+          <p:cNvPr id="28" name="Oval 27"/>
           <p:cNvSpPr/>
           <p:nvPr/>
         </p:nvSpPr>
@@ -16802,7 +14166,7 @@
       </p:sp>
       <p:sp>
         <p:nvSpPr>
-          <p:cNvPr id="30" name="Oval 29"/>
+          <p:cNvPr id="29" name="Oval 28"/>
           <p:cNvSpPr/>
           <p:nvPr/>
         </p:nvSpPr>
@@ -16847,7 +14211,7 @@
       </p:sp>
       <p:sp>
         <p:nvSpPr>
-          <p:cNvPr id="31" name="Oval 30"/>
+          <p:cNvPr id="30" name="Oval 29"/>
           <p:cNvSpPr/>
           <p:nvPr/>
         </p:nvSpPr>
@@ -16892,7 +14256,7 @@
       </p:sp>
       <p:sp>
         <p:nvSpPr>
-          <p:cNvPr id="32" name="Oval 31"/>
+          <p:cNvPr id="31" name="Oval 30"/>
           <p:cNvSpPr/>
           <p:nvPr/>
         </p:nvSpPr>
@@ -16937,7 +14301,7 @@
       </p:sp>
       <p:sp>
         <p:nvSpPr>
-          <p:cNvPr id="33" name="Oval 32"/>
+          <p:cNvPr id="32" name="Oval 31"/>
           <p:cNvSpPr/>
           <p:nvPr/>
         </p:nvSpPr>
@@ -16982,7 +14346,7 @@
       </p:sp>
       <p:sp>
         <p:nvSpPr>
-          <p:cNvPr id="34" name="Oval 33"/>
+          <p:cNvPr id="33" name="Oval 32"/>
           <p:cNvSpPr/>
           <p:nvPr/>
         </p:nvSpPr>
@@ -17027,7 +14391,7 @@
       </p:sp>
       <p:sp>
         <p:nvSpPr>
-          <p:cNvPr id="35" name="Oval 34"/>
+          <p:cNvPr id="34" name="Oval 33"/>
           <p:cNvSpPr/>
           <p:nvPr/>
         </p:nvSpPr>
@@ -17072,7 +14436,7 @@
       </p:sp>
       <p:sp>
         <p:nvSpPr>
-          <p:cNvPr id="36" name="TextBox 35"/>
+          <p:cNvPr id="35" name="TextBox 34"/>
           <p:cNvSpPr txBox="1"/>
           <p:nvPr/>
         </p:nvSpPr>
@@ -17111,7 +14475,7 @@
       </p:sp>
       <p:sp>
         <p:nvSpPr>
-          <p:cNvPr id="37" name="TextBox 36"/>
+          <p:cNvPr id="36" name="TextBox 35"/>
           <p:cNvSpPr txBox="1"/>
           <p:nvPr/>
         </p:nvSpPr>
@@ -17166,7 +14530,7 @@
       </p:sp>
       <p:sp>
         <p:nvSpPr>
-          <p:cNvPr id="38" name="Oval 37"/>
+          <p:cNvPr id="37" name="Oval 36"/>
           <p:cNvSpPr/>
           <p:nvPr/>
         </p:nvSpPr>
@@ -17211,7 +14575,7 @@
       </p:sp>
       <p:sp>
         <p:nvSpPr>
-          <p:cNvPr id="39" name="TextBox 38"/>
+          <p:cNvPr id="38" name="TextBox 37"/>
           <p:cNvSpPr txBox="1"/>
           <p:nvPr/>
         </p:nvSpPr>
@@ -17250,7 +14614,7 @@
       </p:sp>
       <p:cxnSp>
         <p:nvCxnSpPr>
-          <p:cNvPr id="40" name="Connector 39"/>
+          <p:cNvPr id="39" name="Connector 38"/>
           <p:cNvCxnSpPr/>
           <p:nvPr/>
         </p:nvCxnSpPr>
@@ -17285,7 +14649,7 @@
       </p:cxnSp>
       <p:sp>
         <p:nvSpPr>
-          <p:cNvPr id="41" name="TextBox 40"/>
+          <p:cNvPr id="40" name="TextBox 39"/>
           <p:cNvSpPr txBox="1"/>
           <p:nvPr/>
         </p:nvSpPr>
@@ -17322,81 +14686,6 @@
           </a:p>
         </p:txBody>
       </p:sp>
-      <p:cxnSp>
-        <p:nvCxnSpPr>
-          <p:cNvPr id="42" name="Connector 41"/>
-          <p:cNvCxnSpPr/>
-          <p:nvPr/>
-        </p:nvCxnSpPr>
-        <p:spPr>
-          <a:xfrm>
-            <a:off x="6400800" y="5989320"/>
-            <a:ext cx="256032" cy="0"/>
-          </a:xfrm>
-          <a:prstGeom prst="line">
-            <a:avLst/>
-          </a:prstGeom>
-          <a:ln w="25400">
-            <a:solidFill>
-              <a:srgbClr val="7963AF"/>
-            </a:solidFill>
-            <a:prstDash val="dash"/>
-          </a:ln>
-        </p:spPr>
-        <p:style>
-          <a:lnRef idx="2">
-            <a:schemeClr val="accent1"/>
-          </a:lnRef>
-          <a:fillRef idx="0">
-            <a:schemeClr val="accent1"/>
-          </a:fillRef>
-          <a:effectRef idx="0">
-            <a:schemeClr val="accent1"/>
-          </a:effectRef>
-          <a:fontRef idx="minor">
-            <a:schemeClr val="tx1"/>
-          </a:fontRef>
-        </p:style>
-      </p:cxnSp>
-      <p:sp>
-        <p:nvSpPr>
-          <p:cNvPr id="43" name="TextBox 42"/>
-          <p:cNvSpPr txBox="1"/>
-          <p:nvPr/>
-        </p:nvSpPr>
-        <p:spPr>
-          <a:xfrm>
-            <a:off x="6757416" y="5870448"/>
-            <a:ext cx="2468880" cy="320040"/>
-          </a:xfrm>
-          <a:prstGeom prst="rect">
-            <a:avLst/>
-          </a:prstGeom>
-          <a:noFill/>
-        </p:spPr>
-        <p:txBody>
-          <a:bodyPr wrap="square" lIns="0" rIns="0" tIns="0" bIns="0">
-            <a:spAutoFit/>
-          </a:bodyPr>
-          <a:lstStyle/>
-          <a:p>
-            <a:pPr>
-              <a:spcAft>
-                <a:spcPts val="0"/>
-              </a:spcAft>
-              <a:defRPr sz="1300" b="0">
-                <a:solidFill>
-                  <a:srgbClr val="686C66"/>
-                </a:solidFill>
-                <a:latin typeface="Arial"/>
-              </a:defRPr>
-            </a:pPr>
-            <a:r>
-              <a:t>true pattern</a:t>
-            </a:r>
-          </a:p>
-        </p:txBody>
-      </p:sp>
     </p:spTree>
   </p:cSld>
   <p:clrMapOvr>
@@ -17423,9 +14712,33 @@
         <p:nvPr/>
       </p:nvGrpSpPr>
       <p:grpSpPr/>
+      <p:pic>
+        <p:nvPicPr>
+          <p:cNvPr id="2" name="Picture 1" descr="image.png"/>
+          <p:cNvPicPr>
+            <a:picLocks noChangeAspect="1"/>
+          </p:cNvPicPr>
+          <p:nvPr/>
+        </p:nvPicPr>
+        <p:blipFill>
+          <a:blip r:embed="rId2"/>
+          <a:stretch>
+            <a:fillRect/>
+          </a:stretch>
+        </p:blipFill>
+        <p:spPr>
+          <a:xfrm>
+            <a:off x="11768328" y="201168"/>
+            <a:ext cx="219456" cy="6455664"/>
+          </a:xfrm>
+          <a:prstGeom prst="rect">
+            <a:avLst/>
+          </a:prstGeom>
+        </p:spPr>
+      </p:pic>
       <p:sp>
         <p:nvSpPr>
-          <p:cNvPr id="2" name="TextBox 1"/>
+          <p:cNvPr id="3" name="TextBox 2"/>
           <p:cNvSpPr txBox="1"/>
           <p:nvPr/>
         </p:nvSpPr>
@@ -17462,41 +14775,6 @@
           </a:p>
         </p:txBody>
       </p:sp>
-      <p:cxnSp>
-        <p:nvCxnSpPr>
-          <p:cNvPr id="3" name="Connector 2"/>
-          <p:cNvCxnSpPr/>
-          <p:nvPr/>
-        </p:nvCxnSpPr>
-        <p:spPr>
-          <a:xfrm>
-            <a:off x="594360" y="6419088"/>
-            <a:ext cx="10972800" cy="0"/>
-          </a:xfrm>
-          <a:prstGeom prst="line">
-            <a:avLst/>
-          </a:prstGeom>
-          <a:ln w="12700">
-            <a:solidFill>
-              <a:srgbClr val="D4D6D0"/>
-            </a:solidFill>
-          </a:ln>
-        </p:spPr>
-        <p:style>
-          <a:lnRef idx="2">
-            <a:schemeClr val="accent1"/>
-          </a:lnRef>
-          <a:fillRef idx="0">
-            <a:schemeClr val="accent1"/>
-          </a:fillRef>
-          <a:effectRef idx="0">
-            <a:schemeClr val="accent1"/>
-          </a:effectRef>
-          <a:fontRef idx="minor">
-            <a:schemeClr val="tx1"/>
-          </a:fontRef>
-        </p:style>
-      </p:cxnSp>
       <p:sp>
         <p:nvSpPr>
           <p:cNvPr id="4" name="TextBox 3"/>
@@ -52067,9 +49345,33 @@
         <p:nvPr/>
       </p:nvGrpSpPr>
       <p:grpSpPr/>
+      <p:pic>
+        <p:nvPicPr>
+          <p:cNvPr id="2" name="Picture 1" descr="image.png"/>
+          <p:cNvPicPr>
+            <a:picLocks noChangeAspect="1"/>
+          </p:cNvPicPr>
+          <p:nvPr/>
+        </p:nvPicPr>
+        <p:blipFill>
+          <a:blip r:embed="rId2"/>
+          <a:stretch>
+            <a:fillRect/>
+          </a:stretch>
+        </p:blipFill>
+        <p:spPr>
+          <a:xfrm>
+            <a:off x="11768328" y="201168"/>
+            <a:ext cx="219456" cy="6455664"/>
+          </a:xfrm>
+          <a:prstGeom prst="rect">
+            <a:avLst/>
+          </a:prstGeom>
+        </p:spPr>
+      </p:pic>
       <p:sp>
         <p:nvSpPr>
-          <p:cNvPr id="2" name="TextBox 1"/>
+          <p:cNvPr id="3" name="TextBox 2"/>
           <p:cNvSpPr txBox="1"/>
           <p:nvPr/>
         </p:nvSpPr>
@@ -52106,41 +49408,6 @@
           </a:p>
         </p:txBody>
       </p:sp>
-      <p:cxnSp>
-        <p:nvCxnSpPr>
-          <p:cNvPr id="3" name="Connector 2"/>
-          <p:cNvCxnSpPr/>
-          <p:nvPr/>
-        </p:nvCxnSpPr>
-        <p:spPr>
-          <a:xfrm>
-            <a:off x="594360" y="6419088"/>
-            <a:ext cx="10972800" cy="0"/>
-          </a:xfrm>
-          <a:prstGeom prst="line">
-            <a:avLst/>
-          </a:prstGeom>
-          <a:ln w="12700">
-            <a:solidFill>
-              <a:srgbClr val="D4D6D0"/>
-            </a:solidFill>
-          </a:ln>
-        </p:spPr>
-        <p:style>
-          <a:lnRef idx="2">
-            <a:schemeClr val="accent1"/>
-          </a:lnRef>
-          <a:fillRef idx="0">
-            <a:schemeClr val="accent1"/>
-          </a:fillRef>
-          <a:effectRef idx="0">
-            <a:schemeClr val="accent1"/>
-          </a:effectRef>
-          <a:fontRef idx="minor">
-            <a:schemeClr val="tx1"/>
-          </a:fontRef>
-        </p:style>
-      </p:cxnSp>
       <p:sp>
         <p:nvSpPr>
           <p:cNvPr id="4" name="TextBox 3"/>
@@ -54210,9 +51477,33 @@
         <p:nvPr/>
       </p:nvGrpSpPr>
       <p:grpSpPr/>
+      <p:pic>
+        <p:nvPicPr>
+          <p:cNvPr id="2" name="Picture 1" descr="image.png"/>
+          <p:cNvPicPr>
+            <a:picLocks noChangeAspect="1"/>
+          </p:cNvPicPr>
+          <p:nvPr/>
+        </p:nvPicPr>
+        <p:blipFill>
+          <a:blip r:embed="rId2"/>
+          <a:stretch>
+            <a:fillRect/>
+          </a:stretch>
+        </p:blipFill>
+        <p:spPr>
+          <a:xfrm>
+            <a:off x="11768328" y="201168"/>
+            <a:ext cx="219456" cy="6455664"/>
+          </a:xfrm>
+          <a:prstGeom prst="rect">
+            <a:avLst/>
+          </a:prstGeom>
+        </p:spPr>
+      </p:pic>
       <p:sp>
         <p:nvSpPr>
-          <p:cNvPr id="2" name="TextBox 1"/>
+          <p:cNvPr id="3" name="TextBox 2"/>
           <p:cNvSpPr txBox="1"/>
           <p:nvPr/>
         </p:nvSpPr>
@@ -54249,41 +51540,6 @@
           </a:p>
         </p:txBody>
       </p:sp>
-      <p:cxnSp>
-        <p:nvCxnSpPr>
-          <p:cNvPr id="3" name="Connector 2"/>
-          <p:cNvCxnSpPr/>
-          <p:nvPr/>
-        </p:nvCxnSpPr>
-        <p:spPr>
-          <a:xfrm>
-            <a:off x="594360" y="6419088"/>
-            <a:ext cx="10972800" cy="0"/>
-          </a:xfrm>
-          <a:prstGeom prst="line">
-            <a:avLst/>
-          </a:prstGeom>
-          <a:ln w="12700">
-            <a:solidFill>
-              <a:srgbClr val="D4D6D0"/>
-            </a:solidFill>
-          </a:ln>
-        </p:spPr>
-        <p:style>
-          <a:lnRef idx="2">
-            <a:schemeClr val="accent1"/>
-          </a:lnRef>
-          <a:fillRef idx="0">
-            <a:schemeClr val="accent1"/>
-          </a:fillRef>
-          <a:effectRef idx="0">
-            <a:schemeClr val="accent1"/>
-          </a:effectRef>
-          <a:fontRef idx="minor">
-            <a:schemeClr val="tx1"/>
-          </a:fontRef>
-        </p:style>
-      </p:cxnSp>
       <p:sp>
         <p:nvSpPr>
           <p:cNvPr id="4" name="TextBox 3"/>
@@ -55072,44 +52328,9 @@
           </a:p>
         </p:txBody>
       </p:sp>
-      <p:cxnSp>
-        <p:nvCxnSpPr>
-          <p:cNvPr id="4" name="Connector 3"/>
-          <p:cNvCxnSpPr/>
-          <p:nvPr/>
-        </p:nvCxnSpPr>
-        <p:spPr>
-          <a:xfrm>
-            <a:off x="594360" y="6419088"/>
-            <a:ext cx="10972800" cy="0"/>
-          </a:xfrm>
-          <a:prstGeom prst="line">
-            <a:avLst/>
-          </a:prstGeom>
-          <a:ln w="12700">
-            <a:solidFill>
-              <a:srgbClr val="D4D6D0"/>
-            </a:solidFill>
-          </a:ln>
-        </p:spPr>
-        <p:style>
-          <a:lnRef idx="2">
-            <a:schemeClr val="accent1"/>
-          </a:lnRef>
-          <a:fillRef idx="0">
-            <a:schemeClr val="accent1"/>
-          </a:fillRef>
-          <a:effectRef idx="0">
-            <a:schemeClr val="accent1"/>
-          </a:effectRef>
-          <a:fontRef idx="minor">
-            <a:schemeClr val="tx1"/>
-          </a:fontRef>
-        </p:style>
-      </p:cxnSp>
       <p:sp>
         <p:nvSpPr>
-          <p:cNvPr id="5" name="TextBox 4"/>
+          <p:cNvPr id="4" name="TextBox 3"/>
           <p:cNvSpPr txBox="1"/>
           <p:nvPr/>
         </p:nvSpPr>
@@ -55148,7 +52369,7 @@
       </p:sp>
       <p:cxnSp>
         <p:nvCxnSpPr>
-          <p:cNvPr id="6" name="Connector 5"/>
+          <p:cNvPr id="5" name="Connector 4"/>
           <p:cNvCxnSpPr/>
           <p:nvPr/>
         </p:nvCxnSpPr>
@@ -55183,7 +52404,7 @@
       </p:cxnSp>
       <p:sp>
         <p:nvSpPr>
-          <p:cNvPr id="7" name="TextBox 6"/>
+          <p:cNvPr id="6" name="TextBox 5"/>
           <p:cNvSpPr txBox="1"/>
           <p:nvPr/>
         </p:nvSpPr>
@@ -55222,7 +52443,7 @@
       </p:sp>
       <p:sp>
         <p:nvSpPr>
-          <p:cNvPr id="8" name="TextBox 7"/>
+          <p:cNvPr id="7" name="TextBox 6"/>
           <p:cNvSpPr txBox="1"/>
           <p:nvPr/>
         </p:nvSpPr>
@@ -55277,7 +52498,7 @@
       </p:sp>
       <p:cxnSp>
         <p:nvCxnSpPr>
-          <p:cNvPr id="9" name="Connector 8"/>
+          <p:cNvPr id="8" name="Connector 7"/>
           <p:cNvCxnSpPr/>
           <p:nvPr/>
         </p:nvCxnSpPr>
@@ -55312,7 +52533,7 @@
       </p:cxnSp>
       <p:sp>
         <p:nvSpPr>
-          <p:cNvPr id="10" name="TextBox 9"/>
+          <p:cNvPr id="9" name="TextBox 8"/>
           <p:cNvSpPr txBox="1"/>
           <p:nvPr/>
         </p:nvSpPr>
@@ -55351,7 +52572,7 @@
       </p:sp>
       <p:sp>
         <p:nvSpPr>
-          <p:cNvPr id="11" name="TextBox 10"/>
+          <p:cNvPr id="10" name="TextBox 9"/>
           <p:cNvSpPr txBox="1"/>
           <p:nvPr/>
         </p:nvSpPr>
@@ -55406,7 +52627,7 @@
       </p:sp>
       <p:cxnSp>
         <p:nvCxnSpPr>
-          <p:cNvPr id="12" name="Connector 11"/>
+          <p:cNvPr id="11" name="Connector 10"/>
           <p:cNvCxnSpPr/>
           <p:nvPr/>
         </p:nvCxnSpPr>
@@ -55441,7 +52662,7 @@
       </p:cxnSp>
       <p:sp>
         <p:nvSpPr>
-          <p:cNvPr id="13" name="TextBox 12"/>
+          <p:cNvPr id="12" name="TextBox 11"/>
           <p:cNvSpPr txBox="1"/>
           <p:nvPr/>
         </p:nvSpPr>
@@ -55480,7 +52701,7 @@
       </p:sp>
       <p:sp>
         <p:nvSpPr>
-          <p:cNvPr id="14" name="TextBox 13"/>
+          <p:cNvPr id="13" name="TextBox 12"/>
           <p:cNvSpPr txBox="1"/>
           <p:nvPr/>
         </p:nvSpPr>
@@ -55535,7 +52756,7 @@
       </p:sp>
       <p:sp>
         <p:nvSpPr>
-          <p:cNvPr id="15" name="TextBox 14"/>
+          <p:cNvPr id="14" name="TextBox 13"/>
           <p:cNvSpPr txBox="1"/>
           <p:nvPr/>
         </p:nvSpPr>

</xml_diff>

<commit_message>
docs(cmpsc-448): clarify slide titles
</commit_message>
<xml_diff>
--- a/cmpsc-448/presentation/bias-variance-tradeoff.pptx
+++ b/cmpsc-448/presentation/bias-variance-tradeoff.pptx
@@ -4000,7 +4000,7 @@
               </a:defRPr>
             </a:pPr>
             <a:r>
-              <a:t>Same problem. Different training samples.</a:t>
+              <a:t>New data, same underlying pattern</a:t>
             </a:r>
           </a:p>
         </p:txBody>
@@ -6386,7 +6386,7 @@
               </a:defRPr>
             </a:pPr>
             <a:r>
-              <a:t>Train again. Does the prediction change?</a:t>
+              <a:t>Different training data changes the model</a:t>
             </a:r>
           </a:p>
         </p:txBody>
@@ -11588,7 +11588,7 @@
               </a:defRPr>
             </a:pPr>
             <a:r>
-              <a:t>Variance is sensitivity to the sample.</a:t>
+              <a:t>High variance: predictions change a lot</a:t>
             </a:r>
           </a:p>
         </p:txBody>
@@ -34771,7 +34771,7 @@
               </a:defRPr>
             </a:pPr>
             <a:r>
-              <a:t>Consistency is not enough.</a:t>
+              <a:t>High bias: predictions are consistently off</a:t>
             </a:r>
           </a:p>
         </p:txBody>
@@ -48000,7 +48000,7 @@
               </a:defRPr>
             </a:pPr>
             <a:r>
-              <a:t>Close to the truth. Stable across samples.</a:t>
+              <a:t>A good model stays close to the truth</a:t>
             </a:r>
           </a:p>
         </p:txBody>
@@ -61062,7 +61062,7 @@
               </a:defRPr>
             </a:pPr>
             <a:r>
-              <a:t>Three sources of prediction error.</a:t>
+              <a:t>Even good models make errors</a:t>
             </a:r>
           </a:p>
         </p:txBody>
@@ -61736,7 +61736,7 @@
               </a:defRPr>
             </a:pPr>
             <a:r>
-              <a:t>Learn accurately. Predict consistently.</a:t>
+              <a:t>We want accurate, stable predictions</a:t>
             </a:r>
           </a:p>
         </p:txBody>

</xml_diff>

<commit_message>
docs(cmpsc-448): remove opening scatterplot slide
</commit_message>
<xml_diff>
--- a/cmpsc-448/presentation/bias-variance-tradeoff.pptx
+++ b/cmpsc-448/presentation/bias-variance-tradeoff.pptx
@@ -11,7 +11,6 @@
     <p:sldId id="259" r:id="rId11"/>
     <p:sldId id="260" r:id="rId12"/>
     <p:sldId id="261" r:id="rId13"/>
-    <p:sldId id="262" r:id="rId14"/>
   </p:sldIdLst>
   <p:sldSz cx="12191999" cy="6858000" type="screen4x3"/>
   <p:notesSz cx="6858000" cy="9144000"/>
@@ -508,7 +507,7 @@
           <a:lstStyle/>
           <a:p>
             <a:r>
-              <a:t>Open with a question: If we collected our training data again, would we get exactly the same observations? Both panels use the same 20 x positions and the same underlying relationship, y = 0.3 + 0.4x + 1.3x² + noise. Only the independent Gaussian output noise changes, with standard deviation 0.4. Sample A is the original fixed-seed dataset; sample B is another draw. This is a controlled thought experiment, not train versus test and not distribution shift. We have not fitted a model yet. The other presentation explains underfitting and overfitting; our focus is what changes across training samples and why it matters for prediction.</a:t>
+              <a:t>Samples A and B come from the same quadratic relationship at the same 20 x positions, with independent Gaussian output noise of standard deviation 0.4. These are two training samples, not training versus test data. Fit the same degree-12 polynomial procedure separately to each. Keep the inputs, model family, and fitting method fixed. At x = 0.5, A predicts 0.96 and B predicts 0.40. The vertical guides mark that identical input. The orange dots are model predictions, not additional observations. Retraining changed the prediction even though the underlying problem did not change. Two samples illustrate the idea; they do not estimate population variance reliably. We now repeat the experiment eight times.</a:t>
             </a:r>
           </a:p>
         </p:txBody>
@@ -578,7 +577,7 @@
           <a:lstStyle/>
           <a:p>
             <a:r>
-              <a:t>Use the exact same samples A and B from slide 1, and fit the same degree-12 polynomial procedure separately to each. Keep the inputs, model family, and fitting method fixed. At x = 0.5, A predicts 0.96 and B predicts 0.40. The vertical guides mark that identical input. The orange dots are model predictions, not additional observations. Retraining changed the prediction even though the underlying problem did not change. Two samples illustrate the idea; they do not estimate population variance reliably. We now repeat the experiment eight times.</a:t>
+              <a:t>Each pale curve is a model fitted to one of eight training samples, including A and B. Every degree sees exactly the same eight samples. The orange curve is the pointwise arithmetic average of those eight predictions, not a ninth fit and not the true relationship. At any fixed input, variance describes the spread of predictions around their average across training samples. The degree-12 procedure is more sensitive here; the degree-2 procedure is more stable. Wiggliness by itself is not the definition of variance, and variance is not the scatter of the raw data. Eight curves are a teaching illustration, not a precise population estimate. Axis limits are identical; curve portions outside the visible range are omitted. Flexibility need not produce high variance in every setting; sample size and regularization also matter.</a:t>
             </a:r>
           </a:p>
         </p:txBody>
@@ -648,7 +647,7 @@
           <a:lstStyle/>
           <a:p>
             <a:r>
-              <a:t>Each pale curve is a model fitted to one of eight training samples, including A and B. Every degree sees exactly the same eight samples. The orange curve is the pointwise arithmetic average of those eight predictions, not a ninth fit and not the true relationship. At any fixed input, variance describes the spread of predictions around their average across training samples. The degree-12 procedure is more sensitive here; the degree-2 procedure is more stable. Wiggliness by itself is not the definition of variance, and variance is not the scatter of the raw data. Eight curves are a teaching illustration, not a precise population estimate. Axis limits are identical; curve portions outside the visible range are omitted. Flexibility need not produce high variance in every setting; sample size and regularization also matter.</a:t>
+              <a:t>Now reveal the true regression function, shown as the dashed curve. We know it because this is synthetic data; it is usually unknown in practice. These are degree-1 fits to the same eight samples. They cluster, yet their average misses the curved relationship. At x = 0 the average shown predicts 0.79, while the true mean output is 0.30; the vertical segment marks that gap. Bias at a fixed input is the expected model prediction over training samples minus the true regression function at that input. The displayed eight-fit average is only a finite-sample approximation to that expectation. Bias is not a single model's residual against one noisy observation. Low variance does not guarantee low bias. A straight-line family is too restrictive for this quadratic relationship, connecting briefly to the other student's underfitting example.</a:t>
             </a:r>
           </a:p>
         </p:txBody>
@@ -718,7 +717,7 @@
           <a:lstStyle/>
           <a:p>
             <a:r>
-              <a:t>Now reveal the true regression function, shown as the dashed curve. We know it because this is synthetic data; it is usually unknown in practice. These are degree-1 fits to the same eight samples. They cluster, yet their average misses the curved relationship. At x = 0 the average shown predicts 0.79, while the true mean output is 0.30; the vertical segment marks that gap. Bias at a fixed input is the expected model prediction over training samples minus the true regression function at that input. The displayed eight-fit average is only a finite-sample approximation to that expectation. Bias is not a single model's residual against one noisy observation. Low variance does not guarantee low bias. A straight-line family is too restrictive for this quadratic relationship, connecting briefly to the other student's underfitting example.</a:t>
+              <a:t>Return to the degree-2 fits from slide 2, now with the true pattern revealed. All data, noise levels, and axes remain unchanged. Their average is close to the true relationship, unlike the degree-1 average; their spread is smaller than the degree-12 spread. Low bias and low variance are relative descriptions for this controlled example, not claims of zero prediction error. Because the quadratic family contains the true function and noise has mean zero, fixed-design least squares is unbiased here in expectation. The eight-fit average need not equal truth exactly. Increasing flexibility from a line to a quadratic reduces systematic error; increasing it further can add sensitivity without useful signal. That is the tradeoff, not a universal requirement that bias and variance must always move in opposite directions.</a:t>
             </a:r>
           </a:p>
         </p:txBody>
@@ -788,7 +787,7 @@
           <a:lstStyle/>
           <a:p>
             <a:r>
-              <a:t>Return to the degree-2 fits from slide 3, now with the true pattern revealed. All data, noise levels, and axes remain unchanged. Their average is close to the true relationship, unlike the degree-1 average; their spread is smaller than the degree-12 spread. Low bias and low variance are relative descriptions for this controlled example, not claims of zero prediction error. Because the quadratic family contains the true function and noise has mean zero, fixed-design least squares is unbiased here in expectation. The eight-fit average need not equal truth exactly. Increasing flexibility from a line to a quadratic reduces systematic error; increasing it further can add sensitivity without useful signal. That is the tradeoff, not a universal requirement that bias and variance must always move in opposite directions.</a:t>
+              <a:t>This equality is the squared-error decomposition at a fixed input x: E[(f_hat_D(x) - Y_new)²] = (E_D[f_hat_D(x)] - f(x))² + Var_D[f_hat_D(x)] + Var(Y_new | x). Average over random training datasets D and independent fresh output noise, with Y_new = f(x) + epsilon and E[epsilon | x] = 0. The noise term is conditional variance, not standard deviation; here it is 0.4² = 0.16. Even a predictor equal to the true mean function cannot predict the random noise in a fresh observation. The decomposition is not a formula for one observed residual or one training loss, and is not generally valid in this form for classification error or every loss function. Noise is irreducible relative to the information available to the model; better measurements or extra informative features can change that information. The build checks the finite-ensemble squared-error identity numerically. Do not imply the displayed eight curves are the full population expectation.</a:t>
             </a:r>
           </a:p>
         </p:txBody>
@@ -814,76 +813,6 @@
 </file>
 
 <file path=ppt/notesSlides/notesSlide6.xml><?xml version="1.0" encoding="utf-8"?>
-<p:notes xmlns:a="http://schemas.openxmlformats.org/drawingml/2006/main" xmlns:p="http://schemas.openxmlformats.org/presentationml/2006/main" xmlns:r="http://schemas.openxmlformats.org/officeDocument/2006/relationships">
-  <p:cSld>
-    <p:spTree>
-      <p:nvGrpSpPr>
-        <p:cNvPr id="1" name=""/>
-        <p:cNvGrpSpPr/>
-        <p:nvPr/>
-      </p:nvGrpSpPr>
-      <p:grpSpPr>
-        <a:xfrm>
-          <a:off x="0" y="0"/>
-          <a:ext cx="0" cy="0"/>
-          <a:chOff x="0" y="0"/>
-          <a:chExt cx="0" cy="0"/>
-        </a:xfrm>
-      </p:grpSpPr>
-      <p:sp>
-        <p:nvSpPr>
-          <p:cNvPr id="2" name="Slide Image Placeholder 1"/>
-          <p:cNvSpPr>
-            <a:spLocks noGrp="1"/>
-          </p:cNvSpPr>
-          <p:nvPr>
-            <p:ph type="sldImg" idx="2"/>
-          </p:nvPr>
-        </p:nvSpPr>
-        <p:spPr/>
-      </p:sp>
-      <p:sp>
-        <p:nvSpPr>
-          <p:cNvPr id="3" name="Notes Placeholder 2"/>
-          <p:cNvSpPr>
-            <a:spLocks noGrp="1"/>
-          </p:cNvSpPr>
-          <p:nvPr>
-            <p:ph type="body" idx="3" sz="quarter"/>
-          </p:nvPr>
-        </p:nvSpPr>
-        <p:spPr/>
-        <p:txBody>
-          <a:bodyPr/>
-          <a:lstStyle/>
-          <a:p>
-            <a:r>
-              <a:t>This equality is the squared-error decomposition at a fixed input x: E[(f_hat_D(x) - Y_new)²] = (E_D[f_hat_D(x)] - f(x))² + Var_D[f_hat_D(x)] + Var(Y_new | x). Average over random training datasets D and independent fresh output noise, with Y_new = f(x) + epsilon and E[epsilon | x] = 0. The noise term is conditional variance, not standard deviation; here it is 0.4² = 0.16. Even a predictor equal to the true mean function cannot predict the random noise in a fresh observation. The decomposition is not a formula for one observed residual or one training loss, and is not generally valid in this form for classification error or every loss function. Noise is irreducible relative to the information available to the model; better measurements or extra informative features can change that information. The build checks the finite-ensemble squared-error identity numerically. Do not imply the displayed eight curves are the full population expectation.</a:t>
-            </a:r>
-          </a:p>
-        </p:txBody>
-      </p:sp>
-      <p:sp>
-        <p:nvSpPr>
-          <p:cNvPr id="4" name="Slide Number Placeholder 3"/>
-          <p:cNvSpPr>
-            <a:spLocks noGrp="1"/>
-          </p:cNvSpPr>
-          <p:nvPr>
-            <p:ph type="sldNum" idx="5" sz="quarter"/>
-          </p:nvPr>
-        </p:nvSpPr>
-        <p:spPr/>
-      </p:sp>
-    </p:spTree>
-  </p:cSld>
-  <p:clrMapOvr>
-    <a:masterClrMapping/>
-  </p:clrMapOvr>
-</p:notes>
-</file>
-
-<file path=ppt/notesSlides/notesSlide7.xml><?xml version="1.0" encoding="utf-8"?>
 <p:notes xmlns:a="http://schemas.openxmlformats.org/drawingml/2006/main" xmlns:p="http://schemas.openxmlformats.org/presentationml/2006/main" xmlns:r="http://schemas.openxmlformats.org/officeDocument/2006/relationships">
   <p:cSld>
     <p:spTree>
@@ -4000,2392 +3929,6 @@
               </a:defRPr>
             </a:pPr>
             <a:r>
-              <a:t>New data, same underlying pattern</a:t>
-            </a:r>
-          </a:p>
-        </p:txBody>
-      </p:sp>
-      <p:sp>
-        <p:nvSpPr>
-          <p:cNvPr id="4" name="TextBox 3"/>
-          <p:cNvSpPr txBox="1"/>
-          <p:nvPr/>
-        </p:nvSpPr>
-        <p:spPr>
-          <a:xfrm>
-            <a:off x="10917936" y="6510528"/>
-            <a:ext cx="685800" cy="201168"/>
-          </a:xfrm>
-          <a:prstGeom prst="rect">
-            <a:avLst/>
-          </a:prstGeom>
-          <a:noFill/>
-        </p:spPr>
-        <p:txBody>
-          <a:bodyPr wrap="square" lIns="0" rIns="0" tIns="0" bIns="0">
-            <a:spAutoFit/>
-          </a:bodyPr>
-          <a:lstStyle/>
-          <a:p>
-            <a:pPr>
-              <a:spcAft>
-                <a:spcPts val="0"/>
-              </a:spcAft>
-              <a:defRPr sz="1100" b="0">
-                <a:solidFill>
-                  <a:srgbClr val="686C66"/>
-                </a:solidFill>
-                <a:latin typeface="Arial"/>
-              </a:defRPr>
-            </a:pPr>
-            <a:r>
-              <a:t>01/07</a:t>
-            </a:r>
-          </a:p>
-        </p:txBody>
-      </p:sp>
-      <p:sp>
-        <p:nvSpPr>
-          <p:cNvPr id="5" name="TextBox 4"/>
-          <p:cNvSpPr txBox="1"/>
-          <p:nvPr/>
-        </p:nvSpPr>
-        <p:spPr>
-          <a:xfrm>
-            <a:off x="896112" y="2423160"/>
-            <a:ext cx="4480560" cy="274320"/>
-          </a:xfrm>
-          <a:prstGeom prst="rect">
-            <a:avLst/>
-          </a:prstGeom>
-          <a:noFill/>
-        </p:spPr>
-        <p:txBody>
-          <a:bodyPr wrap="square" lIns="0" rIns="0" tIns="0" bIns="0">
-            <a:spAutoFit/>
-          </a:bodyPr>
-          <a:lstStyle/>
-          <a:p>
-            <a:pPr>
-              <a:spcAft>
-                <a:spcPts val="0"/>
-              </a:spcAft>
-              <a:defRPr sz="1600" b="0">
-                <a:solidFill>
-                  <a:srgbClr val="181D16"/>
-                </a:solidFill>
-                <a:latin typeface="Arial"/>
-              </a:defRPr>
-            </a:pPr>
-            <a:r>
-              <a:t>Sample A</a:t>
-            </a:r>
-          </a:p>
-        </p:txBody>
-      </p:sp>
-      <p:cxnSp>
-        <p:nvCxnSpPr>
-          <p:cNvPr id="6" name="Connector 5"/>
-          <p:cNvCxnSpPr/>
-          <p:nvPr/>
-        </p:nvCxnSpPr>
-        <p:spPr>
-          <a:xfrm>
-            <a:off x="896112" y="5440680"/>
-            <a:ext cx="4572000" cy="0"/>
-          </a:xfrm>
-          <a:prstGeom prst="line">
-            <a:avLst/>
-          </a:prstGeom>
-          <a:ln w="12700">
-            <a:solidFill>
-              <a:srgbClr val="D4D6D0"/>
-            </a:solidFill>
-          </a:ln>
-        </p:spPr>
-        <p:style>
-          <a:lnRef idx="2">
-            <a:schemeClr val="accent1"/>
-          </a:lnRef>
-          <a:fillRef idx="0">
-            <a:schemeClr val="accent1"/>
-          </a:fillRef>
-          <a:effectRef idx="0">
-            <a:schemeClr val="accent1"/>
-          </a:effectRef>
-          <a:fontRef idx="minor">
-            <a:schemeClr val="tx1"/>
-          </a:fontRef>
-        </p:style>
-      </p:cxnSp>
-      <p:cxnSp>
-        <p:nvCxnSpPr>
-          <p:cNvPr id="7" name="Connector 6"/>
-          <p:cNvCxnSpPr/>
-          <p:nvPr/>
-        </p:nvCxnSpPr>
-        <p:spPr>
-          <a:xfrm>
-            <a:off x="896112" y="2834640"/>
-            <a:ext cx="0" cy="2606040"/>
-          </a:xfrm>
-          <a:prstGeom prst="line">
-            <a:avLst/>
-          </a:prstGeom>
-          <a:ln w="12700">
-            <a:solidFill>
-              <a:srgbClr val="D4D6D0"/>
-            </a:solidFill>
-          </a:ln>
-        </p:spPr>
-        <p:style>
-          <a:lnRef idx="2">
-            <a:schemeClr val="accent1"/>
-          </a:lnRef>
-          <a:fillRef idx="0">
-            <a:schemeClr val="accent1"/>
-          </a:fillRef>
-          <a:effectRef idx="0">
-            <a:schemeClr val="accent1"/>
-          </a:effectRef>
-          <a:fontRef idx="minor">
-            <a:schemeClr val="tx1"/>
-          </a:fontRef>
-        </p:style>
-      </p:cxnSp>
-      <p:sp>
-        <p:nvSpPr>
-          <p:cNvPr id="8" name="TextBox 7"/>
-          <p:cNvSpPr txBox="1"/>
-          <p:nvPr/>
-        </p:nvSpPr>
-        <p:spPr>
-          <a:xfrm>
-            <a:off x="5376672" y="5532120"/>
-            <a:ext cx="640080" cy="274320"/>
-          </a:xfrm>
-          <a:prstGeom prst="rect">
-            <a:avLst/>
-          </a:prstGeom>
-          <a:noFill/>
-        </p:spPr>
-        <p:txBody>
-          <a:bodyPr wrap="square" lIns="0" rIns="0" tIns="0" bIns="0">
-            <a:spAutoFit/>
-          </a:bodyPr>
-          <a:lstStyle/>
-          <a:p>
-            <a:pPr>
-              <a:spcAft>
-                <a:spcPts val="0"/>
-              </a:spcAft>
-              <a:defRPr sz="1400" b="0">
-                <a:solidFill>
-                  <a:srgbClr val="686C66"/>
-                </a:solidFill>
-                <a:latin typeface="Arial"/>
-              </a:defRPr>
-            </a:pPr>
-            <a:r>
-              <a:t>x</a:t>
-            </a:r>
-          </a:p>
-        </p:txBody>
-      </p:sp>
-      <p:sp>
-        <p:nvSpPr>
-          <p:cNvPr id="9" name="TextBox 8"/>
-          <p:cNvSpPr txBox="1"/>
-          <p:nvPr/>
-        </p:nvSpPr>
-        <p:spPr>
-          <a:xfrm>
-            <a:off x="621792" y="2651760"/>
-            <a:ext cx="914400" cy="274320"/>
-          </a:xfrm>
-          <a:prstGeom prst="rect">
-            <a:avLst/>
-          </a:prstGeom>
-          <a:noFill/>
-        </p:spPr>
-        <p:txBody>
-          <a:bodyPr wrap="square" lIns="0" rIns="0" tIns="0" bIns="0">
-            <a:spAutoFit/>
-          </a:bodyPr>
-          <a:lstStyle/>
-          <a:p>
-            <a:pPr>
-              <a:spcAft>
-                <a:spcPts val="0"/>
-              </a:spcAft>
-              <a:defRPr sz="1400" b="0">
-                <a:solidFill>
-                  <a:srgbClr val="686C66"/>
-                </a:solidFill>
-                <a:latin typeface="Arial"/>
-              </a:defRPr>
-            </a:pPr>
-            <a:r>
-              <a:t>y</a:t>
-            </a:r>
-          </a:p>
-        </p:txBody>
-      </p:sp>
-      <p:sp>
-        <p:nvSpPr>
-          <p:cNvPr id="10" name="Oval 9"/>
-          <p:cNvSpPr/>
-          <p:nvPr/>
-        </p:nvSpPr>
-        <p:spPr>
-          <a:xfrm>
-            <a:off x="854964" y="3846610"/>
-            <a:ext cx="82296" cy="82296"/>
-          </a:xfrm>
-          <a:prstGeom prst="ellipse">
-            <a:avLst/>
-          </a:prstGeom>
-          <a:solidFill>
-            <a:srgbClr val="181D16"/>
-          </a:solidFill>
-          <a:ln w="19050">
-            <a:solidFill>
-              <a:srgbClr val="181D16"/>
-            </a:solidFill>
-          </a:ln>
-        </p:spPr>
-        <p:style>
-          <a:lnRef idx="1">
-            <a:schemeClr val="accent1"/>
-          </a:lnRef>
-          <a:fillRef idx="3">
-            <a:schemeClr val="accent1"/>
-          </a:fillRef>
-          <a:effectRef idx="0">
-            <a:schemeClr val="accent1"/>
-          </a:effectRef>
-          <a:fontRef idx="minor">
-            <a:schemeClr val="lt1"/>
-          </a:fontRef>
-        </p:style>
-        <p:txBody>
-          <a:bodyPr rtlCol="0" anchor="ctr"/>
-          <a:lstStyle/>
-          <a:p>
-            <a:pPr algn="ctr"/>
-          </a:p>
-        </p:txBody>
-      </p:sp>
-      <p:sp>
-        <p:nvSpPr>
-          <p:cNvPr id="11" name="Oval 10"/>
-          <p:cNvSpPr/>
-          <p:nvPr/>
-        </p:nvSpPr>
-        <p:spPr>
-          <a:xfrm>
-            <a:off x="1095595" y="3675104"/>
-            <a:ext cx="82296" cy="82296"/>
-          </a:xfrm>
-          <a:prstGeom prst="ellipse">
-            <a:avLst/>
-          </a:prstGeom>
-          <a:solidFill>
-            <a:srgbClr val="181D16"/>
-          </a:solidFill>
-          <a:ln w="19050">
-            <a:solidFill>
-              <a:srgbClr val="181D16"/>
-            </a:solidFill>
-          </a:ln>
-        </p:spPr>
-        <p:style>
-          <a:lnRef idx="1">
-            <a:schemeClr val="accent1"/>
-          </a:lnRef>
-          <a:fillRef idx="3">
-            <a:schemeClr val="accent1"/>
-          </a:fillRef>
-          <a:effectRef idx="0">
-            <a:schemeClr val="accent1"/>
-          </a:effectRef>
-          <a:fontRef idx="minor">
-            <a:schemeClr val="lt1"/>
-          </a:fontRef>
-        </p:style>
-        <p:txBody>
-          <a:bodyPr rtlCol="0" anchor="ctr"/>
-          <a:lstStyle/>
-          <a:p>
-            <a:pPr algn="ctr"/>
-          </a:p>
-        </p:txBody>
-      </p:sp>
-      <p:sp>
-        <p:nvSpPr>
-          <p:cNvPr id="12" name="Oval 11"/>
-          <p:cNvSpPr/>
-          <p:nvPr/>
-        </p:nvSpPr>
-        <p:spPr>
-          <a:xfrm>
-            <a:off x="1336227" y="3935866"/>
-            <a:ext cx="82296" cy="82296"/>
-          </a:xfrm>
-          <a:prstGeom prst="ellipse">
-            <a:avLst/>
-          </a:prstGeom>
-          <a:solidFill>
-            <a:srgbClr val="181D16"/>
-          </a:solidFill>
-          <a:ln w="19050">
-            <a:solidFill>
-              <a:srgbClr val="181D16"/>
-            </a:solidFill>
-          </a:ln>
-        </p:spPr>
-        <p:style>
-          <a:lnRef idx="1">
-            <a:schemeClr val="accent1"/>
-          </a:lnRef>
-          <a:fillRef idx="3">
-            <a:schemeClr val="accent1"/>
-          </a:fillRef>
-          <a:effectRef idx="0">
-            <a:schemeClr val="accent1"/>
-          </a:effectRef>
-          <a:fontRef idx="minor">
-            <a:schemeClr val="lt1"/>
-          </a:fontRef>
-        </p:style>
-        <p:txBody>
-          <a:bodyPr rtlCol="0" anchor="ctr"/>
-          <a:lstStyle/>
-          <a:p>
-            <a:pPr algn="ctr"/>
-          </a:p>
-        </p:txBody>
-      </p:sp>
-      <p:sp>
-        <p:nvSpPr>
-          <p:cNvPr id="13" name="Oval 12"/>
-          <p:cNvSpPr/>
-          <p:nvPr/>
-        </p:nvSpPr>
-        <p:spPr>
-          <a:xfrm>
-            <a:off x="1576858" y="4075927"/>
-            <a:ext cx="82296" cy="82296"/>
-          </a:xfrm>
-          <a:prstGeom prst="ellipse">
-            <a:avLst/>
-          </a:prstGeom>
-          <a:solidFill>
-            <a:srgbClr val="181D16"/>
-          </a:solidFill>
-          <a:ln w="19050">
-            <a:solidFill>
-              <a:srgbClr val="181D16"/>
-            </a:solidFill>
-          </a:ln>
-        </p:spPr>
-        <p:style>
-          <a:lnRef idx="1">
-            <a:schemeClr val="accent1"/>
-          </a:lnRef>
-          <a:fillRef idx="3">
-            <a:schemeClr val="accent1"/>
-          </a:fillRef>
-          <a:effectRef idx="0">
-            <a:schemeClr val="accent1"/>
-          </a:effectRef>
-          <a:fontRef idx="minor">
-            <a:schemeClr val="lt1"/>
-          </a:fontRef>
-        </p:style>
-        <p:txBody>
-          <a:bodyPr rtlCol="0" anchor="ctr"/>
-          <a:lstStyle/>
-          <a:p>
-            <a:pPr algn="ctr"/>
-          </a:p>
-        </p:txBody>
-      </p:sp>
-      <p:sp>
-        <p:nvSpPr>
-          <p:cNvPr id="14" name="Oval 13"/>
-          <p:cNvSpPr/>
-          <p:nvPr/>
-        </p:nvSpPr>
-        <p:spPr>
-          <a:xfrm>
-            <a:off x="1817490" y="3884947"/>
-            <a:ext cx="82296" cy="82296"/>
-          </a:xfrm>
-          <a:prstGeom prst="ellipse">
-            <a:avLst/>
-          </a:prstGeom>
-          <a:solidFill>
-            <a:srgbClr val="181D16"/>
-          </a:solidFill>
-          <a:ln w="19050">
-            <a:solidFill>
-              <a:srgbClr val="181D16"/>
-            </a:solidFill>
-          </a:ln>
-        </p:spPr>
-        <p:style>
-          <a:lnRef idx="1">
-            <a:schemeClr val="accent1"/>
-          </a:lnRef>
-          <a:fillRef idx="3">
-            <a:schemeClr val="accent1"/>
-          </a:fillRef>
-          <a:effectRef idx="0">
-            <a:schemeClr val="accent1"/>
-          </a:effectRef>
-          <a:fontRef idx="minor">
-            <a:schemeClr val="lt1"/>
-          </a:fontRef>
-        </p:style>
-        <p:txBody>
-          <a:bodyPr rtlCol="0" anchor="ctr"/>
-          <a:lstStyle/>
-          <a:p>
-            <a:pPr algn="ctr"/>
-          </a:p>
-        </p:txBody>
-      </p:sp>
-      <p:sp>
-        <p:nvSpPr>
-          <p:cNvPr id="15" name="Oval 14"/>
-          <p:cNvSpPr/>
-          <p:nvPr/>
-        </p:nvSpPr>
-        <p:spPr>
-          <a:xfrm>
-            <a:off x="2058121" y="4920362"/>
-            <a:ext cx="82296" cy="82296"/>
-          </a:xfrm>
-          <a:prstGeom prst="ellipse">
-            <a:avLst/>
-          </a:prstGeom>
-          <a:solidFill>
-            <a:srgbClr val="181D16"/>
-          </a:solidFill>
-          <a:ln w="19050">
-            <a:solidFill>
-              <a:srgbClr val="181D16"/>
-            </a:solidFill>
-          </a:ln>
-        </p:spPr>
-        <p:style>
-          <a:lnRef idx="1">
-            <a:schemeClr val="accent1"/>
-          </a:lnRef>
-          <a:fillRef idx="3">
-            <a:schemeClr val="accent1"/>
-          </a:fillRef>
-          <a:effectRef idx="0">
-            <a:schemeClr val="accent1"/>
-          </a:effectRef>
-          <a:fontRef idx="minor">
-            <a:schemeClr val="lt1"/>
-          </a:fontRef>
-        </p:style>
-        <p:txBody>
-          <a:bodyPr rtlCol="0" anchor="ctr"/>
-          <a:lstStyle/>
-          <a:p>
-            <a:pPr algn="ctr"/>
-          </a:p>
-        </p:txBody>
-      </p:sp>
-      <p:sp>
-        <p:nvSpPr>
-          <p:cNvPr id="16" name="Oval 15"/>
-          <p:cNvSpPr/>
-          <p:nvPr/>
-        </p:nvSpPr>
-        <p:spPr>
-          <a:xfrm>
-            <a:off x="2298753" y="4787277"/>
-            <a:ext cx="82296" cy="82296"/>
-          </a:xfrm>
-          <a:prstGeom prst="ellipse">
-            <a:avLst/>
-          </a:prstGeom>
-          <a:solidFill>
-            <a:srgbClr val="181D16"/>
-          </a:solidFill>
-          <a:ln w="19050">
-            <a:solidFill>
-              <a:srgbClr val="181D16"/>
-            </a:solidFill>
-          </a:ln>
-        </p:spPr>
-        <p:style>
-          <a:lnRef idx="1">
-            <a:schemeClr val="accent1"/>
-          </a:lnRef>
-          <a:fillRef idx="3">
-            <a:schemeClr val="accent1"/>
-          </a:fillRef>
-          <a:effectRef idx="0">
-            <a:schemeClr val="accent1"/>
-          </a:effectRef>
-          <a:fontRef idx="minor">
-            <a:schemeClr val="lt1"/>
-          </a:fontRef>
-        </p:style>
-        <p:txBody>
-          <a:bodyPr rtlCol="0" anchor="ctr"/>
-          <a:lstStyle/>
-          <a:p>
-            <a:pPr algn="ctr"/>
-          </a:p>
-        </p:txBody>
-      </p:sp>
-      <p:sp>
-        <p:nvSpPr>
-          <p:cNvPr id="17" name="Oval 16"/>
-          <p:cNvSpPr/>
-          <p:nvPr/>
-        </p:nvSpPr>
-        <p:spPr>
-          <a:xfrm>
-            <a:off x="2539385" y="5057805"/>
-            <a:ext cx="82296" cy="82296"/>
-          </a:xfrm>
-          <a:prstGeom prst="ellipse">
-            <a:avLst/>
-          </a:prstGeom>
-          <a:solidFill>
-            <a:srgbClr val="181D16"/>
-          </a:solidFill>
-          <a:ln w="19050">
-            <a:solidFill>
-              <a:srgbClr val="181D16"/>
-            </a:solidFill>
-          </a:ln>
-        </p:spPr>
-        <p:style>
-          <a:lnRef idx="1">
-            <a:schemeClr val="accent1"/>
-          </a:lnRef>
-          <a:fillRef idx="3">
-            <a:schemeClr val="accent1"/>
-          </a:fillRef>
-          <a:effectRef idx="0">
-            <a:schemeClr val="accent1"/>
-          </a:effectRef>
-          <a:fontRef idx="minor">
-            <a:schemeClr val="lt1"/>
-          </a:fontRef>
-        </p:style>
-        <p:txBody>
-          <a:bodyPr rtlCol="0" anchor="ctr"/>
-          <a:lstStyle/>
-          <a:p>
-            <a:pPr algn="ctr"/>
-          </a:p>
-        </p:txBody>
-      </p:sp>
-      <p:sp>
-        <p:nvSpPr>
-          <p:cNvPr id="18" name="Oval 17"/>
-          <p:cNvSpPr/>
-          <p:nvPr/>
-        </p:nvSpPr>
-        <p:spPr>
-          <a:xfrm>
-            <a:off x="2780016" y="4662988"/>
-            <a:ext cx="82296" cy="82296"/>
-          </a:xfrm>
-          <a:prstGeom prst="ellipse">
-            <a:avLst/>
-          </a:prstGeom>
-          <a:solidFill>
-            <a:srgbClr val="181D16"/>
-          </a:solidFill>
-          <a:ln w="19050">
-            <a:solidFill>
-              <a:srgbClr val="181D16"/>
-            </a:solidFill>
-          </a:ln>
-        </p:spPr>
-        <p:style>
-          <a:lnRef idx="1">
-            <a:schemeClr val="accent1"/>
-          </a:lnRef>
-          <a:fillRef idx="3">
-            <a:schemeClr val="accent1"/>
-          </a:fillRef>
-          <a:effectRef idx="0">
-            <a:schemeClr val="accent1"/>
-          </a:effectRef>
-          <a:fontRef idx="minor">
-            <a:schemeClr val="lt1"/>
-          </a:fontRef>
-        </p:style>
-        <p:txBody>
-          <a:bodyPr rtlCol="0" anchor="ctr"/>
-          <a:lstStyle/>
-          <a:p>
-            <a:pPr algn="ctr"/>
-          </a:p>
-        </p:txBody>
-      </p:sp>
-      <p:sp>
-        <p:nvSpPr>
-          <p:cNvPr id="19" name="Oval 18"/>
-          <p:cNvSpPr/>
-          <p:nvPr/>
-        </p:nvSpPr>
-        <p:spPr>
-          <a:xfrm>
-            <a:off x="3020648" y="4279730"/>
-            <a:ext cx="82296" cy="82296"/>
-          </a:xfrm>
-          <a:prstGeom prst="ellipse">
-            <a:avLst/>
-          </a:prstGeom>
-          <a:solidFill>
-            <a:srgbClr val="181D16"/>
-          </a:solidFill>
-          <a:ln w="19050">
-            <a:solidFill>
-              <a:srgbClr val="181D16"/>
-            </a:solidFill>
-          </a:ln>
-        </p:spPr>
-        <p:style>
-          <a:lnRef idx="1">
-            <a:schemeClr val="accent1"/>
-          </a:lnRef>
-          <a:fillRef idx="3">
-            <a:schemeClr val="accent1"/>
-          </a:fillRef>
-          <a:effectRef idx="0">
-            <a:schemeClr val="accent1"/>
-          </a:effectRef>
-          <a:fontRef idx="minor">
-            <a:schemeClr val="lt1"/>
-          </a:fontRef>
-        </p:style>
-        <p:txBody>
-          <a:bodyPr rtlCol="0" anchor="ctr"/>
-          <a:lstStyle/>
-          <a:p>
-            <a:pPr algn="ctr"/>
-          </a:p>
-        </p:txBody>
-      </p:sp>
-      <p:sp>
-        <p:nvSpPr>
-          <p:cNvPr id="20" name="Oval 19"/>
-          <p:cNvSpPr/>
-          <p:nvPr/>
-        </p:nvSpPr>
-        <p:spPr>
-          <a:xfrm>
-            <a:off x="3261279" y="4587561"/>
-            <a:ext cx="82296" cy="82296"/>
-          </a:xfrm>
-          <a:prstGeom prst="ellipse">
-            <a:avLst/>
-          </a:prstGeom>
-          <a:solidFill>
-            <a:srgbClr val="181D16"/>
-          </a:solidFill>
-          <a:ln w="19050">
-            <a:solidFill>
-              <a:srgbClr val="181D16"/>
-            </a:solidFill>
-          </a:ln>
-        </p:spPr>
-        <p:style>
-          <a:lnRef idx="1">
-            <a:schemeClr val="accent1"/>
-          </a:lnRef>
-          <a:fillRef idx="3">
-            <a:schemeClr val="accent1"/>
-          </a:fillRef>
-          <a:effectRef idx="0">
-            <a:schemeClr val="accent1"/>
-          </a:effectRef>
-          <a:fontRef idx="minor">
-            <a:schemeClr val="lt1"/>
-          </a:fontRef>
-        </p:style>
-        <p:txBody>
-          <a:bodyPr rtlCol="0" anchor="ctr"/>
-          <a:lstStyle/>
-          <a:p>
-            <a:pPr algn="ctr"/>
-          </a:p>
-        </p:txBody>
-      </p:sp>
-      <p:sp>
-        <p:nvSpPr>
-          <p:cNvPr id="21" name="Oval 20"/>
-          <p:cNvSpPr/>
-          <p:nvPr/>
-        </p:nvSpPr>
-        <p:spPr>
-          <a:xfrm>
-            <a:off x="3501911" y="4353820"/>
-            <a:ext cx="82296" cy="82296"/>
-          </a:xfrm>
-          <a:prstGeom prst="ellipse">
-            <a:avLst/>
-          </a:prstGeom>
-          <a:solidFill>
-            <a:srgbClr val="181D16"/>
-          </a:solidFill>
-          <a:ln w="19050">
-            <a:solidFill>
-              <a:srgbClr val="181D16"/>
-            </a:solidFill>
-          </a:ln>
-        </p:spPr>
-        <p:style>
-          <a:lnRef idx="1">
-            <a:schemeClr val="accent1"/>
-          </a:lnRef>
-          <a:fillRef idx="3">
-            <a:schemeClr val="accent1"/>
-          </a:fillRef>
-          <a:effectRef idx="0">
-            <a:schemeClr val="accent1"/>
-          </a:effectRef>
-          <a:fontRef idx="minor">
-            <a:schemeClr val="lt1"/>
-          </a:fontRef>
-        </p:style>
-        <p:txBody>
-          <a:bodyPr rtlCol="0" anchor="ctr"/>
-          <a:lstStyle/>
-          <a:p>
-            <a:pPr algn="ctr"/>
-          </a:p>
-        </p:txBody>
-      </p:sp>
-      <p:sp>
-        <p:nvSpPr>
-          <p:cNvPr id="22" name="Oval 21"/>
-          <p:cNvSpPr/>
-          <p:nvPr/>
-        </p:nvSpPr>
-        <p:spPr>
-          <a:xfrm>
-            <a:off x="3742542" y="5079255"/>
-            <a:ext cx="82296" cy="82296"/>
-          </a:xfrm>
-          <a:prstGeom prst="ellipse">
-            <a:avLst/>
-          </a:prstGeom>
-          <a:solidFill>
-            <a:srgbClr val="181D16"/>
-          </a:solidFill>
-          <a:ln w="19050">
-            <a:solidFill>
-              <a:srgbClr val="181D16"/>
-            </a:solidFill>
-          </a:ln>
-        </p:spPr>
-        <p:style>
-          <a:lnRef idx="1">
-            <a:schemeClr val="accent1"/>
-          </a:lnRef>
-          <a:fillRef idx="3">
-            <a:schemeClr val="accent1"/>
-          </a:fillRef>
-          <a:effectRef idx="0">
-            <a:schemeClr val="accent1"/>
-          </a:effectRef>
-          <a:fontRef idx="minor">
-            <a:schemeClr val="lt1"/>
-          </a:fontRef>
-        </p:style>
-        <p:txBody>
-          <a:bodyPr rtlCol="0" anchor="ctr"/>
-          <a:lstStyle/>
-          <a:p>
-            <a:pPr algn="ctr"/>
-          </a:p>
-        </p:txBody>
-      </p:sp>
-      <p:sp>
-        <p:nvSpPr>
-          <p:cNvPr id="23" name="Oval 22"/>
-          <p:cNvSpPr/>
-          <p:nvPr/>
-        </p:nvSpPr>
-        <p:spPr>
-          <a:xfrm>
-            <a:off x="3983174" y="4279230"/>
-            <a:ext cx="82296" cy="82296"/>
-          </a:xfrm>
-          <a:prstGeom prst="ellipse">
-            <a:avLst/>
-          </a:prstGeom>
-          <a:solidFill>
-            <a:srgbClr val="181D16"/>
-          </a:solidFill>
-          <a:ln w="19050">
-            <a:solidFill>
-              <a:srgbClr val="181D16"/>
-            </a:solidFill>
-          </a:ln>
-        </p:spPr>
-        <p:style>
-          <a:lnRef idx="1">
-            <a:schemeClr val="accent1"/>
-          </a:lnRef>
-          <a:fillRef idx="3">
-            <a:schemeClr val="accent1"/>
-          </a:fillRef>
-          <a:effectRef idx="0">
-            <a:schemeClr val="accent1"/>
-          </a:effectRef>
-          <a:fontRef idx="minor">
-            <a:schemeClr val="lt1"/>
-          </a:fontRef>
-        </p:style>
-        <p:txBody>
-          <a:bodyPr rtlCol="0" anchor="ctr"/>
-          <a:lstStyle/>
-          <a:p>
-            <a:pPr algn="ctr"/>
-          </a:p>
-        </p:txBody>
-      </p:sp>
-      <p:sp>
-        <p:nvSpPr>
-          <p:cNvPr id="24" name="Oval 23"/>
-          <p:cNvSpPr/>
-          <p:nvPr/>
-        </p:nvSpPr>
-        <p:spPr>
-          <a:xfrm>
-            <a:off x="4223806" y="4501384"/>
-            <a:ext cx="82296" cy="82296"/>
-          </a:xfrm>
-          <a:prstGeom prst="ellipse">
-            <a:avLst/>
-          </a:prstGeom>
-          <a:solidFill>
-            <a:srgbClr val="181D16"/>
-          </a:solidFill>
-          <a:ln w="19050">
-            <a:solidFill>
-              <a:srgbClr val="181D16"/>
-            </a:solidFill>
-          </a:ln>
-        </p:spPr>
-        <p:style>
-          <a:lnRef idx="1">
-            <a:schemeClr val="accent1"/>
-          </a:lnRef>
-          <a:fillRef idx="3">
-            <a:schemeClr val="accent1"/>
-          </a:fillRef>
-          <a:effectRef idx="0">
-            <a:schemeClr val="accent1"/>
-          </a:effectRef>
-          <a:fontRef idx="minor">
-            <a:schemeClr val="lt1"/>
-          </a:fontRef>
-        </p:style>
-        <p:txBody>
-          <a:bodyPr rtlCol="0" anchor="ctr"/>
-          <a:lstStyle/>
-          <a:p>
-            <a:pPr algn="ctr"/>
-          </a:p>
-        </p:txBody>
-      </p:sp>
-      <p:sp>
-        <p:nvSpPr>
-          <p:cNvPr id="25" name="Oval 24"/>
-          <p:cNvSpPr/>
-          <p:nvPr/>
-        </p:nvSpPr>
-        <p:spPr>
-          <a:xfrm>
-            <a:off x="4464437" y="3442926"/>
-            <a:ext cx="82296" cy="82296"/>
-          </a:xfrm>
-          <a:prstGeom prst="ellipse">
-            <a:avLst/>
-          </a:prstGeom>
-          <a:solidFill>
-            <a:srgbClr val="181D16"/>
-          </a:solidFill>
-          <a:ln w="19050">
-            <a:solidFill>
-              <a:srgbClr val="181D16"/>
-            </a:solidFill>
-          </a:ln>
-        </p:spPr>
-        <p:style>
-          <a:lnRef idx="1">
-            <a:schemeClr val="accent1"/>
-          </a:lnRef>
-          <a:fillRef idx="3">
-            <a:schemeClr val="accent1"/>
-          </a:fillRef>
-          <a:effectRef idx="0">
-            <a:schemeClr val="accent1"/>
-          </a:effectRef>
-          <a:fontRef idx="minor">
-            <a:schemeClr val="lt1"/>
-          </a:fontRef>
-        </p:style>
-        <p:txBody>
-          <a:bodyPr rtlCol="0" anchor="ctr"/>
-          <a:lstStyle/>
-          <a:p>
-            <a:pPr algn="ctr"/>
-          </a:p>
-        </p:txBody>
-      </p:sp>
-      <p:sp>
-        <p:nvSpPr>
-          <p:cNvPr id="26" name="Oval 25"/>
-          <p:cNvSpPr/>
-          <p:nvPr/>
-        </p:nvSpPr>
-        <p:spPr>
-          <a:xfrm>
-            <a:off x="4705069" y="3561003"/>
-            <a:ext cx="82296" cy="82296"/>
-          </a:xfrm>
-          <a:prstGeom prst="ellipse">
-            <a:avLst/>
-          </a:prstGeom>
-          <a:solidFill>
-            <a:srgbClr val="181D16"/>
-          </a:solidFill>
-          <a:ln w="19050">
-            <a:solidFill>
-              <a:srgbClr val="181D16"/>
-            </a:solidFill>
-          </a:ln>
-        </p:spPr>
-        <p:style>
-          <a:lnRef idx="1">
-            <a:schemeClr val="accent1"/>
-          </a:lnRef>
-          <a:fillRef idx="3">
-            <a:schemeClr val="accent1"/>
-          </a:fillRef>
-          <a:effectRef idx="0">
-            <a:schemeClr val="accent1"/>
-          </a:effectRef>
-          <a:fontRef idx="minor">
-            <a:schemeClr val="lt1"/>
-          </a:fontRef>
-        </p:style>
-        <p:txBody>
-          <a:bodyPr rtlCol="0" anchor="ctr"/>
-          <a:lstStyle/>
-          <a:p>
-            <a:pPr algn="ctr"/>
-          </a:p>
-        </p:txBody>
-      </p:sp>
-      <p:sp>
-        <p:nvSpPr>
-          <p:cNvPr id="27" name="Oval 26"/>
-          <p:cNvSpPr/>
-          <p:nvPr/>
-        </p:nvSpPr>
-        <p:spPr>
-          <a:xfrm>
-            <a:off x="4945700" y="3335061"/>
-            <a:ext cx="82296" cy="82296"/>
-          </a:xfrm>
-          <a:prstGeom prst="ellipse">
-            <a:avLst/>
-          </a:prstGeom>
-          <a:solidFill>
-            <a:srgbClr val="181D16"/>
-          </a:solidFill>
-          <a:ln w="19050">
-            <a:solidFill>
-              <a:srgbClr val="181D16"/>
-            </a:solidFill>
-          </a:ln>
-        </p:spPr>
-        <p:style>
-          <a:lnRef idx="1">
-            <a:schemeClr val="accent1"/>
-          </a:lnRef>
-          <a:fillRef idx="3">
-            <a:schemeClr val="accent1"/>
-          </a:fillRef>
-          <a:effectRef idx="0">
-            <a:schemeClr val="accent1"/>
-          </a:effectRef>
-          <a:fontRef idx="minor">
-            <a:schemeClr val="lt1"/>
-          </a:fontRef>
-        </p:style>
-        <p:txBody>
-          <a:bodyPr rtlCol="0" anchor="ctr"/>
-          <a:lstStyle/>
-          <a:p>
-            <a:pPr algn="ctr"/>
-          </a:p>
-        </p:txBody>
-      </p:sp>
-      <p:sp>
-        <p:nvSpPr>
-          <p:cNvPr id="28" name="Oval 27"/>
-          <p:cNvSpPr/>
-          <p:nvPr/>
-        </p:nvSpPr>
-        <p:spPr>
-          <a:xfrm>
-            <a:off x="5186332" y="3444604"/>
-            <a:ext cx="82296" cy="82296"/>
-          </a:xfrm>
-          <a:prstGeom prst="ellipse">
-            <a:avLst/>
-          </a:prstGeom>
-          <a:solidFill>
-            <a:srgbClr val="181D16"/>
-          </a:solidFill>
-          <a:ln w="19050">
-            <a:solidFill>
-              <a:srgbClr val="181D16"/>
-            </a:solidFill>
-          </a:ln>
-        </p:spPr>
-        <p:style>
-          <a:lnRef idx="1">
-            <a:schemeClr val="accent1"/>
-          </a:lnRef>
-          <a:fillRef idx="3">
-            <a:schemeClr val="accent1"/>
-          </a:fillRef>
-          <a:effectRef idx="0">
-            <a:schemeClr val="accent1"/>
-          </a:effectRef>
-          <a:fontRef idx="minor">
-            <a:schemeClr val="lt1"/>
-          </a:fontRef>
-        </p:style>
-        <p:txBody>
-          <a:bodyPr rtlCol="0" anchor="ctr"/>
-          <a:lstStyle/>
-          <a:p>
-            <a:pPr algn="ctr"/>
-          </a:p>
-        </p:txBody>
-      </p:sp>
-      <p:sp>
-        <p:nvSpPr>
-          <p:cNvPr id="29" name="Oval 28"/>
-          <p:cNvSpPr/>
-          <p:nvPr/>
-        </p:nvSpPr>
-        <p:spPr>
-          <a:xfrm>
-            <a:off x="5426964" y="2965705"/>
-            <a:ext cx="82296" cy="82296"/>
-          </a:xfrm>
-          <a:prstGeom prst="ellipse">
-            <a:avLst/>
-          </a:prstGeom>
-          <a:solidFill>
-            <a:srgbClr val="181D16"/>
-          </a:solidFill>
-          <a:ln w="19050">
-            <a:solidFill>
-              <a:srgbClr val="181D16"/>
-            </a:solidFill>
-          </a:ln>
-        </p:spPr>
-        <p:style>
-          <a:lnRef idx="1">
-            <a:schemeClr val="accent1"/>
-          </a:lnRef>
-          <a:fillRef idx="3">
-            <a:schemeClr val="accent1"/>
-          </a:fillRef>
-          <a:effectRef idx="0">
-            <a:schemeClr val="accent1"/>
-          </a:effectRef>
-          <a:fontRef idx="minor">
-            <a:schemeClr val="lt1"/>
-          </a:fontRef>
-        </p:style>
-        <p:txBody>
-          <a:bodyPr rtlCol="0" anchor="ctr"/>
-          <a:lstStyle/>
-          <a:p>
-            <a:pPr algn="ctr"/>
-          </a:p>
-        </p:txBody>
-      </p:sp>
-      <p:sp>
-        <p:nvSpPr>
-          <p:cNvPr id="30" name="TextBox 29"/>
-          <p:cNvSpPr txBox="1"/>
-          <p:nvPr/>
-        </p:nvSpPr>
-        <p:spPr>
-          <a:xfrm>
-            <a:off x="6510528" y="2423160"/>
-            <a:ext cx="4480560" cy="274320"/>
-          </a:xfrm>
-          <a:prstGeom prst="rect">
-            <a:avLst/>
-          </a:prstGeom>
-          <a:noFill/>
-        </p:spPr>
-        <p:txBody>
-          <a:bodyPr wrap="square" lIns="0" rIns="0" tIns="0" bIns="0">
-            <a:spAutoFit/>
-          </a:bodyPr>
-          <a:lstStyle/>
-          <a:p>
-            <a:pPr>
-              <a:spcAft>
-                <a:spcPts val="0"/>
-              </a:spcAft>
-              <a:defRPr sz="1600" b="0">
-                <a:solidFill>
-                  <a:srgbClr val="181D16"/>
-                </a:solidFill>
-                <a:latin typeface="Arial"/>
-              </a:defRPr>
-            </a:pPr>
-            <a:r>
-              <a:t>Sample B</a:t>
-            </a:r>
-          </a:p>
-        </p:txBody>
-      </p:sp>
-      <p:cxnSp>
-        <p:nvCxnSpPr>
-          <p:cNvPr id="31" name="Connector 30"/>
-          <p:cNvCxnSpPr/>
-          <p:nvPr/>
-        </p:nvCxnSpPr>
-        <p:spPr>
-          <a:xfrm>
-            <a:off x="6510528" y="5440680"/>
-            <a:ext cx="4572000" cy="0"/>
-          </a:xfrm>
-          <a:prstGeom prst="line">
-            <a:avLst/>
-          </a:prstGeom>
-          <a:ln w="12700">
-            <a:solidFill>
-              <a:srgbClr val="D4D6D0"/>
-            </a:solidFill>
-          </a:ln>
-        </p:spPr>
-        <p:style>
-          <a:lnRef idx="2">
-            <a:schemeClr val="accent1"/>
-          </a:lnRef>
-          <a:fillRef idx="0">
-            <a:schemeClr val="accent1"/>
-          </a:fillRef>
-          <a:effectRef idx="0">
-            <a:schemeClr val="accent1"/>
-          </a:effectRef>
-          <a:fontRef idx="minor">
-            <a:schemeClr val="tx1"/>
-          </a:fontRef>
-        </p:style>
-      </p:cxnSp>
-      <p:cxnSp>
-        <p:nvCxnSpPr>
-          <p:cNvPr id="32" name="Connector 31"/>
-          <p:cNvCxnSpPr/>
-          <p:nvPr/>
-        </p:nvCxnSpPr>
-        <p:spPr>
-          <a:xfrm>
-            <a:off x="6510528" y="2834640"/>
-            <a:ext cx="0" cy="2606040"/>
-          </a:xfrm>
-          <a:prstGeom prst="line">
-            <a:avLst/>
-          </a:prstGeom>
-          <a:ln w="12700">
-            <a:solidFill>
-              <a:srgbClr val="D4D6D0"/>
-            </a:solidFill>
-          </a:ln>
-        </p:spPr>
-        <p:style>
-          <a:lnRef idx="2">
-            <a:schemeClr val="accent1"/>
-          </a:lnRef>
-          <a:fillRef idx="0">
-            <a:schemeClr val="accent1"/>
-          </a:fillRef>
-          <a:effectRef idx="0">
-            <a:schemeClr val="accent1"/>
-          </a:effectRef>
-          <a:fontRef idx="minor">
-            <a:schemeClr val="tx1"/>
-          </a:fontRef>
-        </p:style>
-      </p:cxnSp>
-      <p:sp>
-        <p:nvSpPr>
-          <p:cNvPr id="33" name="TextBox 32"/>
-          <p:cNvSpPr txBox="1"/>
-          <p:nvPr/>
-        </p:nvSpPr>
-        <p:spPr>
-          <a:xfrm>
-            <a:off x="10991088" y="5532120"/>
-            <a:ext cx="640080" cy="274320"/>
-          </a:xfrm>
-          <a:prstGeom prst="rect">
-            <a:avLst/>
-          </a:prstGeom>
-          <a:noFill/>
-        </p:spPr>
-        <p:txBody>
-          <a:bodyPr wrap="square" lIns="0" rIns="0" tIns="0" bIns="0">
-            <a:spAutoFit/>
-          </a:bodyPr>
-          <a:lstStyle/>
-          <a:p>
-            <a:pPr>
-              <a:spcAft>
-                <a:spcPts val="0"/>
-              </a:spcAft>
-              <a:defRPr sz="1400" b="0">
-                <a:solidFill>
-                  <a:srgbClr val="686C66"/>
-                </a:solidFill>
-                <a:latin typeface="Arial"/>
-              </a:defRPr>
-            </a:pPr>
-            <a:r>
-              <a:t>x</a:t>
-            </a:r>
-          </a:p>
-        </p:txBody>
-      </p:sp>
-      <p:sp>
-        <p:nvSpPr>
-          <p:cNvPr id="34" name="TextBox 33"/>
-          <p:cNvSpPr txBox="1"/>
-          <p:nvPr/>
-        </p:nvSpPr>
-        <p:spPr>
-          <a:xfrm>
-            <a:off x="6236208" y="2651760"/>
-            <a:ext cx="914400" cy="274320"/>
-          </a:xfrm>
-          <a:prstGeom prst="rect">
-            <a:avLst/>
-          </a:prstGeom>
-          <a:noFill/>
-        </p:spPr>
-        <p:txBody>
-          <a:bodyPr wrap="square" lIns="0" rIns="0" tIns="0" bIns="0">
-            <a:spAutoFit/>
-          </a:bodyPr>
-          <a:lstStyle/>
-          <a:p>
-            <a:pPr>
-              <a:spcAft>
-                <a:spcPts val="0"/>
-              </a:spcAft>
-              <a:defRPr sz="1400" b="0">
-                <a:solidFill>
-                  <a:srgbClr val="686C66"/>
-                </a:solidFill>
-                <a:latin typeface="Arial"/>
-              </a:defRPr>
-            </a:pPr>
-            <a:r>
-              <a:t>y</a:t>
-            </a:r>
-          </a:p>
-        </p:txBody>
-      </p:sp>
-      <p:sp>
-        <p:nvSpPr>
-          <p:cNvPr id="35" name="Oval 34"/>
-          <p:cNvSpPr/>
-          <p:nvPr/>
-        </p:nvSpPr>
-        <p:spPr>
-          <a:xfrm>
-            <a:off x="6469380" y="3965257"/>
-            <a:ext cx="82296" cy="82296"/>
-          </a:xfrm>
-          <a:prstGeom prst="ellipse">
-            <a:avLst/>
-          </a:prstGeom>
-          <a:solidFill>
-            <a:srgbClr val="181D16"/>
-          </a:solidFill>
-          <a:ln w="19050">
-            <a:solidFill>
-              <a:srgbClr val="181D16"/>
-            </a:solidFill>
-          </a:ln>
-        </p:spPr>
-        <p:style>
-          <a:lnRef idx="1">
-            <a:schemeClr val="accent1"/>
-          </a:lnRef>
-          <a:fillRef idx="3">
-            <a:schemeClr val="accent1"/>
-          </a:fillRef>
-          <a:effectRef idx="0">
-            <a:schemeClr val="accent1"/>
-          </a:effectRef>
-          <a:fontRef idx="minor">
-            <a:schemeClr val="lt1"/>
-          </a:fontRef>
-        </p:style>
-        <p:txBody>
-          <a:bodyPr rtlCol="0" anchor="ctr"/>
-          <a:lstStyle/>
-          <a:p>
-            <a:pPr algn="ctr"/>
-          </a:p>
-        </p:txBody>
-      </p:sp>
-      <p:sp>
-        <p:nvSpPr>
-          <p:cNvPr id="36" name="Oval 35"/>
-          <p:cNvSpPr/>
-          <p:nvPr/>
-        </p:nvSpPr>
-        <p:spPr>
-          <a:xfrm>
-            <a:off x="6710011" y="3622132"/>
-            <a:ext cx="82296" cy="82296"/>
-          </a:xfrm>
-          <a:prstGeom prst="ellipse">
-            <a:avLst/>
-          </a:prstGeom>
-          <a:solidFill>
-            <a:srgbClr val="181D16"/>
-          </a:solidFill>
-          <a:ln w="19050">
-            <a:solidFill>
-              <a:srgbClr val="181D16"/>
-            </a:solidFill>
-          </a:ln>
-        </p:spPr>
-        <p:style>
-          <a:lnRef idx="1">
-            <a:schemeClr val="accent1"/>
-          </a:lnRef>
-          <a:fillRef idx="3">
-            <a:schemeClr val="accent1"/>
-          </a:fillRef>
-          <a:effectRef idx="0">
-            <a:schemeClr val="accent1"/>
-          </a:effectRef>
-          <a:fontRef idx="minor">
-            <a:schemeClr val="lt1"/>
-          </a:fontRef>
-        </p:style>
-        <p:txBody>
-          <a:bodyPr rtlCol="0" anchor="ctr"/>
-          <a:lstStyle/>
-          <a:p>
-            <a:pPr algn="ctr"/>
-          </a:p>
-        </p:txBody>
-      </p:sp>
-      <p:sp>
-        <p:nvSpPr>
-          <p:cNvPr id="37" name="Oval 36"/>
-          <p:cNvSpPr/>
-          <p:nvPr/>
-        </p:nvSpPr>
-        <p:spPr>
-          <a:xfrm>
-            <a:off x="6950643" y="3715519"/>
-            <a:ext cx="82296" cy="82296"/>
-          </a:xfrm>
-          <a:prstGeom prst="ellipse">
-            <a:avLst/>
-          </a:prstGeom>
-          <a:solidFill>
-            <a:srgbClr val="181D16"/>
-          </a:solidFill>
-          <a:ln w="19050">
-            <a:solidFill>
-              <a:srgbClr val="181D16"/>
-            </a:solidFill>
-          </a:ln>
-        </p:spPr>
-        <p:style>
-          <a:lnRef idx="1">
-            <a:schemeClr val="accent1"/>
-          </a:lnRef>
-          <a:fillRef idx="3">
-            <a:schemeClr val="accent1"/>
-          </a:fillRef>
-          <a:effectRef idx="0">
-            <a:schemeClr val="accent1"/>
-          </a:effectRef>
-          <a:fontRef idx="minor">
-            <a:schemeClr val="lt1"/>
-          </a:fontRef>
-        </p:style>
-        <p:txBody>
-          <a:bodyPr rtlCol="0" anchor="ctr"/>
-          <a:lstStyle/>
-          <a:p>
-            <a:pPr algn="ctr"/>
-          </a:p>
-        </p:txBody>
-      </p:sp>
-      <p:sp>
-        <p:nvSpPr>
-          <p:cNvPr id="38" name="Oval 37"/>
-          <p:cNvSpPr/>
-          <p:nvPr/>
-        </p:nvSpPr>
-        <p:spPr>
-          <a:xfrm>
-            <a:off x="7191274" y="4212693"/>
-            <a:ext cx="82296" cy="82296"/>
-          </a:xfrm>
-          <a:prstGeom prst="ellipse">
-            <a:avLst/>
-          </a:prstGeom>
-          <a:solidFill>
-            <a:srgbClr val="181D16"/>
-          </a:solidFill>
-          <a:ln w="19050">
-            <a:solidFill>
-              <a:srgbClr val="181D16"/>
-            </a:solidFill>
-          </a:ln>
-        </p:spPr>
-        <p:style>
-          <a:lnRef idx="1">
-            <a:schemeClr val="accent1"/>
-          </a:lnRef>
-          <a:fillRef idx="3">
-            <a:schemeClr val="accent1"/>
-          </a:fillRef>
-          <a:effectRef idx="0">
-            <a:schemeClr val="accent1"/>
-          </a:effectRef>
-          <a:fontRef idx="minor">
-            <a:schemeClr val="lt1"/>
-          </a:fontRef>
-        </p:style>
-        <p:txBody>
-          <a:bodyPr rtlCol="0" anchor="ctr"/>
-          <a:lstStyle/>
-          <a:p>
-            <a:pPr algn="ctr"/>
-          </a:p>
-        </p:txBody>
-      </p:sp>
-      <p:sp>
-        <p:nvSpPr>
-          <p:cNvPr id="39" name="Oval 38"/>
-          <p:cNvSpPr/>
-          <p:nvPr/>
-        </p:nvSpPr>
-        <p:spPr>
-          <a:xfrm>
-            <a:off x="7431906" y="4290024"/>
-            <a:ext cx="82296" cy="82296"/>
-          </a:xfrm>
-          <a:prstGeom prst="ellipse">
-            <a:avLst/>
-          </a:prstGeom>
-          <a:solidFill>
-            <a:srgbClr val="181D16"/>
-          </a:solidFill>
-          <a:ln w="19050">
-            <a:solidFill>
-              <a:srgbClr val="181D16"/>
-            </a:solidFill>
-          </a:ln>
-        </p:spPr>
-        <p:style>
-          <a:lnRef idx="1">
-            <a:schemeClr val="accent1"/>
-          </a:lnRef>
-          <a:fillRef idx="3">
-            <a:schemeClr val="accent1"/>
-          </a:fillRef>
-          <a:effectRef idx="0">
-            <a:schemeClr val="accent1"/>
-          </a:effectRef>
-          <a:fontRef idx="minor">
-            <a:schemeClr val="lt1"/>
-          </a:fontRef>
-        </p:style>
-        <p:txBody>
-          <a:bodyPr rtlCol="0" anchor="ctr"/>
-          <a:lstStyle/>
-          <a:p>
-            <a:pPr algn="ctr"/>
-          </a:p>
-        </p:txBody>
-      </p:sp>
-      <p:sp>
-        <p:nvSpPr>
-          <p:cNvPr id="40" name="Oval 39"/>
-          <p:cNvSpPr/>
-          <p:nvPr/>
-        </p:nvSpPr>
-        <p:spPr>
-          <a:xfrm>
-            <a:off x="7672537" y="4679595"/>
-            <a:ext cx="82296" cy="82296"/>
-          </a:xfrm>
-          <a:prstGeom prst="ellipse">
-            <a:avLst/>
-          </a:prstGeom>
-          <a:solidFill>
-            <a:srgbClr val="181D16"/>
-          </a:solidFill>
-          <a:ln w="19050">
-            <a:solidFill>
-              <a:srgbClr val="181D16"/>
-            </a:solidFill>
-          </a:ln>
-        </p:spPr>
-        <p:style>
-          <a:lnRef idx="1">
-            <a:schemeClr val="accent1"/>
-          </a:lnRef>
-          <a:fillRef idx="3">
-            <a:schemeClr val="accent1"/>
-          </a:fillRef>
-          <a:effectRef idx="0">
-            <a:schemeClr val="accent1"/>
-          </a:effectRef>
-          <a:fontRef idx="minor">
-            <a:schemeClr val="lt1"/>
-          </a:fontRef>
-        </p:style>
-        <p:txBody>
-          <a:bodyPr rtlCol="0" anchor="ctr"/>
-          <a:lstStyle/>
-          <a:p>
-            <a:pPr algn="ctr"/>
-          </a:p>
-        </p:txBody>
-      </p:sp>
-      <p:sp>
-        <p:nvSpPr>
-          <p:cNvPr id="41" name="Oval 40"/>
-          <p:cNvSpPr/>
-          <p:nvPr/>
-        </p:nvSpPr>
-        <p:spPr>
-          <a:xfrm>
-            <a:off x="7913169" y="4883840"/>
-            <a:ext cx="82296" cy="82296"/>
-          </a:xfrm>
-          <a:prstGeom prst="ellipse">
-            <a:avLst/>
-          </a:prstGeom>
-          <a:solidFill>
-            <a:srgbClr val="181D16"/>
-          </a:solidFill>
-          <a:ln w="19050">
-            <a:solidFill>
-              <a:srgbClr val="181D16"/>
-            </a:solidFill>
-          </a:ln>
-        </p:spPr>
-        <p:style>
-          <a:lnRef idx="1">
-            <a:schemeClr val="accent1"/>
-          </a:lnRef>
-          <a:fillRef idx="3">
-            <a:schemeClr val="accent1"/>
-          </a:fillRef>
-          <a:effectRef idx="0">
-            <a:schemeClr val="accent1"/>
-          </a:effectRef>
-          <a:fontRef idx="minor">
-            <a:schemeClr val="lt1"/>
-          </a:fontRef>
-        </p:style>
-        <p:txBody>
-          <a:bodyPr rtlCol="0" anchor="ctr"/>
-          <a:lstStyle/>
-          <a:p>
-            <a:pPr algn="ctr"/>
-          </a:p>
-        </p:txBody>
-      </p:sp>
-      <p:sp>
-        <p:nvSpPr>
-          <p:cNvPr id="42" name="Oval 41"/>
-          <p:cNvSpPr/>
-          <p:nvPr/>
-        </p:nvSpPr>
-        <p:spPr>
-          <a:xfrm>
-            <a:off x="8153801" y="4916472"/>
-            <a:ext cx="82296" cy="82296"/>
-          </a:xfrm>
-          <a:prstGeom prst="ellipse">
-            <a:avLst/>
-          </a:prstGeom>
-          <a:solidFill>
-            <a:srgbClr val="181D16"/>
-          </a:solidFill>
-          <a:ln w="19050">
-            <a:solidFill>
-              <a:srgbClr val="181D16"/>
-            </a:solidFill>
-          </a:ln>
-        </p:spPr>
-        <p:style>
-          <a:lnRef idx="1">
-            <a:schemeClr val="accent1"/>
-          </a:lnRef>
-          <a:fillRef idx="3">
-            <a:schemeClr val="accent1"/>
-          </a:fillRef>
-          <a:effectRef idx="0">
-            <a:schemeClr val="accent1"/>
-          </a:effectRef>
-          <a:fontRef idx="minor">
-            <a:schemeClr val="lt1"/>
-          </a:fontRef>
-        </p:style>
-        <p:txBody>
-          <a:bodyPr rtlCol="0" anchor="ctr"/>
-          <a:lstStyle/>
-          <a:p>
-            <a:pPr algn="ctr"/>
-          </a:p>
-        </p:txBody>
-      </p:sp>
-      <p:sp>
-        <p:nvSpPr>
-          <p:cNvPr id="43" name="Oval 42"/>
-          <p:cNvSpPr/>
-          <p:nvPr/>
-        </p:nvSpPr>
-        <p:spPr>
-          <a:xfrm>
-            <a:off x="8394432" y="4962491"/>
-            <a:ext cx="82296" cy="82296"/>
-          </a:xfrm>
-          <a:prstGeom prst="ellipse">
-            <a:avLst/>
-          </a:prstGeom>
-          <a:solidFill>
-            <a:srgbClr val="181D16"/>
-          </a:solidFill>
-          <a:ln w="19050">
-            <a:solidFill>
-              <a:srgbClr val="181D16"/>
-            </a:solidFill>
-          </a:ln>
-        </p:spPr>
-        <p:style>
-          <a:lnRef idx="1">
-            <a:schemeClr val="accent1"/>
-          </a:lnRef>
-          <a:fillRef idx="3">
-            <a:schemeClr val="accent1"/>
-          </a:fillRef>
-          <a:effectRef idx="0">
-            <a:schemeClr val="accent1"/>
-          </a:effectRef>
-          <a:fontRef idx="minor">
-            <a:schemeClr val="lt1"/>
-          </a:fontRef>
-        </p:style>
-        <p:txBody>
-          <a:bodyPr rtlCol="0" anchor="ctr"/>
-          <a:lstStyle/>
-          <a:p>
-            <a:pPr algn="ctr"/>
-          </a:p>
-        </p:txBody>
-      </p:sp>
-      <p:sp>
-        <p:nvSpPr>
-          <p:cNvPr id="44" name="Oval 43"/>
-          <p:cNvSpPr/>
-          <p:nvPr/>
-        </p:nvSpPr>
-        <p:spPr>
-          <a:xfrm>
-            <a:off x="8635064" y="4303120"/>
-            <a:ext cx="82296" cy="82296"/>
-          </a:xfrm>
-          <a:prstGeom prst="ellipse">
-            <a:avLst/>
-          </a:prstGeom>
-          <a:solidFill>
-            <a:srgbClr val="181D16"/>
-          </a:solidFill>
-          <a:ln w="19050">
-            <a:solidFill>
-              <a:srgbClr val="181D16"/>
-            </a:solidFill>
-          </a:ln>
-        </p:spPr>
-        <p:style>
-          <a:lnRef idx="1">
-            <a:schemeClr val="accent1"/>
-          </a:lnRef>
-          <a:fillRef idx="3">
-            <a:schemeClr val="accent1"/>
-          </a:fillRef>
-          <a:effectRef idx="0">
-            <a:schemeClr val="accent1"/>
-          </a:effectRef>
-          <a:fontRef idx="minor">
-            <a:schemeClr val="lt1"/>
-          </a:fontRef>
-        </p:style>
-        <p:txBody>
-          <a:bodyPr rtlCol="0" anchor="ctr"/>
-          <a:lstStyle/>
-          <a:p>
-            <a:pPr algn="ctr"/>
-          </a:p>
-        </p:txBody>
-      </p:sp>
-      <p:sp>
-        <p:nvSpPr>
-          <p:cNvPr id="45" name="Oval 44"/>
-          <p:cNvSpPr/>
-          <p:nvPr/>
-        </p:nvSpPr>
-        <p:spPr>
-          <a:xfrm>
-            <a:off x="8875695" y="4599110"/>
-            <a:ext cx="82296" cy="82296"/>
-          </a:xfrm>
-          <a:prstGeom prst="ellipse">
-            <a:avLst/>
-          </a:prstGeom>
-          <a:solidFill>
-            <a:srgbClr val="181D16"/>
-          </a:solidFill>
-          <a:ln w="19050">
-            <a:solidFill>
-              <a:srgbClr val="181D16"/>
-            </a:solidFill>
-          </a:ln>
-        </p:spPr>
-        <p:style>
-          <a:lnRef idx="1">
-            <a:schemeClr val="accent1"/>
-          </a:lnRef>
-          <a:fillRef idx="3">
-            <a:schemeClr val="accent1"/>
-          </a:fillRef>
-          <a:effectRef idx="0">
-            <a:schemeClr val="accent1"/>
-          </a:effectRef>
-          <a:fontRef idx="minor">
-            <a:schemeClr val="lt1"/>
-          </a:fontRef>
-        </p:style>
-        <p:txBody>
-          <a:bodyPr rtlCol="0" anchor="ctr"/>
-          <a:lstStyle/>
-          <a:p>
-            <a:pPr algn="ctr"/>
-          </a:p>
-        </p:txBody>
-      </p:sp>
-      <p:sp>
-        <p:nvSpPr>
-          <p:cNvPr id="46" name="Oval 45"/>
-          <p:cNvSpPr/>
-          <p:nvPr/>
-        </p:nvSpPr>
-        <p:spPr>
-          <a:xfrm>
-            <a:off x="9116327" y="4477431"/>
-            <a:ext cx="82296" cy="82296"/>
-          </a:xfrm>
-          <a:prstGeom prst="ellipse">
-            <a:avLst/>
-          </a:prstGeom>
-          <a:solidFill>
-            <a:srgbClr val="181D16"/>
-          </a:solidFill>
-          <a:ln w="19050">
-            <a:solidFill>
-              <a:srgbClr val="181D16"/>
-            </a:solidFill>
-          </a:ln>
-        </p:spPr>
-        <p:style>
-          <a:lnRef idx="1">
-            <a:schemeClr val="accent1"/>
-          </a:lnRef>
-          <a:fillRef idx="3">
-            <a:schemeClr val="accent1"/>
-          </a:fillRef>
-          <a:effectRef idx="0">
-            <a:schemeClr val="accent1"/>
-          </a:effectRef>
-          <a:fontRef idx="minor">
-            <a:schemeClr val="lt1"/>
-          </a:fontRef>
-        </p:style>
-        <p:txBody>
-          <a:bodyPr rtlCol="0" anchor="ctr"/>
-          <a:lstStyle/>
-          <a:p>
-            <a:pPr algn="ctr"/>
-          </a:p>
-        </p:txBody>
-      </p:sp>
-      <p:sp>
-        <p:nvSpPr>
-          <p:cNvPr id="47" name="Oval 46"/>
-          <p:cNvSpPr/>
-          <p:nvPr/>
-        </p:nvSpPr>
-        <p:spPr>
-          <a:xfrm>
-            <a:off x="9356958" y="4651932"/>
-            <a:ext cx="82296" cy="82296"/>
-          </a:xfrm>
-          <a:prstGeom prst="ellipse">
-            <a:avLst/>
-          </a:prstGeom>
-          <a:solidFill>
-            <a:srgbClr val="181D16"/>
-          </a:solidFill>
-          <a:ln w="19050">
-            <a:solidFill>
-              <a:srgbClr val="181D16"/>
-            </a:solidFill>
-          </a:ln>
-        </p:spPr>
-        <p:style>
-          <a:lnRef idx="1">
-            <a:schemeClr val="accent1"/>
-          </a:lnRef>
-          <a:fillRef idx="3">
-            <a:schemeClr val="accent1"/>
-          </a:fillRef>
-          <a:effectRef idx="0">
-            <a:schemeClr val="accent1"/>
-          </a:effectRef>
-          <a:fontRef idx="minor">
-            <a:schemeClr val="lt1"/>
-          </a:fontRef>
-        </p:style>
-        <p:txBody>
-          <a:bodyPr rtlCol="0" anchor="ctr"/>
-          <a:lstStyle/>
-          <a:p>
-            <a:pPr algn="ctr"/>
-          </a:p>
-        </p:txBody>
-      </p:sp>
-      <p:sp>
-        <p:nvSpPr>
-          <p:cNvPr id="48" name="Oval 47"/>
-          <p:cNvSpPr/>
-          <p:nvPr/>
-        </p:nvSpPr>
-        <p:spPr>
-          <a:xfrm>
-            <a:off x="9597590" y="4694475"/>
-            <a:ext cx="82296" cy="82296"/>
-          </a:xfrm>
-          <a:prstGeom prst="ellipse">
-            <a:avLst/>
-          </a:prstGeom>
-          <a:solidFill>
-            <a:srgbClr val="181D16"/>
-          </a:solidFill>
-          <a:ln w="19050">
-            <a:solidFill>
-              <a:srgbClr val="181D16"/>
-            </a:solidFill>
-          </a:ln>
-        </p:spPr>
-        <p:style>
-          <a:lnRef idx="1">
-            <a:schemeClr val="accent1"/>
-          </a:lnRef>
-          <a:fillRef idx="3">
-            <a:schemeClr val="accent1"/>
-          </a:fillRef>
-          <a:effectRef idx="0">
-            <a:schemeClr val="accent1"/>
-          </a:effectRef>
-          <a:fontRef idx="minor">
-            <a:schemeClr val="lt1"/>
-          </a:fontRef>
-        </p:style>
-        <p:txBody>
-          <a:bodyPr rtlCol="0" anchor="ctr"/>
-          <a:lstStyle/>
-          <a:p>
-            <a:pPr algn="ctr"/>
-          </a:p>
-        </p:txBody>
-      </p:sp>
-      <p:sp>
-        <p:nvSpPr>
-          <p:cNvPr id="49" name="Oval 48"/>
-          <p:cNvSpPr/>
-          <p:nvPr/>
-        </p:nvSpPr>
-        <p:spPr>
-          <a:xfrm>
-            <a:off x="9838222" y="4600585"/>
-            <a:ext cx="82296" cy="82296"/>
-          </a:xfrm>
-          <a:prstGeom prst="ellipse">
-            <a:avLst/>
-          </a:prstGeom>
-          <a:solidFill>
-            <a:srgbClr val="181D16"/>
-          </a:solidFill>
-          <a:ln w="19050">
-            <a:solidFill>
-              <a:srgbClr val="181D16"/>
-            </a:solidFill>
-          </a:ln>
-        </p:spPr>
-        <p:style>
-          <a:lnRef idx="1">
-            <a:schemeClr val="accent1"/>
-          </a:lnRef>
-          <a:fillRef idx="3">
-            <a:schemeClr val="accent1"/>
-          </a:fillRef>
-          <a:effectRef idx="0">
-            <a:schemeClr val="accent1"/>
-          </a:effectRef>
-          <a:fontRef idx="minor">
-            <a:schemeClr val="lt1"/>
-          </a:fontRef>
-        </p:style>
-        <p:txBody>
-          <a:bodyPr rtlCol="0" anchor="ctr"/>
-          <a:lstStyle/>
-          <a:p>
-            <a:pPr algn="ctr"/>
-          </a:p>
-        </p:txBody>
-      </p:sp>
-      <p:sp>
-        <p:nvSpPr>
-          <p:cNvPr id="50" name="Oval 49"/>
-          <p:cNvSpPr/>
-          <p:nvPr/>
-        </p:nvSpPr>
-        <p:spPr>
-          <a:xfrm>
-            <a:off x="10078853" y="4322913"/>
-            <a:ext cx="82296" cy="82296"/>
-          </a:xfrm>
-          <a:prstGeom prst="ellipse">
-            <a:avLst/>
-          </a:prstGeom>
-          <a:solidFill>
-            <a:srgbClr val="181D16"/>
-          </a:solidFill>
-          <a:ln w="19050">
-            <a:solidFill>
-              <a:srgbClr val="181D16"/>
-            </a:solidFill>
-          </a:ln>
-        </p:spPr>
-        <p:style>
-          <a:lnRef idx="1">
-            <a:schemeClr val="accent1"/>
-          </a:lnRef>
-          <a:fillRef idx="3">
-            <a:schemeClr val="accent1"/>
-          </a:fillRef>
-          <a:effectRef idx="0">
-            <a:schemeClr val="accent1"/>
-          </a:effectRef>
-          <a:fontRef idx="minor">
-            <a:schemeClr val="lt1"/>
-          </a:fontRef>
-        </p:style>
-        <p:txBody>
-          <a:bodyPr rtlCol="0" anchor="ctr"/>
-          <a:lstStyle/>
-          <a:p>
-            <a:pPr algn="ctr"/>
-          </a:p>
-        </p:txBody>
-      </p:sp>
-      <p:sp>
-        <p:nvSpPr>
-          <p:cNvPr id="51" name="Oval 50"/>
-          <p:cNvSpPr/>
-          <p:nvPr/>
-        </p:nvSpPr>
-        <p:spPr>
-          <a:xfrm>
-            <a:off x="10319485" y="3657743"/>
-            <a:ext cx="82296" cy="82296"/>
-          </a:xfrm>
-          <a:prstGeom prst="ellipse">
-            <a:avLst/>
-          </a:prstGeom>
-          <a:solidFill>
-            <a:srgbClr val="181D16"/>
-          </a:solidFill>
-          <a:ln w="19050">
-            <a:solidFill>
-              <a:srgbClr val="181D16"/>
-            </a:solidFill>
-          </a:ln>
-        </p:spPr>
-        <p:style>
-          <a:lnRef idx="1">
-            <a:schemeClr val="accent1"/>
-          </a:lnRef>
-          <a:fillRef idx="3">
-            <a:schemeClr val="accent1"/>
-          </a:fillRef>
-          <a:effectRef idx="0">
-            <a:schemeClr val="accent1"/>
-          </a:effectRef>
-          <a:fontRef idx="minor">
-            <a:schemeClr val="lt1"/>
-          </a:fontRef>
-        </p:style>
-        <p:txBody>
-          <a:bodyPr rtlCol="0" anchor="ctr"/>
-          <a:lstStyle/>
-          <a:p>
-            <a:pPr algn="ctr"/>
-          </a:p>
-        </p:txBody>
-      </p:sp>
-      <p:sp>
-        <p:nvSpPr>
-          <p:cNvPr id="52" name="Oval 51"/>
-          <p:cNvSpPr/>
-          <p:nvPr/>
-        </p:nvSpPr>
-        <p:spPr>
-          <a:xfrm>
-            <a:off x="10560116" y="3648092"/>
-            <a:ext cx="82296" cy="82296"/>
-          </a:xfrm>
-          <a:prstGeom prst="ellipse">
-            <a:avLst/>
-          </a:prstGeom>
-          <a:solidFill>
-            <a:srgbClr val="181D16"/>
-          </a:solidFill>
-          <a:ln w="19050">
-            <a:solidFill>
-              <a:srgbClr val="181D16"/>
-            </a:solidFill>
-          </a:ln>
-        </p:spPr>
-        <p:style>
-          <a:lnRef idx="1">
-            <a:schemeClr val="accent1"/>
-          </a:lnRef>
-          <a:fillRef idx="3">
-            <a:schemeClr val="accent1"/>
-          </a:fillRef>
-          <a:effectRef idx="0">
-            <a:schemeClr val="accent1"/>
-          </a:effectRef>
-          <a:fontRef idx="minor">
-            <a:schemeClr val="lt1"/>
-          </a:fontRef>
-        </p:style>
-        <p:txBody>
-          <a:bodyPr rtlCol="0" anchor="ctr"/>
-          <a:lstStyle/>
-          <a:p>
-            <a:pPr algn="ctr"/>
-          </a:p>
-        </p:txBody>
-      </p:sp>
-      <p:sp>
-        <p:nvSpPr>
-          <p:cNvPr id="53" name="Oval 52"/>
-          <p:cNvSpPr/>
-          <p:nvPr/>
-        </p:nvSpPr>
-        <p:spPr>
-          <a:xfrm>
-            <a:off x="10800748" y="3578745"/>
-            <a:ext cx="82296" cy="82296"/>
-          </a:xfrm>
-          <a:prstGeom prst="ellipse">
-            <a:avLst/>
-          </a:prstGeom>
-          <a:solidFill>
-            <a:srgbClr val="181D16"/>
-          </a:solidFill>
-          <a:ln w="19050">
-            <a:solidFill>
-              <a:srgbClr val="181D16"/>
-            </a:solidFill>
-          </a:ln>
-        </p:spPr>
-        <p:style>
-          <a:lnRef idx="1">
-            <a:schemeClr val="accent1"/>
-          </a:lnRef>
-          <a:fillRef idx="3">
-            <a:schemeClr val="accent1"/>
-          </a:fillRef>
-          <a:effectRef idx="0">
-            <a:schemeClr val="accent1"/>
-          </a:effectRef>
-          <a:fontRef idx="minor">
-            <a:schemeClr val="lt1"/>
-          </a:fontRef>
-        </p:style>
-        <p:txBody>
-          <a:bodyPr rtlCol="0" anchor="ctr"/>
-          <a:lstStyle/>
-          <a:p>
-            <a:pPr algn="ctr"/>
-          </a:p>
-        </p:txBody>
-      </p:sp>
-      <p:sp>
-        <p:nvSpPr>
-          <p:cNvPr id="54" name="Oval 53"/>
-          <p:cNvSpPr/>
-          <p:nvPr/>
-        </p:nvSpPr>
-        <p:spPr>
-          <a:xfrm>
-            <a:off x="11041380" y="3252248"/>
-            <a:ext cx="82296" cy="82296"/>
-          </a:xfrm>
-          <a:prstGeom prst="ellipse">
-            <a:avLst/>
-          </a:prstGeom>
-          <a:solidFill>
-            <a:srgbClr val="181D16"/>
-          </a:solidFill>
-          <a:ln w="19050">
-            <a:solidFill>
-              <a:srgbClr val="181D16"/>
-            </a:solidFill>
-          </a:ln>
-        </p:spPr>
-        <p:style>
-          <a:lnRef idx="1">
-            <a:schemeClr val="accent1"/>
-          </a:lnRef>
-          <a:fillRef idx="3">
-            <a:schemeClr val="accent1"/>
-          </a:fillRef>
-          <a:effectRef idx="0">
-            <a:schemeClr val="accent1"/>
-          </a:effectRef>
-          <a:fontRef idx="minor">
-            <a:schemeClr val="lt1"/>
-          </a:fontRef>
-        </p:style>
-        <p:txBody>
-          <a:bodyPr rtlCol="0" anchor="ctr"/>
-          <a:lstStyle/>
-          <a:p>
-            <a:pPr algn="ctr"/>
-          </a:p>
-        </p:txBody>
-      </p:sp>
-      <p:sp>
-        <p:nvSpPr>
-          <p:cNvPr id="55" name="Oval 54"/>
-          <p:cNvSpPr/>
-          <p:nvPr/>
-        </p:nvSpPr>
-        <p:spPr>
-          <a:xfrm>
-            <a:off x="864108" y="5948172"/>
-            <a:ext cx="82296" cy="82296"/>
-          </a:xfrm>
-          <a:prstGeom prst="ellipse">
-            <a:avLst/>
-          </a:prstGeom>
-          <a:solidFill>
-            <a:srgbClr val="181D16"/>
-          </a:solidFill>
-          <a:ln w="19050">
-            <a:solidFill>
-              <a:srgbClr val="181D16"/>
-            </a:solidFill>
-          </a:ln>
-        </p:spPr>
-        <p:style>
-          <a:lnRef idx="1">
-            <a:schemeClr val="accent1"/>
-          </a:lnRef>
-          <a:fillRef idx="3">
-            <a:schemeClr val="accent1"/>
-          </a:fillRef>
-          <a:effectRef idx="0">
-            <a:schemeClr val="accent1"/>
-          </a:effectRef>
-          <a:fontRef idx="minor">
-            <a:schemeClr val="lt1"/>
-          </a:fontRef>
-        </p:style>
-        <p:txBody>
-          <a:bodyPr rtlCol="0" anchor="ctr"/>
-          <a:lstStyle/>
-          <a:p>
-            <a:pPr algn="ctr"/>
-          </a:p>
-        </p:txBody>
-      </p:sp>
-      <p:sp>
-        <p:nvSpPr>
-          <p:cNvPr id="56" name="TextBox 55"/>
-          <p:cNvSpPr txBox="1"/>
-          <p:nvPr/>
-        </p:nvSpPr>
-        <p:spPr>
-          <a:xfrm>
-            <a:off x="1197864" y="5870448"/>
-            <a:ext cx="2468880" cy="320040"/>
-          </a:xfrm>
-          <a:prstGeom prst="rect">
-            <a:avLst/>
-          </a:prstGeom>
-          <a:noFill/>
-        </p:spPr>
-        <p:txBody>
-          <a:bodyPr wrap="square" lIns="0" rIns="0" tIns="0" bIns="0">
-            <a:spAutoFit/>
-          </a:bodyPr>
-          <a:lstStyle/>
-          <a:p>
-            <a:pPr>
-              <a:spcAft>
-                <a:spcPts val="0"/>
-              </a:spcAft>
-              <a:defRPr sz="1300" b="0">
-                <a:solidFill>
-                  <a:srgbClr val="686C66"/>
-                </a:solidFill>
-                <a:latin typeface="Arial"/>
-              </a:defRPr>
-            </a:pPr>
-            <a:r>
-              <a:t>training observations</a:t>
-            </a:r>
-          </a:p>
-        </p:txBody>
-      </p:sp>
-    </p:spTree>
-  </p:cSld>
-  <p:clrMapOvr>
-    <a:masterClrMapping/>
-  </p:clrMapOvr>
-</p:sld>
-</file>
-
-<file path=ppt/slides/slide2.xml><?xml version="1.0" encoding="utf-8"?>
-<p:sld xmlns:a="http://schemas.openxmlformats.org/drawingml/2006/main" xmlns:p="http://schemas.openxmlformats.org/presentationml/2006/main" xmlns:r="http://schemas.openxmlformats.org/officeDocument/2006/relationships">
-  <p:cSld>
-    <p:bg>
-      <p:bgPr>
-        <a:solidFill>
-          <a:srgbClr val="F5F5F4"/>
-        </a:solidFill>
-        <a:effectLst/>
-      </p:bgPr>
-    </p:bg>
-    <p:spTree>
-      <p:nvGrpSpPr>
-        <p:cNvPr id="1" name=""/>
-        <p:cNvGrpSpPr/>
-        <p:nvPr/>
-      </p:nvGrpSpPr>
-      <p:grpSpPr/>
-      <p:pic>
-        <p:nvPicPr>
-          <p:cNvPr id="2" name="Picture 1" descr="image.png"/>
-          <p:cNvPicPr>
-            <a:picLocks noChangeAspect="1"/>
-          </p:cNvPicPr>
-          <p:nvPr/>
-        </p:nvPicPr>
-        <p:blipFill>
-          <a:blip r:embed="rId2"/>
-          <a:stretch>
-            <a:fillRect/>
-          </a:stretch>
-        </p:blipFill>
-        <p:spPr>
-          <a:xfrm>
-            <a:off x="11768328" y="201168"/>
-            <a:ext cx="219456" cy="6455664"/>
-          </a:xfrm>
-          <a:prstGeom prst="rect">
-            <a:avLst/>
-          </a:prstGeom>
-        </p:spPr>
-      </p:pic>
-      <p:sp>
-        <p:nvSpPr>
-          <p:cNvPr id="3" name="TextBox 2"/>
-          <p:cNvSpPr txBox="1"/>
-          <p:nvPr/>
-        </p:nvSpPr>
-        <p:spPr>
-          <a:xfrm>
-            <a:off x="566928" y="960120"/>
-            <a:ext cx="10972800" cy="731520"/>
-          </a:xfrm>
-          <a:prstGeom prst="rect">
-            <a:avLst/>
-          </a:prstGeom>
-          <a:noFill/>
-        </p:spPr>
-        <p:txBody>
-          <a:bodyPr wrap="square" lIns="0" rIns="0" tIns="0" bIns="0">
-            <a:spAutoFit/>
-          </a:bodyPr>
-          <a:lstStyle/>
-          <a:p>
-            <a:pPr>
-              <a:spcAft>
-                <a:spcPts val="0"/>
-              </a:spcAft>
-              <a:defRPr sz="3800" b="0">
-                <a:solidFill>
-                  <a:srgbClr val="181D16"/>
-                </a:solidFill>
-                <a:latin typeface="Arial"/>
-              </a:defRPr>
-            </a:pPr>
-            <a:r>
               <a:t>Different training data changes the model</a:t>
             </a:r>
           </a:p>
@@ -6425,7 +3968,7 @@
               </a:defRPr>
             </a:pPr>
             <a:r>
-              <a:t>02/07</a:t>
+              <a:t>01/06</a:t>
             </a:r>
           </a:p>
         </p:txBody>
@@ -11512,7 +9055,7 @@
 </p:sld>
 </file>
 
-<file path=ppt/slides/slide3.xml><?xml version="1.0" encoding="utf-8"?>
+<file path=ppt/slides/slide2.xml><?xml version="1.0" encoding="utf-8"?>
 <p:sld xmlns:a="http://schemas.openxmlformats.org/drawingml/2006/main" xmlns:p="http://schemas.openxmlformats.org/presentationml/2006/main" xmlns:r="http://schemas.openxmlformats.org/officeDocument/2006/relationships">
   <p:cSld>
     <p:bg>
@@ -11627,7 +9170,7 @@
               </a:defRPr>
             </a:pPr>
             <a:r>
-              <a:t>03/07</a:t>
+              <a:t>02/06</a:t>
             </a:r>
           </a:p>
         </p:txBody>
@@ -34695,7 +32238,7 @@
 </p:sld>
 </file>
 
-<file path=ppt/slides/slide4.xml><?xml version="1.0" encoding="utf-8"?>
+<file path=ppt/slides/slide3.xml><?xml version="1.0" encoding="utf-8"?>
 <p:sld xmlns:a="http://schemas.openxmlformats.org/drawingml/2006/main" xmlns:p="http://schemas.openxmlformats.org/presentationml/2006/main" xmlns:r="http://schemas.openxmlformats.org/officeDocument/2006/relationships">
   <p:cSld>
     <p:bg>
@@ -34810,7 +32353,7 @@
               </a:defRPr>
             </a:pPr>
             <a:r>
-              <a:t>04/07</a:t>
+              <a:t>03/06</a:t>
             </a:r>
           </a:p>
         </p:txBody>
@@ -47924,7 +45467,7 @@
 </p:sld>
 </file>
 
-<file path=ppt/slides/slide5.xml><?xml version="1.0" encoding="utf-8"?>
+<file path=ppt/slides/slide4.xml><?xml version="1.0" encoding="utf-8"?>
 <p:sld xmlns:a="http://schemas.openxmlformats.org/drawingml/2006/main" xmlns:p="http://schemas.openxmlformats.org/presentationml/2006/main" xmlns:r="http://schemas.openxmlformats.org/officeDocument/2006/relationships">
   <p:cSld>
     <p:bg>
@@ -48039,7 +45582,7 @@
               </a:defRPr>
             </a:pPr>
             <a:r>
-              <a:t>05/07</a:t>
+              <a:t>04/06</a:t>
             </a:r>
           </a:p>
         </p:txBody>
@@ -60986,7 +58529,7 @@
 </p:sld>
 </file>
 
-<file path=ppt/slides/slide6.xml><?xml version="1.0" encoding="utf-8"?>
+<file path=ppt/slides/slide5.xml><?xml version="1.0" encoding="utf-8"?>
 <p:sld xmlns:a="http://schemas.openxmlformats.org/drawingml/2006/main" xmlns:p="http://schemas.openxmlformats.org/presentationml/2006/main" xmlns:r="http://schemas.openxmlformats.org/officeDocument/2006/relationships">
   <p:cSld>
     <p:bg>
@@ -61101,7 +58644,7 @@
               </a:defRPr>
             </a:pPr>
             <a:r>
-              <a:t>06/07</a:t>
+              <a:t>05/06</a:t>
             </a:r>
           </a:p>
         </p:txBody>
@@ -61660,7 +59203,7 @@
 </p:sld>
 </file>
 
-<file path=ppt/slides/slide7.xml><?xml version="1.0" encoding="utf-8"?>
+<file path=ppt/slides/slide6.xml><?xml version="1.0" encoding="utf-8"?>
 <p:sld xmlns:a="http://schemas.openxmlformats.org/drawingml/2006/main" xmlns:p="http://schemas.openxmlformats.org/presentationml/2006/main" xmlns:r="http://schemas.openxmlformats.org/officeDocument/2006/relationships">
   <p:cSld>
     <p:bg>
@@ -61775,7 +59318,7 @@
               </a:defRPr>
             </a:pPr>
             <a:r>
-              <a:t>07/07</a:t>
+              <a:t>06/06</a:t>
             </a:r>
           </a:p>
         </p:txBody>

</xml_diff>